<commit_message>
Polish source text and regenerate figures; add limitations slide
Removed em dashes from all source files, replacing prose uses with
colons/commas and data uses (table markers) with plain hyphens.
The fix to visualize.py line 80 changes the rendered text in
bug_detection_matrix.png, so all four result figures are regenerated.

Added slide 12 (Limitations) covering mock SUTs, analytically
constructed models, three bug patterns only, and no scalability
data; total slide count updated to 13.

README headings changed to sentence case. Repo made public with
a description added.
</commit_message>
<xml_diff>
--- a/slides/presentation.pptx
+++ b/slides/presentation.pptx
@@ -17,9 +17,10 @@
     <p:sldId id="265" r:id="rId11"/>
     <p:sldId id="266" r:id="rId12"/>
     <p:sldId id="267" r:id="rId13"/>
+    <p:sldId id="268" r:id="rId14"/>
   </p:sldIdLst>
   <p:notesMasterIdLst>
-    <p:notesMasterId r:id="rId14"/>
+    <p:notesMasterId r:id="rId15"/>
   </p:notesMasterIdLst>
   <p:sldSz cx="9144000" cy="5143500"/>
   <p:notesSz cx="5143500" cy="9144000"/>
@@ -801,6 +802,94 @@
             <a:fld id="{F7021451-1387-4CA6-816F-3879F97B5CBC}" type="slidenum">
               <a:rPr lang="en-US"/>
               <a:t>12</a:t>
+            </a:fld>
+            <a:endParaRPr lang="en-US"/>
+          </a:p>
+        </p:txBody>
+      </p:sp>
+    </p:spTree>
+    <p:extLst>
+      <p:ext uri="{BB962C8B-B14F-4D97-AF65-F5344CB8AC3E}">
+        <p14:creationId xmlns:p14="http://schemas.microsoft.com/office/powerpoint/2010/main" val="1024086991"/>
+      </p:ext>
+    </p:extLst>
+  </p:cSld>
+  <p:clrMapOvr>
+    <a:masterClrMapping/>
+  </p:clrMapOvr>
+</p:notes>
+</file>
+
+<file path=ppt/notesSlides/notesSlide13.xml><?xml version="1.0" encoding="utf-8"?>
+<p:notes xmlns:a="http://schemas.openxmlformats.org/drawingml/2006/main" xmlns:r="http://schemas.openxmlformats.org/officeDocument/2006/relationships" xmlns:p="http://schemas.openxmlformats.org/presentationml/2006/main">
+  <p:cSld>
+    <p:spTree>
+      <p:nvGrpSpPr>
+        <p:cNvPr id="1" name=""/>
+        <p:cNvGrpSpPr/>
+        <p:nvPr/>
+      </p:nvGrpSpPr>
+      <p:grpSpPr>
+        <a:xfrm>
+          <a:off x="0" y="0"/>
+          <a:ext cx="0" cy="0"/>
+          <a:chOff x="0" y="0"/>
+          <a:chExt cx="0" cy="0"/>
+        </a:xfrm>
+      </p:grpSpPr>
+      <p:sp>
+        <p:nvSpPr>
+          <p:cNvPr id="2" name="Slide Image Placeholder 1"/>
+          <p:cNvSpPr>
+            <a:spLocks noGrp="1" noRot="1" noChangeAspect="1"/>
+          </p:cNvSpPr>
+          <p:nvPr>
+            <p:ph type="sldImg"/>
+          </p:nvPr>
+        </p:nvSpPr>
+        <p:spPr/>
+      </p:sp>
+      <p:sp>
+        <p:nvSpPr>
+          <p:cNvPr id="3" name="Notes Placeholder 2"/>
+          <p:cNvSpPr>
+            <a:spLocks noGrp="1"/>
+          </p:cNvSpPr>
+          <p:nvPr>
+            <p:ph type="body" idx="1"/>
+          </p:nvPr>
+        </p:nvSpPr>
+        <p:spPr/>
+        <p:txBody>
+          <a:bodyPr/>
+          <a:lstStyle/>
+          <a:p>
+            <a:r>
+              <a:rPr lang="en-US" dirty="0"/>
+              <a:t/>
+            </a:r>
+            <a:endParaRPr lang="en-US" dirty="0"/>
+          </a:p>
+        </p:txBody>
+      </p:sp>
+      <p:sp>
+        <p:nvSpPr>
+          <p:cNvPr id="4" name="Slide Number Placeholder 3"/>
+          <p:cNvSpPr>
+            <a:spLocks noGrp="1"/>
+          </p:cNvSpPr>
+          <p:nvPr>
+            <p:ph type="sldNum" sz="quarter" idx="10"/>
+          </p:nvPr>
+        </p:nvSpPr>
+        <p:spPr/>
+        <p:txBody>
+          <a:bodyPr/>
+          <a:lstStyle/>
+          <a:p>
+            <a:fld id="{F7021451-1387-4CA6-816F-3879F97B5CBC}" type="slidenum">
+              <a:rPr lang="en-US"/>
+              <a:t>13</a:t>
             </a:fld>
             <a:endParaRPr lang="en-US"/>
           </a:p>
@@ -2479,7 +2568,7 @@
                   <a:srgbClr val="888888"/>
                 </a:solidFill>
               </a:rPr>
-              <a:t>COE 576 Networks &amp; Web Security  |  Bless Elikem Krapah  |  KNUST  |  10/12</a:t>
+              <a:t>COE 576 Networks &amp; Web Security  |  Bless Elikem Krapah  |  KNUST  |  10/13</a:t>
             </a:r>
             <a:endParaRPr lang="en-US" sz="700" dirty="0"/>
           </a:p>
@@ -2817,7 +2906,7 @@
                   <a:srgbClr val="888888"/>
                 </a:solidFill>
               </a:rPr>
-              <a:t>COE 576 Networks &amp; Web Security  |  Bless Elikem Krapah  |  KNUST  |  11/12</a:t>
+              <a:t>COE 576 Networks &amp; Web Security  |  Bless Elikem Krapah  |  KNUST  |  11/13</a:t>
             </a:r>
             <a:endParaRPr lang="en-US" sz="700" dirty="0"/>
           </a:p>
@@ -2863,6 +2952,597 @@
             <a:avLst/>
           </a:prstGeom>
           <a:solidFill>
+            <a:srgbClr val="F7F7F7"/>
+          </a:solidFill>
+          <a:ln w="12700">
+            <a:solidFill>
+              <a:srgbClr val="F7F7F7"/>
+            </a:solidFill>
+            <a:prstDash val="solid"/>
+          </a:ln>
+        </p:spPr>
+      </p:sp>
+      <p:sp>
+        <p:nvSpPr>
+          <p:cNvPr id="3" name="Shape 1"/>
+          <p:cNvSpPr/>
+          <p:nvPr/>
+        </p:nvSpPr>
+        <p:spPr>
+          <a:xfrm>
+            <a:off x="0" y="0"/>
+            <a:ext cx="9144000" cy="658368"/>
+          </a:xfrm>
+          <a:prstGeom prst="rect">
+            <a:avLst/>
+          </a:prstGeom>
+          <a:solidFill>
+            <a:srgbClr val="111111"/>
+          </a:solidFill>
+          <a:ln w="12700">
+            <a:solidFill>
+              <a:srgbClr val="111111"/>
+            </a:solidFill>
+            <a:prstDash val="solid"/>
+          </a:ln>
+        </p:spPr>
+      </p:sp>
+      <p:sp>
+        <p:nvSpPr>
+          <p:cNvPr id="4" name="Text 2"/>
+          <p:cNvSpPr/>
+          <p:nvPr/>
+        </p:nvSpPr>
+        <p:spPr>
+          <a:xfrm>
+            <a:off x="274320" y="0"/>
+            <a:ext cx="8595360" cy="658368"/>
+          </a:xfrm>
+          <a:prstGeom prst="rect">
+            <a:avLst/>
+          </a:prstGeom>
+          <a:noFill/>
+          <a:ln/>
+        </p:spPr>
+        <p:txBody>
+          <a:bodyPr wrap="square" rtlCol="0" anchor="ctr"/>
+          <a:lstStyle/>
+          <a:p>
+            <a:pPr indent="0" marL="0">
+              <a:buNone/>
+            </a:pPr>
+            <a:r>
+              <a:rPr lang="en-US" sz="2100" b="1" dirty="0">
+                <a:solidFill>
+                  <a:srgbClr val="FFFFFF"/>
+                </a:solidFill>
+              </a:rPr>
+              <a:t>Limitations of This Replication</a:t>
+            </a:r>
+            <a:endParaRPr lang="en-US" sz="2100" dirty="0"/>
+          </a:p>
+        </p:txBody>
+      </p:sp>
+      <p:sp>
+        <p:nvSpPr>
+          <p:cNvPr id="5" name="Shape 3"/>
+          <p:cNvSpPr/>
+          <p:nvPr/>
+        </p:nvSpPr>
+        <p:spPr>
+          <a:xfrm>
+            <a:off x="320040" y="804672"/>
+            <a:ext cx="8503920" cy="877824"/>
+          </a:xfrm>
+          <a:prstGeom prst="rect">
+            <a:avLst/>
+          </a:prstGeom>
+          <a:solidFill>
+            <a:srgbClr val="EBEBEB"/>
+          </a:solidFill>
+          <a:ln w="12700">
+            <a:solidFill>
+              <a:srgbClr val="CCCCCC"/>
+            </a:solidFill>
+            <a:prstDash val="solid"/>
+          </a:ln>
+        </p:spPr>
+      </p:sp>
+      <p:sp>
+        <p:nvSpPr>
+          <p:cNvPr id="6" name="Text 4"/>
+          <p:cNvSpPr/>
+          <p:nvPr/>
+        </p:nvSpPr>
+        <p:spPr>
+          <a:xfrm>
+            <a:off x="502920" y="859536"/>
+            <a:ext cx="8229600" cy="237744"/>
+          </a:xfrm>
+          <a:prstGeom prst="rect">
+            <a:avLst/>
+          </a:prstGeom>
+          <a:noFill/>
+          <a:ln/>
+        </p:spPr>
+        <p:txBody>
+          <a:bodyPr wrap="square" rtlCol="0" anchor="ctr"/>
+          <a:lstStyle/>
+          <a:p>
+            <a:pPr indent="0" marL="0">
+              <a:buNone/>
+            </a:pPr>
+            <a:r>
+              <a:rPr lang="en-US" sz="1100" b="1" dirty="0">
+                <a:solidFill>
+                  <a:srgbClr val="111111"/>
+                </a:solidFill>
+              </a:rPr>
+              <a:t>Mock SUTs, not real servers</a:t>
+            </a:r>
+            <a:endParaRPr lang="en-US" sz="1100" dirty="0"/>
+          </a:p>
+        </p:txBody>
+      </p:sp>
+      <p:sp>
+        <p:nvSpPr>
+          <p:cNvPr id="7" name="Text 5"/>
+          <p:cNvSpPr/>
+          <p:nvPr/>
+        </p:nvSpPr>
+        <p:spPr>
+          <a:xfrm>
+            <a:off x="502920" y="1133856"/>
+            <a:ext cx="8229600" cy="475488"/>
+          </a:xfrm>
+          <a:prstGeom prst="rect">
+            <a:avLst/>
+          </a:prstGeom>
+          <a:noFill/>
+          <a:ln/>
+        </p:spPr>
+        <p:txBody>
+          <a:bodyPr wrap="square" rtlCol="0" anchor="ctr"/>
+          <a:lstStyle/>
+          <a:p>
+            <a:pPr indent="0" marL="0">
+              <a:buNone/>
+            </a:pPr>
+            <a:r>
+              <a:rPr lang="en-US" sz="1000" dirty="0">
+                <a:solidFill>
+                  <a:srgbClr val="1A1A1A"/>
+                </a:solidFill>
+              </a:rPr>
+              <a:t>Real paper tested OpenSSL, GnuTLS, WolfSSL, etc. This replication uses hand-written</a:t>
+            </a:r>
+            <a:endParaRPr lang="en-US" sz="1000" dirty="0"/>
+          </a:p>
+          <a:p>
+            <a:pPr indent="0" marL="0">
+              <a:buNone/>
+            </a:pPr>
+            <a:r>
+              <a:rPr lang="en-US" sz="1000" dirty="0">
+                <a:solidFill>
+                  <a:srgbClr val="1A1A1A"/>
+                </a:solidFill>
+              </a:rPr>
+              <a:t>Python state machines that precisely embed the known bugs. Results are deterministic, not probabilistic.</a:t>
+            </a:r>
+            <a:endParaRPr lang="en-US" sz="1000" dirty="0"/>
+          </a:p>
+        </p:txBody>
+      </p:sp>
+      <p:sp>
+        <p:nvSpPr>
+          <p:cNvPr id="8" name="Shape 6"/>
+          <p:cNvSpPr/>
+          <p:nvPr/>
+        </p:nvSpPr>
+        <p:spPr>
+          <a:xfrm>
+            <a:off x="320040" y="1792224"/>
+            <a:ext cx="8503920" cy="877824"/>
+          </a:xfrm>
+          <a:prstGeom prst="rect">
+            <a:avLst/>
+          </a:prstGeom>
+          <a:solidFill>
+            <a:srgbClr val="EBEBEB"/>
+          </a:solidFill>
+          <a:ln w="12700">
+            <a:solidFill>
+              <a:srgbClr val="CCCCCC"/>
+            </a:solidFill>
+            <a:prstDash val="solid"/>
+          </a:ln>
+        </p:spPr>
+      </p:sp>
+      <p:sp>
+        <p:nvSpPr>
+          <p:cNvPr id="9" name="Text 7"/>
+          <p:cNvSpPr/>
+          <p:nvPr/>
+        </p:nvSpPr>
+        <p:spPr>
+          <a:xfrm>
+            <a:off x="502920" y="1847088"/>
+            <a:ext cx="8229600" cy="237744"/>
+          </a:xfrm>
+          <a:prstGeom prst="rect">
+            <a:avLst/>
+          </a:prstGeom>
+          <a:noFill/>
+          <a:ln/>
+        </p:spPr>
+        <p:txBody>
+          <a:bodyPr wrap="square" rtlCol="0" anchor="ctr"/>
+          <a:lstStyle/>
+          <a:p>
+            <a:pPr indent="0" marL="0">
+              <a:buNone/>
+            </a:pPr>
+            <a:r>
+              <a:rPr lang="en-US" sz="1100" b="1" dirty="0">
+                <a:solidFill>
+                  <a:srgbClr val="111111"/>
+                </a:solidFill>
+              </a:rPr>
+              <a:t>Models analytically constructed</a:t>
+            </a:r>
+            <a:endParaRPr lang="en-US" sz="1100" dirty="0"/>
+          </a:p>
+        </p:txBody>
+      </p:sp>
+      <p:sp>
+        <p:nvSpPr>
+          <p:cNvPr id="10" name="Text 8"/>
+          <p:cNvSpPr/>
+          <p:nvPr/>
+        </p:nvSpPr>
+        <p:spPr>
+          <a:xfrm>
+            <a:off x="502920" y="2121408"/>
+            <a:ext cx="8229600" cy="475488"/>
+          </a:xfrm>
+          <a:prstGeom prst="rect">
+            <a:avLst/>
+          </a:prstGeom>
+          <a:noFill/>
+          <a:ln/>
+        </p:spPr>
+        <p:txBody>
+          <a:bodyPr wrap="square" rtlCol="0" anchor="ctr"/>
+          <a:lstStyle/>
+          <a:p>
+            <a:pPr indent="0" marL="0">
+              <a:buNone/>
+            </a:pPr>
+            <a:r>
+              <a:rPr lang="en-US" sz="1000" dirty="0">
+                <a:solidFill>
+                  <a:srgbClr val="1A1A1A"/>
+                </a:solidFill>
+              </a:rPr>
+              <a:t>The paper learns Mealy machines via active automata learning (L*/TTT). Here, models are</a:t>
+            </a:r>
+            <a:endParaRPr lang="en-US" sz="1000" dirty="0"/>
+          </a:p>
+          <a:p>
+            <a:pPr indent="0" marL="0">
+              <a:buNone/>
+            </a:pPr>
+            <a:r>
+              <a:rPr lang="en-US" sz="1000" dirty="0">
+                <a:solidFill>
+                  <a:srgbClr val="1A1A1A"/>
+                </a:solidFill>
+              </a:rPr>
+              <a:t>built directly from SUT code. The intersection and Algorithm 1 are faithful; the learning step is not.</a:t>
+            </a:r>
+            <a:endParaRPr lang="en-US" sz="1000" dirty="0"/>
+          </a:p>
+        </p:txBody>
+      </p:sp>
+      <p:sp>
+        <p:nvSpPr>
+          <p:cNvPr id="11" name="Shape 9"/>
+          <p:cNvSpPr/>
+          <p:nvPr/>
+        </p:nvSpPr>
+        <p:spPr>
+          <a:xfrm>
+            <a:off x="320040" y="2779776"/>
+            <a:ext cx="8503920" cy="877824"/>
+          </a:xfrm>
+          <a:prstGeom prst="rect">
+            <a:avLst/>
+          </a:prstGeom>
+          <a:solidFill>
+            <a:srgbClr val="EBEBEB"/>
+          </a:solidFill>
+          <a:ln w="12700">
+            <a:solidFill>
+              <a:srgbClr val="CCCCCC"/>
+            </a:solidFill>
+            <a:prstDash val="solid"/>
+          </a:ln>
+        </p:spPr>
+      </p:sp>
+      <p:sp>
+        <p:nvSpPr>
+          <p:cNvPr id="12" name="Text 10"/>
+          <p:cNvSpPr/>
+          <p:nvPr/>
+        </p:nvSpPr>
+        <p:spPr>
+          <a:xfrm>
+            <a:off x="502920" y="2834640"/>
+            <a:ext cx="8229600" cy="237744"/>
+          </a:xfrm>
+          <a:prstGeom prst="rect">
+            <a:avLst/>
+          </a:prstGeom>
+          <a:noFill/>
+          <a:ln/>
+        </p:spPr>
+        <p:txBody>
+          <a:bodyPr wrap="square" rtlCol="0" anchor="ctr"/>
+          <a:lstStyle/>
+          <a:p>
+            <a:pPr indent="0" marL="0">
+              <a:buNone/>
+            </a:pPr>
+            <a:r>
+              <a:rPr lang="en-US" sz="1100" b="1" dirty="0">
+                <a:solidFill>
+                  <a:srgbClr val="111111"/>
+                </a:solidFill>
+              </a:rPr>
+              <a:t>Three bug patterns only</a:t>
+            </a:r>
+            <a:endParaRPr lang="en-US" sz="1100" dirty="0"/>
+          </a:p>
+        </p:txBody>
+      </p:sp>
+      <p:sp>
+        <p:nvSpPr>
+          <p:cNvPr id="13" name="Text 11"/>
+          <p:cNvSpPr/>
+          <p:nvPr/>
+        </p:nvSpPr>
+        <p:spPr>
+          <a:xfrm>
+            <a:off x="502920" y="3108960"/>
+            <a:ext cx="8229600" cy="475488"/>
+          </a:xfrm>
+          <a:prstGeom prst="rect">
+            <a:avLst/>
+          </a:prstGeom>
+          <a:noFill/>
+          <a:ln/>
+        </p:spPr>
+        <p:txBody>
+          <a:bodyPr wrap="square" rtlCol="0" anchor="ctr"/>
+          <a:lstStyle/>
+          <a:p>
+            <a:pPr indent="0" marL="0">
+              <a:buNone/>
+            </a:pPr>
+            <a:r>
+              <a:rPr lang="en-US" sz="1000" dirty="0">
+                <a:solidFill>
+                  <a:srgbClr val="1A1A1A"/>
+                </a:solidFill>
+              </a:rPr>
+              <a:t>The paper covers more bug classes across DTLS and SSH. Only BP1, BP2, BP3 are implemented</a:t>
+            </a:r>
+            <a:endParaRPr lang="en-US" sz="1000" dirty="0"/>
+          </a:p>
+          <a:p>
+            <a:pPr indent="0" marL="0">
+              <a:buNone/>
+            </a:pPr>
+            <a:r>
+              <a:rPr lang="en-US" sz="1000" dirty="0">
+                <a:solidFill>
+                  <a:srgbClr val="1A1A1A"/>
+                </a:solidFill>
+              </a:rPr>
+              <a:t>here; extending to new protocols requires new hand-crafted bug-pattern DFAs.</a:t>
+            </a:r>
+            <a:endParaRPr lang="en-US" sz="1000" dirty="0"/>
+          </a:p>
+        </p:txBody>
+      </p:sp>
+      <p:sp>
+        <p:nvSpPr>
+          <p:cNvPr id="14" name="Shape 12"/>
+          <p:cNvSpPr/>
+          <p:nvPr/>
+        </p:nvSpPr>
+        <p:spPr>
+          <a:xfrm>
+            <a:off x="320040" y="3767328"/>
+            <a:ext cx="8503920" cy="877824"/>
+          </a:xfrm>
+          <a:prstGeom prst="rect">
+            <a:avLst/>
+          </a:prstGeom>
+          <a:solidFill>
+            <a:srgbClr val="EBEBEB"/>
+          </a:solidFill>
+          <a:ln w="12700">
+            <a:solidFill>
+              <a:srgbClr val="CCCCCC"/>
+            </a:solidFill>
+            <a:prstDash val="solid"/>
+          </a:ln>
+        </p:spPr>
+      </p:sp>
+      <p:sp>
+        <p:nvSpPr>
+          <p:cNvPr id="15" name="Text 13"/>
+          <p:cNvSpPr/>
+          <p:nvPr/>
+        </p:nvSpPr>
+        <p:spPr>
+          <a:xfrm>
+            <a:off x="502920" y="3822192"/>
+            <a:ext cx="8229600" cy="237744"/>
+          </a:xfrm>
+          <a:prstGeom prst="rect">
+            <a:avLst/>
+          </a:prstGeom>
+          <a:noFill/>
+          <a:ln/>
+        </p:spPr>
+        <p:txBody>
+          <a:bodyPr wrap="square" rtlCol="0" anchor="ctr"/>
+          <a:lstStyle/>
+          <a:p>
+            <a:pPr indent="0" marL="0">
+              <a:buNone/>
+            </a:pPr>
+            <a:r>
+              <a:rPr lang="en-US" sz="1100" b="1" dirty="0">
+                <a:solidFill>
+                  <a:srgbClr val="111111"/>
+                </a:solidFill>
+              </a:rPr>
+              <a:t>No scalability or robustness data</a:t>
+            </a:r>
+            <a:endParaRPr lang="en-US" sz="1100" dirty="0"/>
+          </a:p>
+        </p:txBody>
+      </p:sp>
+      <p:sp>
+        <p:nvSpPr>
+          <p:cNvPr id="16" name="Text 14"/>
+          <p:cNvSpPr/>
+          <p:nvPr/>
+        </p:nvSpPr>
+        <p:spPr>
+          <a:xfrm>
+            <a:off x="502920" y="4096512"/>
+            <a:ext cx="8229600" cy="475488"/>
+          </a:xfrm>
+          <a:prstGeom prst="rect">
+            <a:avLst/>
+          </a:prstGeom>
+          <a:noFill/>
+          <a:ln/>
+        </p:spPr>
+        <p:txBody>
+          <a:bodyPr wrap="square" rtlCol="0" anchor="ctr"/>
+          <a:lstStyle/>
+          <a:p>
+            <a:pPr indent="0" marL="0">
+              <a:buNone/>
+            </a:pPr>
+            <a:r>
+              <a:rPr lang="en-US" sz="1000" dirty="0">
+                <a:solidFill>
+                  <a:srgbClr val="1A1A1A"/>
+                </a:solidFill>
+              </a:rPr>
+              <a:t>The paper reports learning times (hours) and model sizes for 12 real implementations.</a:t>
+            </a:r>
+            <a:endParaRPr lang="en-US" sz="1000" dirty="0"/>
+          </a:p>
+          <a:p>
+            <a:pPr indent="0" marL="0">
+              <a:buNone/>
+            </a:pPr>
+            <a:r>
+              <a:rPr lang="en-US" sz="1000" dirty="0">
+                <a:solidFill>
+                  <a:srgbClr val="1A1A1A"/>
+                </a:solidFill>
+              </a:rPr>
+              <a:t>This replication has no learning overhead, so timing comparisons are not meaningful.</a:t>
+            </a:r>
+            <a:endParaRPr lang="en-US" sz="1000" dirty="0"/>
+          </a:p>
+        </p:txBody>
+      </p:sp>
+      <p:sp>
+        <p:nvSpPr>
+          <p:cNvPr id="17" name="Text 15"/>
+          <p:cNvSpPr/>
+          <p:nvPr/>
+        </p:nvSpPr>
+        <p:spPr>
+          <a:xfrm>
+            <a:off x="0" y="4942332"/>
+            <a:ext cx="9144000" cy="201168"/>
+          </a:xfrm>
+          <a:prstGeom prst="rect">
+            <a:avLst/>
+          </a:prstGeom>
+          <a:noFill/>
+          <a:ln/>
+        </p:spPr>
+        <p:txBody>
+          <a:bodyPr wrap="square" rtlCol="0" anchor="ctr"/>
+          <a:lstStyle/>
+          <a:p>
+            <a:pPr algn="ctr" indent="0" marL="0">
+              <a:buNone/>
+            </a:pPr>
+            <a:r>
+              <a:rPr lang="en-US" sz="700" dirty="0">
+                <a:solidFill>
+                  <a:srgbClr val="888888"/>
+                </a:solidFill>
+              </a:rPr>
+              <a:t>COE 576 Networks &amp; Web Security  |  Bless Elikem Krapah  |  KNUST  |  12/13</a:t>
+            </a:r>
+            <a:endParaRPr lang="en-US" sz="700" dirty="0"/>
+          </a:p>
+        </p:txBody>
+      </p:sp>
+    </p:spTree>
+  </p:cSld>
+  <p:clrMapOvr>
+    <a:masterClrMapping/>
+  </p:clrMapOvr>
+</p:sld>
+</file>
+
+<file path=ppt/slides/slide13.xml><?xml version="1.0" encoding="utf-8"?>
+<p:sld xmlns:a="http://schemas.openxmlformats.org/drawingml/2006/main" xmlns:r="http://schemas.openxmlformats.org/officeDocument/2006/relationships" xmlns:p="http://schemas.openxmlformats.org/presentationml/2006/main">
+  <p:cSld name="Slide 13">
+    <p:spTree>
+      <p:nvGrpSpPr>
+        <p:cNvPr id="1" name=""/>
+        <p:cNvGrpSpPr/>
+        <p:nvPr/>
+      </p:nvGrpSpPr>
+      <p:grpSpPr>
+        <a:xfrm>
+          <a:off x="0" y="0"/>
+          <a:ext cx="0" cy="0"/>
+          <a:chOff x="0" y="0"/>
+          <a:chExt cx="0" cy="0"/>
+        </a:xfrm>
+      </p:grpSpPr>
+      <p:sp>
+        <p:nvSpPr>
+          <p:cNvPr id="2" name="Shape 0"/>
+          <p:cNvSpPr/>
+          <p:nvPr/>
+        </p:nvSpPr>
+        <p:spPr>
+          <a:xfrm>
+            <a:off x="0" y="0"/>
+            <a:ext cx="9144000" cy="5143500"/>
+          </a:xfrm>
+          <a:prstGeom prst="rect">
+            <a:avLst/>
+          </a:prstGeom>
+          <a:solidFill>
             <a:srgbClr val="1A1A1A"/>
           </a:solidFill>
           <a:ln w="12700">
@@ -3311,6 +3991,42 @@
               <a:t>COE 576 Networks and Web Security  |  KNUST MPhil  |  September 2026  |  Bless Elikem Krapah</a:t>
             </a:r>
             <a:endParaRPr lang="en-US" sz="750" dirty="0"/>
+          </a:p>
+        </p:txBody>
+      </p:sp>
+      <p:sp>
+        <p:nvSpPr>
+          <p:cNvPr id="14" name="Text 12"/>
+          <p:cNvSpPr/>
+          <p:nvPr/>
+        </p:nvSpPr>
+        <p:spPr>
+          <a:xfrm>
+            <a:off x="0" y="4942332"/>
+            <a:ext cx="9144000" cy="201168"/>
+          </a:xfrm>
+          <a:prstGeom prst="rect">
+            <a:avLst/>
+          </a:prstGeom>
+          <a:noFill/>
+          <a:ln/>
+        </p:spPr>
+        <p:txBody>
+          <a:bodyPr wrap="square" rtlCol="0" anchor="ctr"/>
+          <a:lstStyle/>
+          <a:p>
+            <a:pPr algn="ctr" indent="0" marL="0">
+              <a:buNone/>
+            </a:pPr>
+            <a:r>
+              <a:rPr lang="en-US" sz="700" dirty="0">
+                <a:solidFill>
+                  <a:srgbClr val="888888"/>
+                </a:solidFill>
+              </a:rPr>
+              <a:t>COE 576 Networks &amp; Web Security  |  Bless Elikem Krapah  |  KNUST  |  13/13</a:t>
+            </a:r>
+            <a:endParaRPr lang="en-US" sz="700" dirty="0"/>
           </a:p>
         </p:txBody>
       </p:sp>
@@ -4284,7 +5000,7 @@
                   <a:srgbClr val="888888"/>
                 </a:solidFill>
               </a:rPr>
-              <a:t>COE 576 Networks &amp; Web Security  |  Bless Elikem Krapah  |  KNUST  |  2/12</a:t>
+              <a:t>COE 576 Networks &amp; Web Security  |  Bless Elikem Krapah  |  KNUST  |  2/13</a:t>
             </a:r>
             <a:endParaRPr lang="en-US" sz="700" dirty="0"/>
           </a:p>
@@ -5126,7 +5842,7 @@
                   <a:srgbClr val="888888"/>
                 </a:solidFill>
               </a:rPr>
-              <a:t>COE 576 Networks &amp; Web Security  |  Bless Elikem Krapah  |  KNUST  |  3/12</a:t>
+              <a:t>COE 576 Networks &amp; Web Security  |  Bless Elikem Krapah  |  KNUST  |  3/13</a:t>
             </a:r>
             <a:endParaRPr lang="en-US" sz="700" dirty="0"/>
           </a:p>
@@ -5741,7 +6457,7 @@
                   <a:srgbClr val="888888"/>
                 </a:solidFill>
               </a:rPr>
-              <a:t>COE 576 Networks &amp; Web Security  |  Bless Elikem Krapah  |  KNUST  |  4/12</a:t>
+              <a:t>COE 576 Networks &amp; Web Security  |  Bless Elikem Krapah  |  KNUST  |  4/13</a:t>
             </a:r>
             <a:endParaRPr lang="en-US" sz="700" dirty="0"/>
           </a:p>
@@ -6592,7 +7308,7 @@
                   <a:srgbClr val="888888"/>
                 </a:solidFill>
               </a:rPr>
-              <a:t>COE 576 Networks &amp; Web Security  |  Bless Elikem Krapah  |  KNUST  |  5/12</a:t>
+              <a:t>COE 576 Networks &amp; Web Security  |  Bless Elikem Krapah  |  KNUST  |  5/13</a:t>
             </a:r>
             <a:endParaRPr lang="en-US" sz="700" dirty="0"/>
           </a:p>
@@ -7196,7 +7912,7 @@
                   <a:srgbClr val="888888"/>
                 </a:solidFill>
               </a:rPr>
-              <a:t>COE 576 Networks &amp; Web Security  |  Bless Elikem Krapah  |  KNUST  |  6/12</a:t>
+              <a:t>COE 576 Networks &amp; Web Security  |  Bless Elikem Krapah  |  KNUST  |  6/13</a:t>
             </a:r>
             <a:endParaRPr lang="en-US" sz="700" dirty="0"/>
           </a:p>
@@ -7792,7 +8508,7 @@
                   <a:srgbClr val="888888"/>
                 </a:solidFill>
               </a:rPr>
-              <a:t>COE 576 Networks &amp; Web Security  |  Bless Elikem Krapah  |  KNUST  |  7/12</a:t>
+              <a:t>COE 576 Networks &amp; Web Security  |  Bless Elikem Krapah  |  KNUST  |  7/13</a:t>
             </a:r>
             <a:endParaRPr lang="en-US" sz="700" dirty="0"/>
           </a:p>
@@ -8378,7 +9094,7 @@
                   <a:srgbClr val="888888"/>
                 </a:solidFill>
               </a:rPr>
-              <a:t>COE 576 Networks &amp; Web Security  |  Bless Elikem Krapah  |  KNUST  |  8/12</a:t>
+              <a:t>COE 576 Networks &amp; Web Security  |  Bless Elikem Krapah  |  KNUST  |  8/13</a:t>
             </a:r>
             <a:endParaRPr lang="en-US" sz="700" dirty="0"/>
           </a:p>
@@ -9644,7 +10360,7 @@
                   <a:srgbClr val="888888"/>
                 </a:solidFill>
               </a:rPr>
-              <a:t>COE 576 Networks &amp; Web Security  |  Bless Elikem Krapah  |  KNUST  |  9/12</a:t>
+              <a:t>COE 576 Networks &amp; Web Security  |  Bless Elikem Krapah  |  KNUST  |  9/13</a:t>
             </a:r>
             <a:endParaRPr lang="en-US" sz="700" dirty="0"/>
           </a:p>

</xml_diff>

<commit_message>
slides: fix subscripts, swap slide order, add DFA diagrams, redesign Mealy→DFA
- Fix wrong Unicode: A\u1d40 (ᵀ) and A\u1d65 (ᵥ) replaced with A_M and A_bug
  throughout all slide headers (Key Formalisms, Mealy→DFA, DFA Intersection)
- Swap slide order: Three-Step Pipeline is now slide 4, Key Formalisms slide 5
  (matches user's manual reordering)
- Key Formalisms (slide 5): add BP1/BP2/BP3 state-machine DFA diagrams using
  pptxgenjs ellipses and line shapes; definition cards compressed to top third;
  DFA drawings fill bottom two-thirds with arc resets
- Mealy→DFA (slide 6): replace Q_aux-only code box with 6-row element-by-element
  mapping table (I,O→Σ; Q→Q∪Qaux∪SINK; q0→q0; δ→Δ chain end; λ→aux steps;
  none→F=Q); highlighted rows show the key transformation steps
- Add DFA drawing helper functions: dfaState, dfaStart, dfaFwd, dfaArcAbove,
  dfaArcBelow
</commit_message>
<xml_diff>
--- a/slides/presentation.pptx
+++ b/slides/presentation.pptx
@@ -5953,7 +5953,7 @@
                   <a:srgbClr val="FFFFFF"/>
                 </a:solidFill>
               </a:rPr>
-              <a:t>Key Formalisms</a:t>
+              <a:t>The Three-Step Bug Detection Pipeline</a:t>
             </a:r>
             <a:endParaRPr lang="en-US" sz="2100" dirty="0"/>
           </a:p>
@@ -5967,8 +5967,8 @@
         </p:nvSpPr>
         <p:spPr>
           <a:xfrm>
-            <a:off x="274320" y="749808"/>
-            <a:ext cx="4160520" cy="4023360"/>
+            <a:off x="228600" y="777240"/>
+            <a:ext cx="2788920" cy="4023360"/>
           </a:xfrm>
           <a:prstGeom prst="rect">
             <a:avLst/>
@@ -5986,14 +5986,39 @@
       </p:sp>
       <p:sp>
         <p:nvSpPr>
-          <p:cNvPr id="6" name="Text 4"/>
-          <p:cNvSpPr/>
-          <p:nvPr/>
-        </p:nvSpPr>
-        <p:spPr>
-          <a:xfrm>
-            <a:off x="411480" y="804672"/>
-            <a:ext cx="3886200" cy="320040"/>
+          <p:cNvPr id="6" name="Shape 4"/>
+          <p:cNvSpPr/>
+          <p:nvPr/>
+        </p:nvSpPr>
+        <p:spPr>
+          <a:xfrm>
+            <a:off x="1234440" y="896112"/>
+            <a:ext cx="777240" cy="777240"/>
+          </a:xfrm>
+          <a:prstGeom prst="ellipse">
+            <a:avLst/>
+          </a:prstGeom>
+          <a:solidFill>
+            <a:srgbClr val="111111"/>
+          </a:solidFill>
+          <a:ln w="12700">
+            <a:solidFill>
+              <a:srgbClr val="111111"/>
+            </a:solidFill>
+            <a:prstDash val="solid"/>
+          </a:ln>
+        </p:spPr>
+      </p:sp>
+      <p:sp>
+        <p:nvSpPr>
+          <p:cNvPr id="7" name="Text 5"/>
+          <p:cNvSpPr/>
+          <p:nvPr/>
+        </p:nvSpPr>
+        <p:spPr>
+          <a:xfrm>
+            <a:off x="1234440" y="896112"/>
+            <a:ext cx="777240" cy="777240"/>
           </a:xfrm>
           <a:prstGeom prst="rect">
             <a:avLst/>
@@ -6005,31 +6030,240 @@
           <a:bodyPr wrap="square" rtlCol="0" anchor="ctr"/>
           <a:lstStyle/>
           <a:p>
-            <a:pPr indent="0" marL="0">
-              <a:buNone/>
-            </a:pPr>
-            <a:r>
-              <a:rPr lang="en-US" sz="1400" b="1" dirty="0">
+            <a:pPr algn="ctr" indent="0" marL="0">
+              <a:buNone/>
+            </a:pPr>
+            <a:r>
+              <a:rPr lang="en-US" sz="1800" b="1" dirty="0">
+                <a:solidFill>
+                  <a:srgbClr val="FFFFFF"/>
+                </a:solidFill>
+              </a:rPr>
+              <a:t>1</a:t>
+            </a:r>
+            <a:endParaRPr lang="en-US" sz="1800" dirty="0"/>
+          </a:p>
+        </p:txBody>
+      </p:sp>
+      <p:sp>
+        <p:nvSpPr>
+          <p:cNvPr id="8" name="Text 6"/>
+          <p:cNvSpPr/>
+          <p:nvPr/>
+        </p:nvSpPr>
+        <p:spPr>
+          <a:xfrm>
+            <a:off x="320040" y="1783080"/>
+            <a:ext cx="2606040" cy="347472"/>
+          </a:xfrm>
+          <a:prstGeom prst="rect">
+            <a:avLst/>
+          </a:prstGeom>
+          <a:noFill/>
+          <a:ln/>
+        </p:spPr>
+        <p:txBody>
+          <a:bodyPr wrap="square" rtlCol="0" anchor="ctr"/>
+          <a:lstStyle/>
+          <a:p>
+            <a:pPr algn="ctr" indent="0" marL="0">
+              <a:buNone/>
+            </a:pPr>
+            <a:r>
+              <a:rPr lang="en-US" sz="1250" b="1" dirty="0">
                 <a:solidFill>
                   <a:srgbClr val="111111"/>
                 </a:solidFill>
               </a:rPr>
-              <a:t>Mealy Machine  M</a:t>
-            </a:r>
-            <a:endParaRPr lang="en-US" sz="1400" dirty="0"/>
-          </a:p>
-        </p:txBody>
-      </p:sp>
-      <p:sp>
-        <p:nvSpPr>
-          <p:cNvPr id="7" name="Text 5"/>
-          <p:cNvSpPr/>
-          <p:nvPr/>
-        </p:nvSpPr>
-        <p:spPr>
-          <a:xfrm>
-            <a:off x="411480" y="1170432"/>
-            <a:ext cx="3886200" cy="274320"/>
+              <a:t>Learn Model</a:t>
+            </a:r>
+            <a:endParaRPr lang="en-US" sz="1250" dirty="0"/>
+          </a:p>
+        </p:txBody>
+      </p:sp>
+      <p:sp>
+        <p:nvSpPr>
+          <p:cNvPr id="9" name="Text 7"/>
+          <p:cNvSpPr/>
+          <p:nvPr/>
+        </p:nvSpPr>
+        <p:spPr>
+          <a:xfrm>
+            <a:off x="365760" y="2212848"/>
+            <a:ext cx="2514600" cy="2423160"/>
+          </a:xfrm>
+          <a:prstGeom prst="rect">
+            <a:avLst/>
+          </a:prstGeom>
+          <a:noFill/>
+          <a:ln/>
+        </p:spPr>
+        <p:txBody>
+          <a:bodyPr wrap="square" rtlCol="0" anchor="t"/>
+          <a:lstStyle/>
+          <a:p>
+            <a:pPr algn="ctr" indent="0" marL="0">
+              <a:buNone/>
+            </a:pPr>
+            <a:r>
+              <a:rPr lang="en-US" sz="1100" dirty="0">
+                <a:solidFill>
+                  <a:srgbClr val="1A1A1A"/>
+                </a:solidFill>
+              </a:rPr>
+              <a:t>Active automata learning</a:t>
+            </a:r>
+            <a:endParaRPr lang="en-US" sz="1100" dirty="0"/>
+          </a:p>
+          <a:p>
+            <a:pPr algn="ctr" indent="0" marL="0">
+              <a:buNone/>
+            </a:pPr>
+            <a:r>
+              <a:rPr lang="en-US" sz="1100" dirty="0">
+                <a:solidFill>
+                  <a:srgbClr val="1A1A1A"/>
+                </a:solidFill>
+              </a:rPr>
+              <a:t>queries the implementation</a:t>
+            </a:r>
+            <a:endParaRPr lang="en-US" sz="1100" dirty="0"/>
+          </a:p>
+          <a:p>
+            <a:pPr algn="ctr" indent="0" marL="0">
+              <a:buNone/>
+            </a:pPr>
+            <a:r>
+              <a:rPr lang="en-US" sz="1100" dirty="0">
+                <a:solidFill>
+                  <a:srgbClr val="1A1A1A"/>
+                </a:solidFill>
+              </a:rPr>
+              <a:t>as a black box and infers</a:t>
+            </a:r>
+            <a:endParaRPr lang="en-US" sz="1100" dirty="0"/>
+          </a:p>
+          <a:p>
+            <a:pPr algn="ctr" indent="0" marL="0">
+              <a:buNone/>
+            </a:pPr>
+            <a:r>
+              <a:rPr lang="en-US" sz="1100" dirty="0">
+                <a:solidFill>
+                  <a:srgbClr val="1A1A1A"/>
+                </a:solidFill>
+              </a:rPr>
+              <a:t>a Mealy machine M</a:t>
+            </a:r>
+            <a:endParaRPr lang="en-US" sz="1100" dirty="0"/>
+          </a:p>
+          <a:p>
+            <a:pPr algn="ctr" indent="0" marL="0">
+              <a:buNone/>
+            </a:pPr>
+            <a:endParaRPr lang="en-US" sz="1100" dirty="0"/>
+          </a:p>
+          <a:p>
+            <a:pPr algn="ctr" indent="0" marL="0">
+              <a:buNone/>
+            </a:pPr>
+            <a:r>
+              <a:rPr lang="en-US" sz="1100" dirty="0">
+                <a:solidFill>
+                  <a:srgbClr val="1A1A1A"/>
+                </a:solidFill>
+              </a:rPr>
+              <a:t>(L* / TTT algorithm)</a:t>
+            </a:r>
+            <a:endParaRPr lang="en-US" sz="1100" dirty="0"/>
+          </a:p>
+        </p:txBody>
+      </p:sp>
+      <p:sp>
+        <p:nvSpPr>
+          <p:cNvPr id="10" name="Shape 8"/>
+          <p:cNvSpPr/>
+          <p:nvPr/>
+        </p:nvSpPr>
+        <p:spPr>
+          <a:xfrm>
+            <a:off x="3063240" y="2788920"/>
+            <a:ext cx="118872" cy="118872"/>
+          </a:xfrm>
+          <a:prstGeom prst="rect">
+            <a:avLst/>
+          </a:prstGeom>
+          <a:solidFill>
+            <a:srgbClr val="888888"/>
+          </a:solidFill>
+          <a:ln w="12700">
+            <a:solidFill>
+              <a:srgbClr val="888888"/>
+            </a:solidFill>
+            <a:prstDash val="solid"/>
+          </a:ln>
+        </p:spPr>
+      </p:sp>
+      <p:sp>
+        <p:nvSpPr>
+          <p:cNvPr id="11" name="Shape 9"/>
+          <p:cNvSpPr/>
+          <p:nvPr/>
+        </p:nvSpPr>
+        <p:spPr>
+          <a:xfrm>
+            <a:off x="3227832" y="777240"/>
+            <a:ext cx="2788920" cy="4023360"/>
+          </a:xfrm>
+          <a:prstGeom prst="rect">
+            <a:avLst/>
+          </a:prstGeom>
+          <a:solidFill>
+            <a:srgbClr val="EBEBEB"/>
+          </a:solidFill>
+          <a:ln w="12700">
+            <a:solidFill>
+              <a:srgbClr val="CCCCCC"/>
+            </a:solidFill>
+            <a:prstDash val="solid"/>
+          </a:ln>
+        </p:spPr>
+      </p:sp>
+      <p:sp>
+        <p:nvSpPr>
+          <p:cNvPr id="12" name="Shape 10"/>
+          <p:cNvSpPr/>
+          <p:nvPr/>
+        </p:nvSpPr>
+        <p:spPr>
+          <a:xfrm>
+            <a:off x="4233672" y="896112"/>
+            <a:ext cx="777240" cy="777240"/>
+          </a:xfrm>
+          <a:prstGeom prst="ellipse">
+            <a:avLst/>
+          </a:prstGeom>
+          <a:solidFill>
+            <a:srgbClr val="111111"/>
+          </a:solidFill>
+          <a:ln w="12700">
+            <a:solidFill>
+              <a:srgbClr val="111111"/>
+            </a:solidFill>
+            <a:prstDash val="solid"/>
+          </a:ln>
+        </p:spPr>
+      </p:sp>
+      <p:sp>
+        <p:nvSpPr>
+          <p:cNvPr id="13" name="Text 11"/>
+          <p:cNvSpPr/>
+          <p:nvPr/>
+        </p:nvSpPr>
+        <p:spPr>
+          <a:xfrm>
+            <a:off x="4233672" y="896112"/>
+            <a:ext cx="777240" cy="777240"/>
           </a:xfrm>
           <a:prstGeom prst="rect">
             <a:avLst/>
@@ -6041,168 +6275,190 @@
           <a:bodyPr wrap="square" rtlCol="0" anchor="ctr"/>
           <a:lstStyle/>
           <a:p>
-            <a:pPr indent="0" marL="0">
-              <a:buNone/>
-            </a:pPr>
-            <a:r>
-              <a:rPr lang="en-US" sz="1200" dirty="0">
+            <a:pPr algn="ctr" indent="0" marL="0">
+              <a:buNone/>
+            </a:pPr>
+            <a:r>
+              <a:rPr lang="en-US" sz="1800" b="1" dirty="0">
+                <a:solidFill>
+                  <a:srgbClr val="FFFFFF"/>
+                </a:solidFill>
+              </a:rPr>
+              <a:t>2</a:t>
+            </a:r>
+            <a:endParaRPr lang="en-US" sz="1800" dirty="0"/>
+          </a:p>
+        </p:txBody>
+      </p:sp>
+      <p:sp>
+        <p:nvSpPr>
+          <p:cNvPr id="14" name="Text 12"/>
+          <p:cNvSpPr/>
+          <p:nvPr/>
+        </p:nvSpPr>
+        <p:spPr>
+          <a:xfrm>
+            <a:off x="3319272" y="1783080"/>
+            <a:ext cx="2606040" cy="347472"/>
+          </a:xfrm>
+          <a:prstGeom prst="rect">
+            <a:avLst/>
+          </a:prstGeom>
+          <a:noFill/>
+          <a:ln/>
+        </p:spPr>
+        <p:txBody>
+          <a:bodyPr wrap="square" rtlCol="0" anchor="ctr"/>
+          <a:lstStyle/>
+          <a:p>
+            <a:pPr algn="ctr" indent="0" marL="0">
+              <a:buNone/>
+            </a:pPr>
+            <a:r>
+              <a:rPr lang="en-US" sz="1250" b="1" dirty="0">
+                <a:solidFill>
+                  <a:srgbClr val="111111"/>
+                </a:solidFill>
+              </a:rPr>
+              <a:t>Encode Bug Pattern</a:t>
+            </a:r>
+            <a:endParaRPr lang="en-US" sz="1250" dirty="0"/>
+          </a:p>
+        </p:txBody>
+      </p:sp>
+      <p:sp>
+        <p:nvSpPr>
+          <p:cNvPr id="15" name="Text 13"/>
+          <p:cNvSpPr/>
+          <p:nvPr/>
+        </p:nvSpPr>
+        <p:spPr>
+          <a:xfrm>
+            <a:off x="3364992" y="2212848"/>
+            <a:ext cx="2514600" cy="2423160"/>
+          </a:xfrm>
+          <a:prstGeom prst="rect">
+            <a:avLst/>
+          </a:prstGeom>
+          <a:noFill/>
+          <a:ln/>
+        </p:spPr>
+        <p:txBody>
+          <a:bodyPr wrap="square" rtlCol="0" anchor="t"/>
+          <a:lstStyle/>
+          <a:p>
+            <a:pPr algn="ctr" indent="0" marL="0">
+              <a:buNone/>
+            </a:pPr>
+            <a:r>
+              <a:rPr lang="en-US" sz="1100" dirty="0">
                 <a:solidFill>
                   <a:srgbClr val="1A1A1A"/>
                 </a:solidFill>
-                <a:latin typeface="Courier New" pitchFamily="34" charset="0"/>
-                <a:ea typeface="Courier New" pitchFamily="34" charset="-122"/>
-                <a:cs typeface="Courier New" pitchFamily="34" charset="-120"/>
-              </a:rPr>
-              <a:t>M = (I, O, Q, q₀, δ, λ)</a:t>
-            </a:r>
-            <a:endParaRPr lang="en-US" sz="1200" dirty="0"/>
-          </a:p>
-        </p:txBody>
-      </p:sp>
-      <p:sp>
-        <p:nvSpPr>
-          <p:cNvPr id="8" name="Text 6"/>
-          <p:cNvSpPr/>
-          <p:nvPr/>
-        </p:nvSpPr>
-        <p:spPr>
-          <a:xfrm>
-            <a:off x="411480" y="1508760"/>
-            <a:ext cx="3886200" cy="3108960"/>
-          </a:xfrm>
-          <a:prstGeom prst="rect">
-            <a:avLst/>
-          </a:prstGeom>
-          <a:noFill/>
-          <a:ln/>
-        </p:spPr>
-        <p:txBody>
-          <a:bodyPr wrap="square" rtlCol="0" anchor="t"/>
-          <a:lstStyle/>
-          <a:p>
-            <a:pPr indent="0" marL="0">
-              <a:spcAft>
-                <a:spcPts val="300"/>
-              </a:spcAft>
+              </a:rPr>
+              <a:t>Construct a 3–5 state DFA</a:t>
+            </a:r>
+            <a:endParaRPr lang="en-US" sz="1100" dirty="0"/>
+          </a:p>
+          <a:p>
+            <a:pPr algn="ctr" indent="0" marL="0">
               <a:buNone/>
             </a:pPr>
             <a:r>
               <a:rPr lang="en-US" sz="1100" dirty="0">
                 <a:solidFill>
-                  <a:srgbClr val="111111"/>
-                </a:solidFill>
-              </a:rPr>
-              <a:t>I  = input alphabet (client → server)</a:t>
-            </a:r>
-            <a:pPr indent="0" marL="0">
-              <a:spcAft>
-                <a:spcPts val="300"/>
-              </a:spcAft>
+                  <a:srgbClr val="1A1A1A"/>
+                </a:solidFill>
+              </a:rPr>
+              <a:t>A_bug that accepts</a:t>
+            </a:r>
+            <a:endParaRPr lang="en-US" sz="1100" dirty="0"/>
+          </a:p>
+          <a:p>
+            <a:pPr algn="ctr" indent="0" marL="0">
               <a:buNone/>
             </a:pPr>
             <a:r>
               <a:rPr lang="en-US" sz="1100" dirty="0">
                 <a:solidFill>
-                  <a:srgbClr val="111111"/>
-                </a:solidFill>
-              </a:rPr>
-              <a:t>O  = output alphabet (server → client)</a:t>
-            </a:r>
-            <a:pPr indent="0" marL="0">
-              <a:spcAft>
-                <a:spcPts val="300"/>
-              </a:spcAft>
+                  <a:srgbClr val="1A1A1A"/>
+                </a:solidFill>
+              </a:rPr>
+              <a:t>exactly the I/O sequences</a:t>
+            </a:r>
+            <a:endParaRPr lang="en-US" sz="1100" dirty="0"/>
+          </a:p>
+          <a:p>
+            <a:pPr algn="ctr" indent="0" marL="0">
               <a:buNone/>
             </a:pPr>
             <a:r>
               <a:rPr lang="en-US" sz="1100" dirty="0">
                 <a:solidFill>
-                  <a:srgbClr val="111111"/>
-                </a:solidFill>
-              </a:rPr>
-              <a:t>Q  = finite set of states</a:t>
-            </a:r>
-            <a:pPr indent="0" marL="0">
-              <a:spcAft>
-                <a:spcPts val="300"/>
-              </a:spcAft>
+                  <a:srgbClr val="1A1A1A"/>
+                </a:solidFill>
+              </a:rPr>
+              <a:t>that exhibit the bug</a:t>
+            </a:r>
+            <a:endParaRPr lang="en-US" sz="1100" dirty="0"/>
+          </a:p>
+          <a:p>
+            <a:pPr algn="ctr" indent="0" marL="0">
+              <a:buNone/>
+            </a:pPr>
+            <a:endParaRPr lang="en-US" sz="1100" dirty="0"/>
+          </a:p>
+          <a:p>
+            <a:pPr algn="ctr" indent="0" marL="0">
               <a:buNone/>
             </a:pPr>
             <a:r>
               <a:rPr lang="en-US" sz="1100" dirty="0">
                 <a:solidFill>
-                  <a:srgbClr val="111111"/>
-                </a:solidFill>
-              </a:rPr>
-              <a:t>q₀ = initial state</a:t>
-            </a:r>
-            <a:pPr indent="0" marL="0">
-              <a:spcAft>
-                <a:spcPts val="300"/>
-              </a:spcAft>
-              <a:buNone/>
-            </a:pPr>
-            <a:r>
-              <a:rPr lang="en-US" sz="1100" dirty="0">
-                <a:solidFill>
-                  <a:srgbClr val="111111"/>
-                </a:solidFill>
-              </a:rPr>
-              <a:t>δ  : Q × I → Q   (transition)</a:t>
-            </a:r>
-            <a:pPr indent="0" marL="0">
-              <a:spcAft>
-                <a:spcPts val="1000"/>
-              </a:spcAft>
-              <a:buNone/>
-            </a:pPr>
-            <a:r>
-              <a:rPr lang="en-US" sz="1100" dirty="0">
-                <a:solidFill>
-                  <a:srgbClr val="111111"/>
-                </a:solidFill>
-              </a:rPr>
-              <a:t>λ  : Q × I → O*  (output sequence)</a:t>
-            </a:r>
-            <a:pPr indent="0" marL="0">
-              <a:buNone/>
-            </a:pPr>
-            <a:r>
-              <a:rPr lang="en-US" sz="1100" i="1" dirty="0">
-                <a:solidFill>
-                  <a:srgbClr val="888888"/>
-                </a:solidFill>
-              </a:rPr>
-              <a:t>Obtained via active automata learning</a:t>
+                  <a:srgbClr val="1A1A1A"/>
+                </a:solidFill>
+              </a:rPr>
+              <a:t>(from RFC or prior CVEs)</a:t>
             </a:r>
             <a:endParaRPr lang="en-US" sz="1100" dirty="0"/>
           </a:p>
-          <a:p>
-            <a:pPr indent="0" marL="0">
-              <a:buNone/>
-            </a:pPr>
-            <a:r>
-              <a:rPr lang="en-US" sz="1100" i="1" dirty="0">
-                <a:solidFill>
-                  <a:srgbClr val="888888"/>
-                </a:solidFill>
-              </a:rPr>
-              <a:t>(L* / TTT queries to the black-box SUT)</a:t>
-            </a:r>
-            <a:endParaRPr lang="en-US" sz="1100" dirty="0"/>
-          </a:p>
-        </p:txBody>
-      </p:sp>
-      <p:sp>
-        <p:nvSpPr>
-          <p:cNvPr id="9" name="Shape 7"/>
-          <p:cNvSpPr/>
-          <p:nvPr/>
-        </p:nvSpPr>
-        <p:spPr>
-          <a:xfrm>
-            <a:off x="4709160" y="749808"/>
-            <a:ext cx="4160520" cy="4023360"/>
+        </p:txBody>
+      </p:sp>
+      <p:sp>
+        <p:nvSpPr>
+          <p:cNvPr id="16" name="Shape 14"/>
+          <p:cNvSpPr/>
+          <p:nvPr/>
+        </p:nvSpPr>
+        <p:spPr>
+          <a:xfrm>
+            <a:off x="6062472" y="2788920"/>
+            <a:ext cx="118872" cy="118872"/>
+          </a:xfrm>
+          <a:prstGeom prst="rect">
+            <a:avLst/>
+          </a:prstGeom>
+          <a:solidFill>
+            <a:srgbClr val="888888"/>
+          </a:solidFill>
+          <a:ln w="12700">
+            <a:solidFill>
+              <a:srgbClr val="888888"/>
+            </a:solidFill>
+            <a:prstDash val="solid"/>
+          </a:ln>
+        </p:spPr>
+      </p:sp>
+      <p:sp>
+        <p:nvSpPr>
+          <p:cNvPr id="17" name="Shape 15"/>
+          <p:cNvSpPr/>
+          <p:nvPr/>
+        </p:nvSpPr>
+        <p:spPr>
+          <a:xfrm>
+            <a:off x="6227064" y="777240"/>
+            <a:ext cx="2788920" cy="4023360"/>
           </a:xfrm>
           <a:prstGeom prst="rect">
             <a:avLst/>
@@ -6220,14 +6476,39 @@
       </p:sp>
       <p:sp>
         <p:nvSpPr>
-          <p:cNvPr id="10" name="Text 8"/>
-          <p:cNvSpPr/>
-          <p:nvPr/>
-        </p:nvSpPr>
-        <p:spPr>
-          <a:xfrm>
-            <a:off x="4846320" y="804672"/>
-            <a:ext cx="3886200" cy="320040"/>
+          <p:cNvPr id="18" name="Shape 16"/>
+          <p:cNvSpPr/>
+          <p:nvPr/>
+        </p:nvSpPr>
+        <p:spPr>
+          <a:xfrm>
+            <a:off x="7232904" y="896112"/>
+            <a:ext cx="777240" cy="777240"/>
+          </a:xfrm>
+          <a:prstGeom prst="ellipse">
+            <a:avLst/>
+          </a:prstGeom>
+          <a:solidFill>
+            <a:srgbClr val="111111"/>
+          </a:solidFill>
+          <a:ln w="12700">
+            <a:solidFill>
+              <a:srgbClr val="111111"/>
+            </a:solidFill>
+            <a:prstDash val="solid"/>
+          </a:ln>
+        </p:spPr>
+      </p:sp>
+      <p:sp>
+        <p:nvSpPr>
+          <p:cNvPr id="19" name="Text 17"/>
+          <p:cNvSpPr/>
+          <p:nvPr/>
+        </p:nvSpPr>
+        <p:spPr>
+          <a:xfrm>
+            <a:off x="7232904" y="896112"/>
+            <a:ext cx="777240" cy="777240"/>
           </a:xfrm>
           <a:prstGeom prst="rect">
             <a:avLst/>
@@ -6239,197 +6520,152 @@
           <a:bodyPr wrap="square" rtlCol="0" anchor="ctr"/>
           <a:lstStyle/>
           <a:p>
-            <a:pPr indent="0" marL="0">
-              <a:buNone/>
-            </a:pPr>
-            <a:r>
-              <a:rPr lang="en-US" sz="1400" b="1" dirty="0">
+            <a:pPr algn="ctr" indent="0" marL="0">
+              <a:buNone/>
+            </a:pPr>
+            <a:r>
+              <a:rPr lang="en-US" sz="1800" b="1" dirty="0">
+                <a:solidFill>
+                  <a:srgbClr val="FFFFFF"/>
+                </a:solidFill>
+              </a:rPr>
+              <a:t>3</a:t>
+            </a:r>
+            <a:endParaRPr lang="en-US" sz="1800" dirty="0"/>
+          </a:p>
+        </p:txBody>
+      </p:sp>
+      <p:sp>
+        <p:nvSpPr>
+          <p:cNvPr id="20" name="Text 18"/>
+          <p:cNvSpPr/>
+          <p:nvPr/>
+        </p:nvSpPr>
+        <p:spPr>
+          <a:xfrm>
+            <a:off x="6318504" y="1783080"/>
+            <a:ext cx="2606040" cy="347472"/>
+          </a:xfrm>
+          <a:prstGeom prst="rect">
+            <a:avLst/>
+          </a:prstGeom>
+          <a:noFill/>
+          <a:ln/>
+        </p:spPr>
+        <p:txBody>
+          <a:bodyPr wrap="square" rtlCol="0" anchor="ctr"/>
+          <a:lstStyle/>
+          <a:p>
+            <a:pPr algn="ctr" indent="0" marL="0">
+              <a:buNone/>
+            </a:pPr>
+            <a:r>
+              <a:rPr lang="en-US" sz="1250" b="1" dirty="0">
                 <a:solidFill>
                   <a:srgbClr val="111111"/>
                 </a:solidFill>
               </a:rPr>
-              <a:t>Bug Pattern DFA  Aᵥ</a:t>
-            </a:r>
-            <a:endParaRPr lang="en-US" sz="1400" dirty="0"/>
-          </a:p>
-        </p:txBody>
-      </p:sp>
-      <p:sp>
-        <p:nvSpPr>
-          <p:cNvPr id="11" name="Text 9"/>
-          <p:cNvSpPr/>
-          <p:nvPr/>
-        </p:nvSpPr>
-        <p:spPr>
-          <a:xfrm>
-            <a:off x="4846320" y="1170432"/>
-            <a:ext cx="3886200" cy="274320"/>
-          </a:xfrm>
-          <a:prstGeom prst="rect">
-            <a:avLst/>
-          </a:prstGeom>
-          <a:noFill/>
-          <a:ln/>
-        </p:spPr>
-        <p:txBody>
-          <a:bodyPr wrap="square" rtlCol="0" anchor="ctr"/>
-          <a:lstStyle/>
-          <a:p>
-            <a:pPr indent="0" marL="0">
-              <a:buNone/>
-            </a:pPr>
-            <a:r>
-              <a:rPr lang="en-US" sz="1200" dirty="0">
+              <a:t>Intersect &amp; Validate</a:t>
+            </a:r>
+            <a:endParaRPr lang="en-US" sz="1250" dirty="0"/>
+          </a:p>
+        </p:txBody>
+      </p:sp>
+      <p:sp>
+        <p:nvSpPr>
+          <p:cNvPr id="21" name="Text 19"/>
+          <p:cNvSpPr/>
+          <p:nvPr/>
+        </p:nvSpPr>
+        <p:spPr>
+          <a:xfrm>
+            <a:off x="6364224" y="2212848"/>
+            <a:ext cx="2514600" cy="2423160"/>
+          </a:xfrm>
+          <a:prstGeom prst="rect">
+            <a:avLst/>
+          </a:prstGeom>
+          <a:noFill/>
+          <a:ln/>
+        </p:spPr>
+        <p:txBody>
+          <a:bodyPr wrap="square" rtlCol="0" anchor="t"/>
+          <a:lstStyle/>
+          <a:p>
+            <a:pPr algn="ctr" indent="0" marL="0">
+              <a:buNone/>
+            </a:pPr>
+            <a:r>
+              <a:rPr lang="en-US" sz="1100" dirty="0">
                 <a:solidFill>
                   <a:srgbClr val="1A1A1A"/>
                 </a:solidFill>
-                <a:latin typeface="Courier New" pitchFamily="34" charset="0"/>
-                <a:ea typeface="Courier New" pitchFamily="34" charset="-122"/>
-                <a:cs typeface="Courier New" pitchFamily="34" charset="-120"/>
-              </a:rPr>
-              <a:t>A = (Σ, Q, q₀, Δ, F)</a:t>
-            </a:r>
-            <a:endParaRPr lang="en-US" sz="1200" dirty="0"/>
-          </a:p>
-        </p:txBody>
-      </p:sp>
-      <p:sp>
-        <p:nvSpPr>
-          <p:cNvPr id="12" name="Text 10"/>
-          <p:cNvSpPr/>
-          <p:nvPr/>
-        </p:nvSpPr>
-        <p:spPr>
-          <a:xfrm>
-            <a:off x="4846320" y="1508760"/>
-            <a:ext cx="3886200" cy="3108960"/>
-          </a:xfrm>
-          <a:prstGeom prst="rect">
-            <a:avLst/>
-          </a:prstGeom>
-          <a:noFill/>
-          <a:ln/>
-        </p:spPr>
-        <p:txBody>
-          <a:bodyPr wrap="square" rtlCol="0" anchor="t"/>
-          <a:lstStyle/>
-          <a:p>
-            <a:pPr indent="0" marL="0">
-              <a:spcAft>
-                <a:spcPts val="300"/>
-              </a:spcAft>
+              </a:rPr>
+              <a:t>A∩ = A_M ∩ A_bug</a:t>
+            </a:r>
+            <a:endParaRPr lang="en-US" sz="1100" dirty="0"/>
+          </a:p>
+          <a:p>
+            <a:pPr algn="ctr" indent="0" marL="0">
               <a:buNone/>
             </a:pPr>
             <a:r>
               <a:rPr lang="en-US" sz="1100" dirty="0">
                 <a:solidFill>
-                  <a:srgbClr val="111111"/>
-                </a:solidFill>
-              </a:rPr>
-              <a:t>Σ  = I ∪ O   (combined alphabet)</a:t>
-            </a:r>
-            <a:pPr indent="0" marL="0">
-              <a:spcAft>
-                <a:spcPts val="300"/>
-              </a:spcAft>
+                  <a:srgbClr val="1A1A1A"/>
+                </a:solidFill>
+              </a:rPr>
+              <a:t>Algorithm 1 extracts a</a:t>
+            </a:r>
+            <a:endParaRPr lang="en-US" sz="1100" dirty="0"/>
+          </a:p>
+          <a:p>
+            <a:pPr algn="ctr" indent="0" marL="0">
               <a:buNone/>
             </a:pPr>
             <a:r>
               <a:rPr lang="en-US" sz="1100" dirty="0">
                 <a:solidFill>
-                  <a:srgbClr val="111111"/>
-                </a:solidFill>
-              </a:rPr>
-              <a:t>Q  = states tracking bug progress</a:t>
-            </a:r>
-            <a:pPr indent="0" marL="0">
-              <a:spcAft>
-                <a:spcPts val="300"/>
-              </a:spcAft>
+                  <a:srgbClr val="1A1A1A"/>
+                </a:solidFill>
+              </a:rPr>
+              <a:t>witness via backward BFS</a:t>
+            </a:r>
+            <a:endParaRPr lang="en-US" sz="1100" dirty="0"/>
+          </a:p>
+          <a:p>
+            <a:pPr algn="ctr" indent="0" marL="0">
               <a:buNone/>
             </a:pPr>
             <a:r>
               <a:rPr lang="en-US" sz="1100" dirty="0">
                 <a:solidFill>
-                  <a:srgbClr val="111111"/>
-                </a:solidFill>
-              </a:rPr>
-              <a:t>F  = accepting states → bug detected</a:t>
-            </a:r>
-            <a:pPr indent="0" marL="0">
-              <a:spcAft>
-                <a:spcPts val="1000"/>
-              </a:spcAft>
+                  <a:srgbClr val="1A1A1A"/>
+                </a:solidFill>
+              </a:rPr>
+              <a:t>and replays on the SUT</a:t>
+            </a:r>
+            <a:endParaRPr lang="en-US" sz="1100" dirty="0"/>
+          </a:p>
+          <a:p>
+            <a:pPr algn="ctr" indent="0" marL="0">
               <a:buNone/>
             </a:pPr>
             <a:r>
               <a:rPr lang="en-US" sz="1100" dirty="0">
                 <a:solidFill>
-                  <a:srgbClr val="111111"/>
-                </a:solidFill>
-              </a:rPr>
-              <a:t>Δ  : Q × Σ → Q  (undefined → SINK)</a:t>
-            </a:r>
-            <a:pPr indent="0" marL="0">
-              <a:spcAft>
-                <a:spcPts val="300"/>
-              </a:spcAft>
-              <a:buNone/>
-            </a:pPr>
-            <a:r>
-              <a:rPr lang="en-US" sz="1100" dirty="0">
-                <a:solidFill>
-                  <a:srgbClr val="111111"/>
-                </a:solidFill>
-              </a:rPr>
-              <a:t>Hand-crafted from RFC requirements</a:t>
-            </a:r>
-            <a:pPr indent="0" marL="0">
-              <a:spcAft>
-                <a:spcPts val="1000"/>
-              </a:spcAft>
-              <a:buNone/>
-            </a:pPr>
-            <a:r>
-              <a:rPr lang="en-US" sz="1100" dirty="0">
-                <a:solidFill>
-                  <a:srgbClr val="111111"/>
-                </a:solidFill>
-              </a:rPr>
-              <a:t>Typically just 3–5 states</a:t>
-            </a:r>
-            <a:pPr indent="0" marL="0">
-              <a:buNone/>
-            </a:pPr>
-            <a:r>
-              <a:rPr lang="en-US" sz="1100" i="1" dirty="0">
-                <a:solidFill>
-                  <a:srgbClr val="888888"/>
-                </a:solidFill>
-              </a:rPr>
-              <a:t>A_bug accepts a sequence w iff w</a:t>
+                  <a:srgbClr val="1A1A1A"/>
+                </a:solidFill>
+              </a:rPr>
+              <a:t>to confirm the bug</a:t>
             </a:r>
             <a:endParaRPr lang="en-US" sz="1100" dirty="0"/>
           </a:p>
-          <a:p>
-            <a:pPr indent="0" marL="0">
-              <a:buNone/>
-            </a:pPr>
-            <a:r>
-              <a:rPr lang="en-US" sz="1100" i="1" dirty="0">
-                <a:solidFill>
-                  <a:srgbClr val="888888"/>
-                </a:solidFill>
-              </a:rPr>
-              <a:t>provides evidence of the bug</a:t>
-            </a:r>
-            <a:endParaRPr lang="en-US" sz="1100" dirty="0"/>
-          </a:p>
-        </p:txBody>
-      </p:sp>
-      <p:sp>
-        <p:nvSpPr>
-          <p:cNvPr id="13" name="Text 11"/>
+        </p:txBody>
+      </p:sp>
+      <p:sp>
+        <p:nvSpPr>
+          <p:cNvPr id="22" name="Text 20"/>
           <p:cNvSpPr/>
           <p:nvPr/>
         </p:nvSpPr>
@@ -6568,7 +6804,7 @@
                   <a:srgbClr val="FFFFFF"/>
                 </a:solidFill>
               </a:rPr>
-              <a:t>The Three-Step Bug Detection Pipeline</a:t>
+              <a:t>Key Formalisms</a:t>
             </a:r>
             <a:endParaRPr lang="en-US" sz="2100" dirty="0"/>
           </a:p>
@@ -6582,8 +6818,8 @@
         </p:nvSpPr>
         <p:spPr>
           <a:xfrm>
-            <a:off x="228600" y="777240"/>
-            <a:ext cx="2788920" cy="4023360"/>
+            <a:off x="274320" y="749808"/>
+            <a:ext cx="4160520" cy="1664208"/>
           </a:xfrm>
           <a:prstGeom prst="rect">
             <a:avLst/>
@@ -6601,14 +6837,617 @@
       </p:sp>
       <p:sp>
         <p:nvSpPr>
-          <p:cNvPr id="6" name="Shape 4"/>
-          <p:cNvSpPr/>
-          <p:nvPr/>
-        </p:nvSpPr>
-        <p:spPr>
-          <a:xfrm>
-            <a:off x="1234440" y="896112"/>
-            <a:ext cx="777240" cy="777240"/>
+          <p:cNvPr id="6" name="Text 4"/>
+          <p:cNvSpPr/>
+          <p:nvPr/>
+        </p:nvSpPr>
+        <p:spPr>
+          <a:xfrm>
+            <a:off x="411480" y="804672"/>
+            <a:ext cx="3886200" cy="292608"/>
+          </a:xfrm>
+          <a:prstGeom prst="rect">
+            <a:avLst/>
+          </a:prstGeom>
+          <a:noFill/>
+          <a:ln/>
+        </p:spPr>
+        <p:txBody>
+          <a:bodyPr wrap="square" rtlCol="0" anchor="ctr"/>
+          <a:lstStyle/>
+          <a:p>
+            <a:pPr indent="0" marL="0">
+              <a:buNone/>
+            </a:pPr>
+            <a:r>
+              <a:rPr lang="en-US" sz="1350" b="1" dirty="0">
+                <a:solidFill>
+                  <a:srgbClr val="111111"/>
+                </a:solidFill>
+              </a:rPr>
+              <a:t>Mealy Machine  M</a:t>
+            </a:r>
+            <a:endParaRPr lang="en-US" sz="1350" dirty="0"/>
+          </a:p>
+        </p:txBody>
+      </p:sp>
+      <p:sp>
+        <p:nvSpPr>
+          <p:cNvPr id="7" name="Text 5"/>
+          <p:cNvSpPr/>
+          <p:nvPr/>
+        </p:nvSpPr>
+        <p:spPr>
+          <a:xfrm>
+            <a:off x="411480" y="1124712"/>
+            <a:ext cx="3886200" cy="237744"/>
+          </a:xfrm>
+          <a:prstGeom prst="rect">
+            <a:avLst/>
+          </a:prstGeom>
+          <a:noFill/>
+          <a:ln/>
+        </p:spPr>
+        <p:txBody>
+          <a:bodyPr wrap="square" rtlCol="0" anchor="ctr"/>
+          <a:lstStyle/>
+          <a:p>
+            <a:pPr indent="0" marL="0">
+              <a:buNone/>
+            </a:pPr>
+            <a:r>
+              <a:rPr lang="en-US" sz="1100" dirty="0">
+                <a:solidFill>
+                  <a:srgbClr val="1A1A1A"/>
+                </a:solidFill>
+                <a:latin typeface="Courier New" pitchFamily="34" charset="0"/>
+                <a:ea typeface="Courier New" pitchFamily="34" charset="-122"/>
+                <a:cs typeface="Courier New" pitchFamily="34" charset="-120"/>
+              </a:rPr>
+              <a:t>M = (I, O, Q, q₀, δ, λ)</a:t>
+            </a:r>
+            <a:endParaRPr lang="en-US" sz="1100" dirty="0"/>
+          </a:p>
+        </p:txBody>
+      </p:sp>
+      <p:sp>
+        <p:nvSpPr>
+          <p:cNvPr id="8" name="Text 6"/>
+          <p:cNvSpPr/>
+          <p:nvPr/>
+        </p:nvSpPr>
+        <p:spPr>
+          <a:xfrm>
+            <a:off x="411480" y="1408176"/>
+            <a:ext cx="3886200" cy="969264"/>
+          </a:xfrm>
+          <a:prstGeom prst="rect">
+            <a:avLst/>
+          </a:prstGeom>
+          <a:noFill/>
+          <a:ln/>
+        </p:spPr>
+        <p:txBody>
+          <a:bodyPr wrap="square" rtlCol="0" anchor="t"/>
+          <a:lstStyle/>
+          <a:p>
+            <a:pPr indent="0" marL="0">
+              <a:spcAft>
+                <a:spcPts val="200"/>
+              </a:spcAft>
+              <a:buNone/>
+            </a:pPr>
+            <a:r>
+              <a:rPr lang="en-US" sz="1000" dirty="0">
+                <a:solidFill>
+                  <a:srgbClr val="111111"/>
+                </a:solidFill>
+              </a:rPr>
+              <a:t>I = inputs,  O = outputs,  Q = states</a:t>
+            </a:r>
+            <a:pPr indent="0" marL="0">
+              <a:spcAft>
+                <a:spcPts val="400"/>
+              </a:spcAft>
+              <a:buNone/>
+            </a:pPr>
+            <a:r>
+              <a:rPr lang="en-US" sz="1000" dirty="0">
+                <a:solidFill>
+                  <a:srgbClr val="111111"/>
+                </a:solidFill>
+              </a:rPr>
+              <a:t>δ : transitions,  λ : output function</a:t>
+            </a:r>
+            <a:pPr indent="0" marL="0">
+              <a:buNone/>
+            </a:pPr>
+            <a:r>
+              <a:rPr lang="en-US" sz="1000" i="1" dirty="0">
+                <a:solidFill>
+                  <a:srgbClr val="888888"/>
+                </a:solidFill>
+              </a:rPr>
+              <a:t>Learned from black-box SUT (L* / TTT)</a:t>
+            </a:r>
+            <a:endParaRPr lang="en-US" sz="1000" dirty="0"/>
+          </a:p>
+        </p:txBody>
+      </p:sp>
+      <p:sp>
+        <p:nvSpPr>
+          <p:cNvPr id="9" name="Shape 7"/>
+          <p:cNvSpPr/>
+          <p:nvPr/>
+        </p:nvSpPr>
+        <p:spPr>
+          <a:xfrm>
+            <a:off x="4709160" y="749808"/>
+            <a:ext cx="4160520" cy="1664208"/>
+          </a:xfrm>
+          <a:prstGeom prst="rect">
+            <a:avLst/>
+          </a:prstGeom>
+          <a:solidFill>
+            <a:srgbClr val="E0E0E0"/>
+          </a:solidFill>
+          <a:ln w="12700">
+            <a:solidFill>
+              <a:srgbClr val="CCCCCC"/>
+            </a:solidFill>
+            <a:prstDash val="solid"/>
+          </a:ln>
+        </p:spPr>
+      </p:sp>
+      <p:sp>
+        <p:nvSpPr>
+          <p:cNvPr id="10" name="Text 8"/>
+          <p:cNvSpPr/>
+          <p:nvPr/>
+        </p:nvSpPr>
+        <p:spPr>
+          <a:xfrm>
+            <a:off x="4846320" y="804672"/>
+            <a:ext cx="3886200" cy="292608"/>
+          </a:xfrm>
+          <a:prstGeom prst="rect">
+            <a:avLst/>
+          </a:prstGeom>
+          <a:noFill/>
+          <a:ln/>
+        </p:spPr>
+        <p:txBody>
+          <a:bodyPr wrap="square" rtlCol="0" anchor="ctr"/>
+          <a:lstStyle/>
+          <a:p>
+            <a:pPr indent="0" marL="0">
+              <a:buNone/>
+            </a:pPr>
+            <a:r>
+              <a:rPr lang="en-US" sz="1350" b="1" dirty="0">
+                <a:solidFill>
+                  <a:srgbClr val="111111"/>
+                </a:solidFill>
+              </a:rPr>
+              <a:t>Bug Pattern DFA  A_bug</a:t>
+            </a:r>
+            <a:endParaRPr lang="en-US" sz="1350" dirty="0"/>
+          </a:p>
+        </p:txBody>
+      </p:sp>
+      <p:sp>
+        <p:nvSpPr>
+          <p:cNvPr id="11" name="Text 9"/>
+          <p:cNvSpPr/>
+          <p:nvPr/>
+        </p:nvSpPr>
+        <p:spPr>
+          <a:xfrm>
+            <a:off x="4846320" y="1124712"/>
+            <a:ext cx="3886200" cy="237744"/>
+          </a:xfrm>
+          <a:prstGeom prst="rect">
+            <a:avLst/>
+          </a:prstGeom>
+          <a:noFill/>
+          <a:ln/>
+        </p:spPr>
+        <p:txBody>
+          <a:bodyPr wrap="square" rtlCol="0" anchor="ctr"/>
+          <a:lstStyle/>
+          <a:p>
+            <a:pPr indent="0" marL="0">
+              <a:buNone/>
+            </a:pPr>
+            <a:r>
+              <a:rPr lang="en-US" sz="1100" dirty="0">
+                <a:solidFill>
+                  <a:srgbClr val="1A1A1A"/>
+                </a:solidFill>
+                <a:latin typeface="Courier New" pitchFamily="34" charset="0"/>
+                <a:ea typeface="Courier New" pitchFamily="34" charset="-122"/>
+                <a:cs typeface="Courier New" pitchFamily="34" charset="-120"/>
+              </a:rPr>
+              <a:t>A = (Σ, Q, q₀, Δ, F)</a:t>
+            </a:r>
+            <a:endParaRPr lang="en-US" sz="1100" dirty="0"/>
+          </a:p>
+        </p:txBody>
+      </p:sp>
+      <p:sp>
+        <p:nvSpPr>
+          <p:cNvPr id="12" name="Text 10"/>
+          <p:cNvSpPr/>
+          <p:nvPr/>
+        </p:nvSpPr>
+        <p:spPr>
+          <a:xfrm>
+            <a:off x="4846320" y="1408176"/>
+            <a:ext cx="3886200" cy="969264"/>
+          </a:xfrm>
+          <a:prstGeom prst="rect">
+            <a:avLst/>
+          </a:prstGeom>
+          <a:noFill/>
+          <a:ln/>
+        </p:spPr>
+        <p:txBody>
+          <a:bodyPr wrap="square" rtlCol="0" anchor="t"/>
+          <a:lstStyle/>
+          <a:p>
+            <a:pPr indent="0" marL="0">
+              <a:spcAft>
+                <a:spcPts val="400"/>
+              </a:spcAft>
+              <a:buNone/>
+            </a:pPr>
+            <a:r>
+              <a:rPr lang="en-US" sz="1000" dirty="0">
+                <a:solidFill>
+                  <a:srgbClr val="111111"/>
+                </a:solidFill>
+              </a:rPr>
+              <a:t>Σ = I ∪ O,  F = accepting states → bug</a:t>
+            </a:r>
+            <a:pPr indent="0" marL="0">
+              <a:buNone/>
+            </a:pPr>
+            <a:r>
+              <a:rPr lang="en-US" sz="1000" i="1" dirty="0">
+                <a:solidFill>
+                  <a:srgbClr val="888888"/>
+                </a:solidFill>
+              </a:rPr>
+              <a:t>Accepts w iff w exhibits the bug; 3–5 states</a:t>
+            </a:r>
+            <a:endParaRPr lang="en-US" sz="1000" dirty="0"/>
+          </a:p>
+        </p:txBody>
+      </p:sp>
+      <p:sp>
+        <p:nvSpPr>
+          <p:cNvPr id="13" name="Shape 11"/>
+          <p:cNvSpPr/>
+          <p:nvPr/>
+        </p:nvSpPr>
+        <p:spPr>
+          <a:xfrm>
+            <a:off x="274320" y="2505456"/>
+            <a:ext cx="8595360" cy="0"/>
+          </a:xfrm>
+          <a:prstGeom prst="line">
+            <a:avLst/>
+          </a:prstGeom>
+          <a:noFill/>
+          <a:ln w="12700">
+            <a:solidFill>
+              <a:srgbClr val="CCCCCC"/>
+            </a:solidFill>
+            <a:prstDash val="solid"/>
+          </a:ln>
+        </p:spPr>
+      </p:sp>
+      <p:sp>
+        <p:nvSpPr>
+          <p:cNvPr id="14" name="Text 12"/>
+          <p:cNvSpPr/>
+          <p:nvPr/>
+        </p:nvSpPr>
+        <p:spPr>
+          <a:xfrm>
+            <a:off x="274320" y="2560320"/>
+            <a:ext cx="8595360" cy="201168"/>
+          </a:xfrm>
+          <a:prstGeom prst="rect">
+            <a:avLst/>
+          </a:prstGeom>
+          <a:noFill/>
+          <a:ln/>
+        </p:spPr>
+        <p:txBody>
+          <a:bodyPr wrap="square" rtlCol="0" anchor="ctr"/>
+          <a:lstStyle/>
+          <a:p>
+            <a:pPr indent="0" marL="0">
+              <a:buNone/>
+            </a:pPr>
+            <a:r>
+              <a:rPr lang="en-US" sz="900" b="1" dirty="0">
+                <a:solidFill>
+                  <a:srgbClr val="111111"/>
+                </a:solidFill>
+              </a:rPr>
+              <a:t>Bug Pattern DFAs: BP1, BP2, BP3  (hand-crafted from RFC; 3-4 states; double circle = accepting = bug detected)</a:t>
+            </a:r>
+            <a:endParaRPr lang="en-US" sz="900" dirty="0"/>
+          </a:p>
+        </p:txBody>
+      </p:sp>
+      <p:sp>
+        <p:nvSpPr>
+          <p:cNvPr id="15" name="Text 13"/>
+          <p:cNvSpPr/>
+          <p:nvPr/>
+        </p:nvSpPr>
+        <p:spPr>
+          <a:xfrm>
+            <a:off x="182880" y="2798064"/>
+            <a:ext cx="2651760" cy="182880"/>
+          </a:xfrm>
+          <a:prstGeom prst="rect">
+            <a:avLst/>
+          </a:prstGeom>
+          <a:noFill/>
+          <a:ln/>
+        </p:spPr>
+        <p:txBody>
+          <a:bodyPr wrap="square" rtlCol="0" anchor="ctr"/>
+          <a:lstStyle/>
+          <a:p>
+            <a:pPr algn="ctr" indent="0" marL="0">
+              <a:buNone/>
+            </a:pPr>
+            <a:r>
+              <a:rPr lang="en-US" sz="850" b="1" dirty="0">
+                <a:solidFill>
+                  <a:srgbClr val="1A1A1A"/>
+                </a:solidFill>
+              </a:rPr>
+              <a:t>BP1  Missing Certificate</a:t>
+            </a:r>
+            <a:endParaRPr lang="en-US" sz="850" dirty="0"/>
+          </a:p>
+        </p:txBody>
+      </p:sp>
+      <p:sp>
+        <p:nvSpPr>
+          <p:cNvPr id="16" name="Text 14"/>
+          <p:cNvSpPr/>
+          <p:nvPr/>
+        </p:nvSpPr>
+        <p:spPr>
+          <a:xfrm>
+            <a:off x="3200400" y="2798064"/>
+            <a:ext cx="2651760" cy="182880"/>
+          </a:xfrm>
+          <a:prstGeom prst="rect">
+            <a:avLst/>
+          </a:prstGeom>
+          <a:noFill/>
+          <a:ln/>
+        </p:spPr>
+        <p:txBody>
+          <a:bodyPr wrap="square" rtlCol="0" anchor="ctr"/>
+          <a:lstStyle/>
+          <a:p>
+            <a:pPr algn="ctr" indent="0" marL="0">
+              <a:buNone/>
+            </a:pPr>
+            <a:r>
+              <a:rPr lang="en-US" sz="850" b="1" dirty="0">
+                <a:solidFill>
+                  <a:srgbClr val="1A1A1A"/>
+                </a:solidFill>
+              </a:rPr>
+              <a:t>BP2  Missing CertVer</a:t>
+            </a:r>
+            <a:endParaRPr lang="en-US" sz="850" dirty="0"/>
+          </a:p>
+        </p:txBody>
+      </p:sp>
+      <p:sp>
+        <p:nvSpPr>
+          <p:cNvPr id="17" name="Text 15"/>
+          <p:cNvSpPr/>
+          <p:nvPr/>
+        </p:nvSpPr>
+        <p:spPr>
+          <a:xfrm>
+            <a:off x="6172200" y="2798064"/>
+            <a:ext cx="2834640" cy="182880"/>
+          </a:xfrm>
+          <a:prstGeom prst="rect">
+            <a:avLst/>
+          </a:prstGeom>
+          <a:noFill/>
+          <a:ln/>
+        </p:spPr>
+        <p:txBody>
+          <a:bodyPr wrap="square" rtlCol="0" anchor="ctr"/>
+          <a:lstStyle/>
+          <a:p>
+            <a:pPr algn="ctr" indent="0" marL="0">
+              <a:buNone/>
+            </a:pPr>
+            <a:r>
+              <a:rPr lang="en-US" sz="850" b="1" dirty="0">
+                <a:solidFill>
+                  <a:srgbClr val="1A1A1A"/>
+                </a:solidFill>
+              </a:rPr>
+              <a:t>BP3  CertVer before CKE</a:t>
+            </a:r>
+            <a:endParaRPr lang="en-US" sz="850" dirty="0"/>
+          </a:p>
+        </p:txBody>
+      </p:sp>
+      <p:sp>
+        <p:nvSpPr>
+          <p:cNvPr id="18" name="Shape 16"/>
+          <p:cNvSpPr/>
+          <p:nvPr/>
+        </p:nvSpPr>
+        <p:spPr>
+          <a:xfrm>
+            <a:off x="498348" y="3854196"/>
+            <a:ext cx="338328" cy="338328"/>
+          </a:xfrm>
+          <a:prstGeom prst="ellipse">
+            <a:avLst/>
+          </a:prstGeom>
+          <a:solidFill>
+            <a:srgbClr val="FFFFFF"/>
+          </a:solidFill>
+          <a:ln w="12700">
+            <a:solidFill>
+              <a:srgbClr val="111111"/>
+            </a:solidFill>
+            <a:prstDash val="solid"/>
+          </a:ln>
+        </p:spPr>
+      </p:sp>
+      <p:sp>
+        <p:nvSpPr>
+          <p:cNvPr id="19" name="Text 17"/>
+          <p:cNvSpPr/>
+          <p:nvPr/>
+        </p:nvSpPr>
+        <p:spPr>
+          <a:xfrm>
+            <a:off x="498348" y="3854196"/>
+            <a:ext cx="338328" cy="338328"/>
+          </a:xfrm>
+          <a:prstGeom prst="rect">
+            <a:avLst/>
+          </a:prstGeom>
+          <a:noFill/>
+          <a:ln/>
+        </p:spPr>
+        <p:txBody>
+          <a:bodyPr wrap="square" lIns="0" tIns="0" rIns="0" bIns="0" rtlCol="0" anchor="ctr"/>
+          <a:lstStyle/>
+          <a:p>
+            <a:pPr algn="ctr" indent="0" marL="0">
+              <a:buNone/>
+            </a:pPr>
+            <a:r>
+              <a:rPr lang="en-US" sz="600" b="1" dirty="0">
+                <a:solidFill>
+                  <a:srgbClr val="111111"/>
+                </a:solidFill>
+              </a:rPr>
+              <a:t>init</a:t>
+            </a:r>
+            <a:endParaRPr lang="en-US" sz="600" dirty="0"/>
+          </a:p>
+        </p:txBody>
+      </p:sp>
+      <p:sp>
+        <p:nvSpPr>
+          <p:cNvPr id="20" name="Shape 18"/>
+          <p:cNvSpPr/>
+          <p:nvPr/>
+        </p:nvSpPr>
+        <p:spPr>
+          <a:xfrm>
+            <a:off x="1367028" y="3854196"/>
+            <a:ext cx="338328" cy="338328"/>
+          </a:xfrm>
+          <a:prstGeom prst="ellipse">
+            <a:avLst/>
+          </a:prstGeom>
+          <a:solidFill>
+            <a:srgbClr val="FFFFFF"/>
+          </a:solidFill>
+          <a:ln w="12700">
+            <a:solidFill>
+              <a:srgbClr val="111111"/>
+            </a:solidFill>
+            <a:prstDash val="solid"/>
+          </a:ln>
+        </p:spPr>
+      </p:sp>
+      <p:sp>
+        <p:nvSpPr>
+          <p:cNvPr id="21" name="Text 19"/>
+          <p:cNvSpPr/>
+          <p:nvPr/>
+        </p:nvSpPr>
+        <p:spPr>
+          <a:xfrm>
+            <a:off x="1367028" y="3854196"/>
+            <a:ext cx="338328" cy="338328"/>
+          </a:xfrm>
+          <a:prstGeom prst="rect">
+            <a:avLst/>
+          </a:prstGeom>
+          <a:noFill/>
+          <a:ln/>
+        </p:spPr>
+        <p:txBody>
+          <a:bodyPr wrap="square" lIns="0" tIns="0" rIns="0" bIns="0" rtlCol="0" anchor="ctr"/>
+          <a:lstStyle/>
+          <a:p>
+            <a:pPr algn="ctr" indent="0" marL="0">
+              <a:buNone/>
+            </a:pPr>
+            <a:r>
+              <a:rPr lang="en-US" sz="600" b="1" dirty="0">
+                <a:solidFill>
+                  <a:srgbClr val="111111"/>
+                </a:solidFill>
+              </a:rPr>
+              <a:t>s1</a:t>
+            </a:r>
+            <a:endParaRPr lang="en-US" sz="600" dirty="0"/>
+          </a:p>
+        </p:txBody>
+      </p:sp>
+      <p:sp>
+        <p:nvSpPr>
+          <p:cNvPr id="22" name="Shape 20"/>
+          <p:cNvSpPr/>
+          <p:nvPr/>
+        </p:nvSpPr>
+        <p:spPr>
+          <a:xfrm>
+            <a:off x="2189988" y="3808476"/>
+            <a:ext cx="429768" cy="429768"/>
+          </a:xfrm>
+          <a:prstGeom prst="ellipse">
+            <a:avLst/>
+          </a:prstGeom>
+          <a:solidFill>
+            <a:srgbClr val="F7F7F7"/>
+          </a:solidFill>
+          <a:ln w="12700">
+            <a:solidFill>
+              <a:srgbClr val="111111"/>
+            </a:solidFill>
+            <a:prstDash val="solid"/>
+          </a:ln>
+        </p:spPr>
+      </p:sp>
+      <p:sp>
+        <p:nvSpPr>
+          <p:cNvPr id="23" name="Shape 21"/>
+          <p:cNvSpPr/>
+          <p:nvPr/>
+        </p:nvSpPr>
+        <p:spPr>
+          <a:xfrm>
+            <a:off x="2235708" y="3854196"/>
+            <a:ext cx="338328" cy="338328"/>
           </a:xfrm>
           <a:prstGeom prst="ellipse">
             <a:avLst/>
@@ -6626,194 +7465,287 @@
       </p:sp>
       <p:sp>
         <p:nvSpPr>
-          <p:cNvPr id="7" name="Text 5"/>
-          <p:cNvSpPr/>
-          <p:nvPr/>
-        </p:nvSpPr>
-        <p:spPr>
-          <a:xfrm>
-            <a:off x="1234440" y="896112"/>
-            <a:ext cx="777240" cy="777240"/>
-          </a:xfrm>
-          <a:prstGeom prst="rect">
-            <a:avLst/>
-          </a:prstGeom>
-          <a:noFill/>
-          <a:ln/>
-        </p:spPr>
-        <p:txBody>
-          <a:bodyPr wrap="square" rtlCol="0" anchor="ctr"/>
+          <p:cNvPr id="24" name="Text 22"/>
+          <p:cNvSpPr/>
+          <p:nvPr/>
+        </p:nvSpPr>
+        <p:spPr>
+          <a:xfrm>
+            <a:off x="2235708" y="3854196"/>
+            <a:ext cx="338328" cy="338328"/>
+          </a:xfrm>
+          <a:prstGeom prst="rect">
+            <a:avLst/>
+          </a:prstGeom>
+          <a:noFill/>
+          <a:ln/>
+        </p:spPr>
+        <p:txBody>
+          <a:bodyPr wrap="square" lIns="0" tIns="0" rIns="0" bIns="0" rtlCol="0" anchor="ctr"/>
           <a:lstStyle/>
           <a:p>
             <a:pPr algn="ctr" indent="0" marL="0">
               <a:buNone/>
             </a:pPr>
             <a:r>
-              <a:rPr lang="en-US" sz="1800" b="1" dirty="0">
+              <a:rPr lang="en-US" sz="600" b="1" dirty="0">
                 <a:solidFill>
                   <a:srgbClr val="FFFFFF"/>
                 </a:solidFill>
               </a:rPr>
-              <a:t>1</a:t>
-            </a:r>
-            <a:endParaRPr lang="en-US" sz="1800" dirty="0"/>
-          </a:p>
-        </p:txBody>
-      </p:sp>
-      <p:sp>
-        <p:nvSpPr>
-          <p:cNvPr id="8" name="Text 6"/>
-          <p:cNvSpPr/>
-          <p:nvPr/>
-        </p:nvSpPr>
-        <p:spPr>
-          <a:xfrm>
-            <a:off x="320040" y="1783080"/>
-            <a:ext cx="2606040" cy="347472"/>
-          </a:xfrm>
-          <a:prstGeom prst="rect">
-            <a:avLst/>
-          </a:prstGeom>
-          <a:noFill/>
-          <a:ln/>
-        </p:spPr>
-        <p:txBody>
-          <a:bodyPr wrap="square" rtlCol="0" anchor="ctr"/>
+              <a:t>BUG</a:t>
+            </a:r>
+            <a:endParaRPr lang="en-US" sz="600" dirty="0"/>
+          </a:p>
+        </p:txBody>
+      </p:sp>
+      <p:sp>
+        <p:nvSpPr>
+          <p:cNvPr id="25" name="Shape 23"/>
+          <p:cNvSpPr/>
+          <p:nvPr/>
+        </p:nvSpPr>
+        <p:spPr>
+          <a:xfrm>
+            <a:off x="333756" y="4023360"/>
+            <a:ext cx="164592" cy="0"/>
+          </a:xfrm>
+          <a:prstGeom prst="line">
+            <a:avLst/>
+          </a:prstGeom>
+          <a:noFill/>
+          <a:ln w="12700">
+            <a:solidFill>
+              <a:srgbClr val="111111"/>
+            </a:solidFill>
+            <a:prstDash val="solid"/>
+            <a:tailEnd type="arrow"/>
+          </a:ln>
+        </p:spPr>
+      </p:sp>
+      <p:sp>
+        <p:nvSpPr>
+          <p:cNvPr id="26" name="Shape 24"/>
+          <p:cNvSpPr/>
+          <p:nvPr/>
+        </p:nvSpPr>
+        <p:spPr>
+          <a:xfrm>
+            <a:off x="836676" y="4023360"/>
+            <a:ext cx="530352" cy="0"/>
+          </a:xfrm>
+          <a:prstGeom prst="line">
+            <a:avLst/>
+          </a:prstGeom>
+          <a:noFill/>
+          <a:ln w="12700">
+            <a:solidFill>
+              <a:srgbClr val="111111"/>
+            </a:solidFill>
+            <a:prstDash val="solid"/>
+            <a:tailEnd type="arrow"/>
+          </a:ln>
+        </p:spPr>
+      </p:sp>
+      <p:sp>
+        <p:nvSpPr>
+          <p:cNvPr id="27" name="Text 25"/>
+          <p:cNvSpPr/>
+          <p:nvPr/>
+        </p:nvSpPr>
+        <p:spPr>
+          <a:xfrm>
+            <a:off x="763524" y="3849624"/>
+            <a:ext cx="676656" cy="155448"/>
+          </a:xfrm>
+          <a:prstGeom prst="rect">
+            <a:avLst/>
+          </a:prstGeom>
+          <a:noFill/>
+          <a:ln/>
+        </p:spPr>
+        <p:txBody>
+          <a:bodyPr wrap="square" lIns="0" tIns="0" rIns="0" bIns="0" rtlCol="0" anchor="ctr"/>
           <a:lstStyle/>
           <a:p>
             <a:pPr algn="ctr" indent="0" marL="0">
               <a:buNone/>
             </a:pPr>
             <a:r>
-              <a:rPr lang="en-US" sz="1250" b="1" dirty="0">
-                <a:solidFill>
-                  <a:srgbClr val="111111"/>
-                </a:solidFill>
-              </a:rPr>
-              <a:t>Learn Model</a:t>
-            </a:r>
-            <a:endParaRPr lang="en-US" sz="1250" dirty="0"/>
-          </a:p>
-        </p:txBody>
-      </p:sp>
-      <p:sp>
-        <p:nvSpPr>
-          <p:cNvPr id="9" name="Text 7"/>
-          <p:cNvSpPr/>
-          <p:nvPr/>
-        </p:nvSpPr>
-        <p:spPr>
-          <a:xfrm>
-            <a:off x="365760" y="2212848"/>
-            <a:ext cx="2514600" cy="2423160"/>
-          </a:xfrm>
-          <a:prstGeom prst="rect">
-            <a:avLst/>
-          </a:prstGeom>
-          <a:noFill/>
-          <a:ln/>
-        </p:spPr>
-        <p:txBody>
-          <a:bodyPr wrap="square" rtlCol="0" anchor="t"/>
+              <a:rPr lang="en-US" sz="650" dirty="0">
+                <a:solidFill>
+                  <a:srgbClr val="1A1A1A"/>
+                </a:solidFill>
+              </a:rPr>
+              <a:t>CertReq</a:t>
+            </a:r>
+            <a:endParaRPr lang="en-US" sz="650" dirty="0"/>
+          </a:p>
+        </p:txBody>
+      </p:sp>
+      <p:sp>
+        <p:nvSpPr>
+          <p:cNvPr id="28" name="Shape 26"/>
+          <p:cNvSpPr/>
+          <p:nvPr/>
+        </p:nvSpPr>
+        <p:spPr>
+          <a:xfrm>
+            <a:off x="1705356" y="4023360"/>
+            <a:ext cx="530352" cy="0"/>
+          </a:xfrm>
+          <a:prstGeom prst="line">
+            <a:avLst/>
+          </a:prstGeom>
+          <a:noFill/>
+          <a:ln w="12700">
+            <a:solidFill>
+              <a:srgbClr val="111111"/>
+            </a:solidFill>
+            <a:prstDash val="solid"/>
+            <a:tailEnd type="arrow"/>
+          </a:ln>
+        </p:spPr>
+      </p:sp>
+      <p:sp>
+        <p:nvSpPr>
+          <p:cNvPr id="29" name="Text 27"/>
+          <p:cNvSpPr/>
+          <p:nvPr/>
+        </p:nvSpPr>
+        <p:spPr>
+          <a:xfrm>
+            <a:off x="1632204" y="3849624"/>
+            <a:ext cx="676656" cy="155448"/>
+          </a:xfrm>
+          <a:prstGeom prst="rect">
+            <a:avLst/>
+          </a:prstGeom>
+          <a:noFill/>
+          <a:ln/>
+        </p:spPr>
+        <p:txBody>
+          <a:bodyPr wrap="square" lIns="0" tIns="0" rIns="0" bIns="0" rtlCol="0" anchor="ctr"/>
           <a:lstStyle/>
           <a:p>
             <a:pPr algn="ctr" indent="0" marL="0">
               <a:buNone/>
             </a:pPr>
             <a:r>
-              <a:rPr lang="en-US" sz="1100" dirty="0">
+              <a:rPr lang="en-US" sz="650" dirty="0">
                 <a:solidFill>
                   <a:srgbClr val="1A1A1A"/>
                 </a:solidFill>
               </a:rPr>
-              <a:t>Active automata learning</a:t>
-            </a:r>
-            <a:endParaRPr lang="en-US" sz="1100" dirty="0"/>
-          </a:p>
+              <a:t>CCS_s</a:t>
+            </a:r>
+            <a:endParaRPr lang="en-US" sz="650" dirty="0"/>
+          </a:p>
+        </p:txBody>
+      </p:sp>
+      <p:sp>
+        <p:nvSpPr>
+          <p:cNvPr id="30" name="Shape 28"/>
+          <p:cNvSpPr/>
+          <p:nvPr/>
+        </p:nvSpPr>
+        <p:spPr>
+          <a:xfrm>
+            <a:off x="1536192" y="3854196"/>
+            <a:ext cx="-434340" cy="-452628"/>
+          </a:xfrm>
+          <a:prstGeom prst="line">
+            <a:avLst/>
+          </a:prstGeom>
+          <a:noFill/>
+          <a:ln w="12700">
+            <a:solidFill>
+              <a:srgbClr val="1A1A1A"/>
+            </a:solidFill>
+            <a:prstDash val="solid"/>
+          </a:ln>
+        </p:spPr>
+      </p:sp>
+      <p:sp>
+        <p:nvSpPr>
+          <p:cNvPr id="31" name="Shape 29"/>
+          <p:cNvSpPr/>
+          <p:nvPr/>
+        </p:nvSpPr>
+        <p:spPr>
+          <a:xfrm>
+            <a:off x="1101852" y="3401568"/>
+            <a:ext cx="-434340" cy="452628"/>
+          </a:xfrm>
+          <a:prstGeom prst="line">
+            <a:avLst/>
+          </a:prstGeom>
+          <a:noFill/>
+          <a:ln w="12700">
+            <a:solidFill>
+              <a:srgbClr val="1A1A1A"/>
+            </a:solidFill>
+            <a:prstDash val="solid"/>
+            <a:tailEnd type="arrow"/>
+          </a:ln>
+        </p:spPr>
+      </p:sp>
+      <p:sp>
+        <p:nvSpPr>
+          <p:cNvPr id="32" name="Text 30"/>
+          <p:cNvSpPr/>
+          <p:nvPr/>
+        </p:nvSpPr>
+        <p:spPr>
+          <a:xfrm>
+            <a:off x="800100" y="3246120"/>
+            <a:ext cx="603504" cy="146304"/>
+          </a:xfrm>
+          <a:prstGeom prst="rect">
+            <a:avLst/>
+          </a:prstGeom>
+          <a:noFill/>
+          <a:ln/>
+        </p:spPr>
+        <p:txBody>
+          <a:bodyPr wrap="square" lIns="0" tIns="0" rIns="0" bIns="0" rtlCol="0" anchor="ctr"/>
+          <a:lstStyle/>
           <a:p>
             <a:pPr algn="ctr" indent="0" marL="0">
               <a:buNone/>
             </a:pPr>
             <a:r>
-              <a:rPr lang="en-US" sz="1100" dirty="0">
+              <a:rPr lang="en-US" sz="650" dirty="0">
                 <a:solidFill>
                   <a:srgbClr val="1A1A1A"/>
                 </a:solidFill>
               </a:rPr>
-              <a:t>queries the implementation</a:t>
-            </a:r>
-            <a:endParaRPr lang="en-US" sz="1100" dirty="0"/>
-          </a:p>
-          <a:p>
-            <a:pPr algn="ctr" indent="0" marL="0">
-              <a:buNone/>
-            </a:pPr>
-            <a:r>
-              <a:rPr lang="en-US" sz="1100" dirty="0">
-                <a:solidFill>
-                  <a:srgbClr val="1A1A1A"/>
-                </a:solidFill>
-              </a:rPr>
-              <a:t>as a black box and infers</a:t>
-            </a:r>
-            <a:endParaRPr lang="en-US" sz="1100" dirty="0"/>
-          </a:p>
-          <a:p>
-            <a:pPr algn="ctr" indent="0" marL="0">
-              <a:buNone/>
-            </a:pPr>
-            <a:r>
-              <a:rPr lang="en-US" sz="1100" dirty="0">
-                <a:solidFill>
-                  <a:srgbClr val="1A1A1A"/>
-                </a:solidFill>
-              </a:rPr>
-              <a:t>a Mealy machine M</a:t>
-            </a:r>
-            <a:endParaRPr lang="en-US" sz="1100" dirty="0"/>
-          </a:p>
-          <a:p>
-            <a:pPr algn="ctr" indent="0" marL="0">
-              <a:buNone/>
-            </a:pPr>
-            <a:endParaRPr lang="en-US" sz="1100" dirty="0"/>
-          </a:p>
-          <a:p>
-            <a:pPr algn="ctr" indent="0" marL="0">
-              <a:buNone/>
-            </a:pPr>
-            <a:r>
-              <a:rPr lang="en-US" sz="1100" dirty="0">
-                <a:solidFill>
-                  <a:srgbClr val="1A1A1A"/>
-                </a:solidFill>
-              </a:rPr>
-              <a:t>(L* / TTT algorithm)</a:t>
-            </a:r>
-            <a:endParaRPr lang="en-US" sz="1100" dirty="0"/>
-          </a:p>
-        </p:txBody>
-      </p:sp>
-      <p:sp>
-        <p:nvSpPr>
-          <p:cNvPr id="10" name="Shape 8"/>
-          <p:cNvSpPr/>
-          <p:nvPr/>
-        </p:nvSpPr>
-        <p:spPr>
-          <a:xfrm>
-            <a:off x="3063240" y="2788920"/>
-            <a:ext cx="118872" cy="118872"/>
-          </a:xfrm>
-          <a:prstGeom prst="rect">
+              <a:t>Cert</a:t>
+            </a:r>
+            <a:endParaRPr lang="en-US" sz="650" dirty="0"/>
+          </a:p>
+        </p:txBody>
+      </p:sp>
+      <p:sp>
+        <p:nvSpPr>
+          <p:cNvPr id="33" name="Shape 31"/>
+          <p:cNvSpPr/>
+          <p:nvPr/>
+        </p:nvSpPr>
+        <p:spPr>
+          <a:xfrm>
+            <a:off x="3561588" y="3854196"/>
+            <a:ext cx="338328" cy="338328"/>
+          </a:xfrm>
+          <a:prstGeom prst="ellipse">
             <a:avLst/>
           </a:prstGeom>
           <a:solidFill>
-            <a:srgbClr val="888888"/>
+            <a:srgbClr val="FFFFFF"/>
           </a:solidFill>
           <a:ln w="12700">
             <a:solidFill>
-              <a:srgbClr val="888888"/>
+              <a:srgbClr val="111111"/>
             </a:solidFill>
             <a:prstDash val="solid"/>
           </a:ln>
@@ -6821,24 +7753,60 @@
       </p:sp>
       <p:sp>
         <p:nvSpPr>
-          <p:cNvPr id="11" name="Shape 9"/>
-          <p:cNvSpPr/>
-          <p:nvPr/>
-        </p:nvSpPr>
-        <p:spPr>
-          <a:xfrm>
-            <a:off x="3227832" y="777240"/>
-            <a:ext cx="2788920" cy="4023360"/>
-          </a:xfrm>
-          <a:prstGeom prst="rect">
+          <p:cNvPr id="34" name="Text 32"/>
+          <p:cNvSpPr/>
+          <p:nvPr/>
+        </p:nvSpPr>
+        <p:spPr>
+          <a:xfrm>
+            <a:off x="3561588" y="3854196"/>
+            <a:ext cx="338328" cy="338328"/>
+          </a:xfrm>
+          <a:prstGeom prst="rect">
+            <a:avLst/>
+          </a:prstGeom>
+          <a:noFill/>
+          <a:ln/>
+        </p:spPr>
+        <p:txBody>
+          <a:bodyPr wrap="square" lIns="0" tIns="0" rIns="0" bIns="0" rtlCol="0" anchor="ctr"/>
+          <a:lstStyle/>
+          <a:p>
+            <a:pPr algn="ctr" indent="0" marL="0">
+              <a:buNone/>
+            </a:pPr>
+            <a:r>
+              <a:rPr lang="en-US" sz="600" b="1" dirty="0">
+                <a:solidFill>
+                  <a:srgbClr val="111111"/>
+                </a:solidFill>
+              </a:rPr>
+              <a:t>init</a:t>
+            </a:r>
+            <a:endParaRPr lang="en-US" sz="600" dirty="0"/>
+          </a:p>
+        </p:txBody>
+      </p:sp>
+      <p:sp>
+        <p:nvSpPr>
+          <p:cNvPr id="35" name="Shape 33"/>
+          <p:cNvSpPr/>
+          <p:nvPr/>
+        </p:nvSpPr>
+        <p:spPr>
+          <a:xfrm>
+            <a:off x="4430268" y="3854196"/>
+            <a:ext cx="338328" cy="338328"/>
+          </a:xfrm>
+          <a:prstGeom prst="ellipse">
             <a:avLst/>
           </a:prstGeom>
           <a:solidFill>
-            <a:srgbClr val="EBEBEB"/>
+            <a:srgbClr val="FFFFFF"/>
           </a:solidFill>
           <a:ln w="12700">
             <a:solidFill>
-              <a:srgbClr val="CCCCCC"/>
+              <a:srgbClr val="111111"/>
             </a:solidFill>
             <a:prstDash val="solid"/>
           </a:ln>
@@ -6846,14 +7814,75 @@
       </p:sp>
       <p:sp>
         <p:nvSpPr>
-          <p:cNvPr id="12" name="Shape 10"/>
-          <p:cNvSpPr/>
-          <p:nvPr/>
-        </p:nvSpPr>
-        <p:spPr>
-          <a:xfrm>
-            <a:off x="4233672" y="896112"/>
-            <a:ext cx="777240" cy="777240"/>
+          <p:cNvPr id="36" name="Text 34"/>
+          <p:cNvSpPr/>
+          <p:nvPr/>
+        </p:nvSpPr>
+        <p:spPr>
+          <a:xfrm>
+            <a:off x="4430268" y="3854196"/>
+            <a:ext cx="338328" cy="338328"/>
+          </a:xfrm>
+          <a:prstGeom prst="rect">
+            <a:avLst/>
+          </a:prstGeom>
+          <a:noFill/>
+          <a:ln/>
+        </p:spPr>
+        <p:txBody>
+          <a:bodyPr wrap="square" lIns="0" tIns="0" rIns="0" bIns="0" rtlCol="0" anchor="ctr"/>
+          <a:lstStyle/>
+          <a:p>
+            <a:pPr algn="ctr" indent="0" marL="0">
+              <a:buNone/>
+            </a:pPr>
+            <a:r>
+              <a:rPr lang="en-US" sz="600" b="1" dirty="0">
+                <a:solidFill>
+                  <a:srgbClr val="111111"/>
+                </a:solidFill>
+              </a:rPr>
+              <a:t>s1</a:t>
+            </a:r>
+            <a:endParaRPr lang="en-US" sz="600" dirty="0"/>
+          </a:p>
+        </p:txBody>
+      </p:sp>
+      <p:sp>
+        <p:nvSpPr>
+          <p:cNvPr id="37" name="Shape 35"/>
+          <p:cNvSpPr/>
+          <p:nvPr/>
+        </p:nvSpPr>
+        <p:spPr>
+          <a:xfrm>
+            <a:off x="5253228" y="3808476"/>
+            <a:ext cx="429768" cy="429768"/>
+          </a:xfrm>
+          <a:prstGeom prst="ellipse">
+            <a:avLst/>
+          </a:prstGeom>
+          <a:solidFill>
+            <a:srgbClr val="F7F7F7"/>
+          </a:solidFill>
+          <a:ln w="12700">
+            <a:solidFill>
+              <a:srgbClr val="111111"/>
+            </a:solidFill>
+            <a:prstDash val="solid"/>
+          </a:ln>
+        </p:spPr>
+      </p:sp>
+      <p:sp>
+        <p:nvSpPr>
+          <p:cNvPr id="38" name="Shape 36"/>
+          <p:cNvSpPr/>
+          <p:nvPr/>
+        </p:nvSpPr>
+        <p:spPr>
+          <a:xfrm>
+            <a:off x="5298948" y="3854196"/>
+            <a:ext cx="338328" cy="338328"/>
           </a:xfrm>
           <a:prstGeom prst="ellipse">
             <a:avLst/>
@@ -6871,194 +7900,287 @@
       </p:sp>
       <p:sp>
         <p:nvSpPr>
-          <p:cNvPr id="13" name="Text 11"/>
-          <p:cNvSpPr/>
-          <p:nvPr/>
-        </p:nvSpPr>
-        <p:spPr>
-          <a:xfrm>
-            <a:off x="4233672" y="896112"/>
-            <a:ext cx="777240" cy="777240"/>
-          </a:xfrm>
-          <a:prstGeom prst="rect">
-            <a:avLst/>
-          </a:prstGeom>
-          <a:noFill/>
-          <a:ln/>
-        </p:spPr>
-        <p:txBody>
-          <a:bodyPr wrap="square" rtlCol="0" anchor="ctr"/>
+          <p:cNvPr id="39" name="Text 37"/>
+          <p:cNvSpPr/>
+          <p:nvPr/>
+        </p:nvSpPr>
+        <p:spPr>
+          <a:xfrm>
+            <a:off x="5298948" y="3854196"/>
+            <a:ext cx="338328" cy="338328"/>
+          </a:xfrm>
+          <a:prstGeom prst="rect">
+            <a:avLst/>
+          </a:prstGeom>
+          <a:noFill/>
+          <a:ln/>
+        </p:spPr>
+        <p:txBody>
+          <a:bodyPr wrap="square" lIns="0" tIns="0" rIns="0" bIns="0" rtlCol="0" anchor="ctr"/>
           <a:lstStyle/>
           <a:p>
             <a:pPr algn="ctr" indent="0" marL="0">
               <a:buNone/>
             </a:pPr>
             <a:r>
-              <a:rPr lang="en-US" sz="1800" b="1" dirty="0">
+              <a:rPr lang="en-US" sz="600" b="1" dirty="0">
                 <a:solidFill>
                   <a:srgbClr val="FFFFFF"/>
                 </a:solidFill>
               </a:rPr>
-              <a:t>2</a:t>
-            </a:r>
-            <a:endParaRPr lang="en-US" sz="1800" dirty="0"/>
-          </a:p>
-        </p:txBody>
-      </p:sp>
-      <p:sp>
-        <p:nvSpPr>
-          <p:cNvPr id="14" name="Text 12"/>
-          <p:cNvSpPr/>
-          <p:nvPr/>
-        </p:nvSpPr>
-        <p:spPr>
-          <a:xfrm>
-            <a:off x="3319272" y="1783080"/>
-            <a:ext cx="2606040" cy="347472"/>
-          </a:xfrm>
-          <a:prstGeom prst="rect">
-            <a:avLst/>
-          </a:prstGeom>
-          <a:noFill/>
-          <a:ln/>
-        </p:spPr>
-        <p:txBody>
-          <a:bodyPr wrap="square" rtlCol="0" anchor="ctr"/>
+              <a:t>BUG</a:t>
+            </a:r>
+            <a:endParaRPr lang="en-US" sz="600" dirty="0"/>
+          </a:p>
+        </p:txBody>
+      </p:sp>
+      <p:sp>
+        <p:nvSpPr>
+          <p:cNvPr id="40" name="Shape 38"/>
+          <p:cNvSpPr/>
+          <p:nvPr/>
+        </p:nvSpPr>
+        <p:spPr>
+          <a:xfrm>
+            <a:off x="3396996" y="4023360"/>
+            <a:ext cx="164592" cy="0"/>
+          </a:xfrm>
+          <a:prstGeom prst="line">
+            <a:avLst/>
+          </a:prstGeom>
+          <a:noFill/>
+          <a:ln w="12700">
+            <a:solidFill>
+              <a:srgbClr val="111111"/>
+            </a:solidFill>
+            <a:prstDash val="solid"/>
+            <a:tailEnd type="arrow"/>
+          </a:ln>
+        </p:spPr>
+      </p:sp>
+      <p:sp>
+        <p:nvSpPr>
+          <p:cNvPr id="41" name="Shape 39"/>
+          <p:cNvSpPr/>
+          <p:nvPr/>
+        </p:nvSpPr>
+        <p:spPr>
+          <a:xfrm>
+            <a:off x="3899916" y="4023360"/>
+            <a:ext cx="530352" cy="0"/>
+          </a:xfrm>
+          <a:prstGeom prst="line">
+            <a:avLst/>
+          </a:prstGeom>
+          <a:noFill/>
+          <a:ln w="12700">
+            <a:solidFill>
+              <a:srgbClr val="111111"/>
+            </a:solidFill>
+            <a:prstDash val="solid"/>
+            <a:tailEnd type="arrow"/>
+          </a:ln>
+        </p:spPr>
+      </p:sp>
+      <p:sp>
+        <p:nvSpPr>
+          <p:cNvPr id="42" name="Text 40"/>
+          <p:cNvSpPr/>
+          <p:nvPr/>
+        </p:nvSpPr>
+        <p:spPr>
+          <a:xfrm>
+            <a:off x="3826764" y="3849624"/>
+            <a:ext cx="676656" cy="155448"/>
+          </a:xfrm>
+          <a:prstGeom prst="rect">
+            <a:avLst/>
+          </a:prstGeom>
+          <a:noFill/>
+          <a:ln/>
+        </p:spPr>
+        <p:txBody>
+          <a:bodyPr wrap="square" lIns="0" tIns="0" rIns="0" bIns="0" rtlCol="0" anchor="ctr"/>
           <a:lstStyle/>
           <a:p>
             <a:pPr algn="ctr" indent="0" marL="0">
               <a:buNone/>
             </a:pPr>
             <a:r>
-              <a:rPr lang="en-US" sz="1250" b="1" dirty="0">
-                <a:solidFill>
-                  <a:srgbClr val="111111"/>
-                </a:solidFill>
-              </a:rPr>
-              <a:t>Encode Bug Pattern</a:t>
-            </a:r>
-            <a:endParaRPr lang="en-US" sz="1250" dirty="0"/>
-          </a:p>
-        </p:txBody>
-      </p:sp>
-      <p:sp>
-        <p:nvSpPr>
-          <p:cNvPr id="15" name="Text 13"/>
-          <p:cNvSpPr/>
-          <p:nvPr/>
-        </p:nvSpPr>
-        <p:spPr>
-          <a:xfrm>
-            <a:off x="3364992" y="2212848"/>
-            <a:ext cx="2514600" cy="2423160"/>
-          </a:xfrm>
-          <a:prstGeom prst="rect">
-            <a:avLst/>
-          </a:prstGeom>
-          <a:noFill/>
-          <a:ln/>
-        </p:spPr>
-        <p:txBody>
-          <a:bodyPr wrap="square" rtlCol="0" anchor="t"/>
+              <a:rPr lang="en-US" sz="650" dirty="0">
+                <a:solidFill>
+                  <a:srgbClr val="1A1A1A"/>
+                </a:solidFill>
+              </a:rPr>
+              <a:t>Cert</a:t>
+            </a:r>
+            <a:endParaRPr lang="en-US" sz="650" dirty="0"/>
+          </a:p>
+        </p:txBody>
+      </p:sp>
+      <p:sp>
+        <p:nvSpPr>
+          <p:cNvPr id="43" name="Shape 41"/>
+          <p:cNvSpPr/>
+          <p:nvPr/>
+        </p:nvSpPr>
+        <p:spPr>
+          <a:xfrm>
+            <a:off x="4768596" y="4023360"/>
+            <a:ext cx="530352" cy="0"/>
+          </a:xfrm>
+          <a:prstGeom prst="line">
+            <a:avLst/>
+          </a:prstGeom>
+          <a:noFill/>
+          <a:ln w="12700">
+            <a:solidFill>
+              <a:srgbClr val="111111"/>
+            </a:solidFill>
+            <a:prstDash val="solid"/>
+            <a:tailEnd type="arrow"/>
+          </a:ln>
+        </p:spPr>
+      </p:sp>
+      <p:sp>
+        <p:nvSpPr>
+          <p:cNvPr id="44" name="Text 42"/>
+          <p:cNvSpPr/>
+          <p:nvPr/>
+        </p:nvSpPr>
+        <p:spPr>
+          <a:xfrm>
+            <a:off x="4695444" y="3849624"/>
+            <a:ext cx="676656" cy="155448"/>
+          </a:xfrm>
+          <a:prstGeom prst="rect">
+            <a:avLst/>
+          </a:prstGeom>
+          <a:noFill/>
+          <a:ln/>
+        </p:spPr>
+        <p:txBody>
+          <a:bodyPr wrap="square" lIns="0" tIns="0" rIns="0" bIns="0" rtlCol="0" anchor="ctr"/>
           <a:lstStyle/>
           <a:p>
             <a:pPr algn="ctr" indent="0" marL="0">
               <a:buNone/>
             </a:pPr>
             <a:r>
-              <a:rPr lang="en-US" sz="1100" dirty="0">
+              <a:rPr lang="en-US" sz="650" dirty="0">
                 <a:solidFill>
                   <a:srgbClr val="1A1A1A"/>
                 </a:solidFill>
               </a:rPr>
-              <a:t>Construct a 3–5 state DFA</a:t>
-            </a:r>
-            <a:endParaRPr lang="en-US" sz="1100" dirty="0"/>
-          </a:p>
+              <a:t>CCS_s</a:t>
+            </a:r>
+            <a:endParaRPr lang="en-US" sz="650" dirty="0"/>
+          </a:p>
+        </p:txBody>
+      </p:sp>
+      <p:sp>
+        <p:nvSpPr>
+          <p:cNvPr id="45" name="Shape 43"/>
+          <p:cNvSpPr/>
+          <p:nvPr/>
+        </p:nvSpPr>
+        <p:spPr>
+          <a:xfrm>
+            <a:off x="4599432" y="3854196"/>
+            <a:ext cx="-434340" cy="-452628"/>
+          </a:xfrm>
+          <a:prstGeom prst="line">
+            <a:avLst/>
+          </a:prstGeom>
+          <a:noFill/>
+          <a:ln w="12700">
+            <a:solidFill>
+              <a:srgbClr val="1A1A1A"/>
+            </a:solidFill>
+            <a:prstDash val="solid"/>
+          </a:ln>
+        </p:spPr>
+      </p:sp>
+      <p:sp>
+        <p:nvSpPr>
+          <p:cNvPr id="46" name="Shape 44"/>
+          <p:cNvSpPr/>
+          <p:nvPr/>
+        </p:nvSpPr>
+        <p:spPr>
+          <a:xfrm>
+            <a:off x="4165092" y="3401568"/>
+            <a:ext cx="-434340" cy="452628"/>
+          </a:xfrm>
+          <a:prstGeom prst="line">
+            <a:avLst/>
+          </a:prstGeom>
+          <a:noFill/>
+          <a:ln w="12700">
+            <a:solidFill>
+              <a:srgbClr val="1A1A1A"/>
+            </a:solidFill>
+            <a:prstDash val="solid"/>
+            <a:tailEnd type="arrow"/>
+          </a:ln>
+        </p:spPr>
+      </p:sp>
+      <p:sp>
+        <p:nvSpPr>
+          <p:cNvPr id="47" name="Text 45"/>
+          <p:cNvSpPr/>
+          <p:nvPr/>
+        </p:nvSpPr>
+        <p:spPr>
+          <a:xfrm>
+            <a:off x="3863340" y="3246120"/>
+            <a:ext cx="603504" cy="146304"/>
+          </a:xfrm>
+          <a:prstGeom prst="rect">
+            <a:avLst/>
+          </a:prstGeom>
+          <a:noFill/>
+          <a:ln/>
+        </p:spPr>
+        <p:txBody>
+          <a:bodyPr wrap="square" lIns="0" tIns="0" rIns="0" bIns="0" rtlCol="0" anchor="ctr"/>
+          <a:lstStyle/>
           <a:p>
             <a:pPr algn="ctr" indent="0" marL="0">
               <a:buNone/>
             </a:pPr>
             <a:r>
-              <a:rPr lang="en-US" sz="1100" dirty="0">
+              <a:rPr lang="en-US" sz="650" dirty="0">
                 <a:solidFill>
                   <a:srgbClr val="1A1A1A"/>
                 </a:solidFill>
               </a:rPr>
-              <a:t>A_bug that accepts</a:t>
-            </a:r>
-            <a:endParaRPr lang="en-US" sz="1100" dirty="0"/>
-          </a:p>
-          <a:p>
-            <a:pPr algn="ctr" indent="0" marL="0">
-              <a:buNone/>
-            </a:pPr>
-            <a:r>
-              <a:rPr lang="en-US" sz="1100" dirty="0">
-                <a:solidFill>
-                  <a:srgbClr val="1A1A1A"/>
-                </a:solidFill>
-              </a:rPr>
-              <a:t>exactly the I/O sequences</a:t>
-            </a:r>
-            <a:endParaRPr lang="en-US" sz="1100" dirty="0"/>
-          </a:p>
-          <a:p>
-            <a:pPr algn="ctr" indent="0" marL="0">
-              <a:buNone/>
-            </a:pPr>
-            <a:r>
-              <a:rPr lang="en-US" sz="1100" dirty="0">
-                <a:solidFill>
-                  <a:srgbClr val="1A1A1A"/>
-                </a:solidFill>
-              </a:rPr>
-              <a:t>that exhibit the bug</a:t>
-            </a:r>
-            <a:endParaRPr lang="en-US" sz="1100" dirty="0"/>
-          </a:p>
-          <a:p>
-            <a:pPr algn="ctr" indent="0" marL="0">
-              <a:buNone/>
-            </a:pPr>
-            <a:endParaRPr lang="en-US" sz="1100" dirty="0"/>
-          </a:p>
-          <a:p>
-            <a:pPr algn="ctr" indent="0" marL="0">
-              <a:buNone/>
-            </a:pPr>
-            <a:r>
-              <a:rPr lang="en-US" sz="1100" dirty="0">
-                <a:solidFill>
-                  <a:srgbClr val="1A1A1A"/>
-                </a:solidFill>
-              </a:rPr>
-              <a:t>(from RFC or prior CVEs)</a:t>
-            </a:r>
-            <a:endParaRPr lang="en-US" sz="1100" dirty="0"/>
-          </a:p>
-        </p:txBody>
-      </p:sp>
-      <p:sp>
-        <p:nvSpPr>
-          <p:cNvPr id="16" name="Shape 14"/>
-          <p:cNvSpPr/>
-          <p:nvPr/>
-        </p:nvSpPr>
-        <p:spPr>
-          <a:xfrm>
-            <a:off x="6062472" y="2788920"/>
-            <a:ext cx="118872" cy="118872"/>
-          </a:xfrm>
-          <a:prstGeom prst="rect">
+              <a:t>CertVer</a:t>
+            </a:r>
+            <a:endParaRPr lang="en-US" sz="650" dirty="0"/>
+          </a:p>
+        </p:txBody>
+      </p:sp>
+      <p:sp>
+        <p:nvSpPr>
+          <p:cNvPr id="48" name="Shape 46"/>
+          <p:cNvSpPr/>
+          <p:nvPr/>
+        </p:nvSpPr>
+        <p:spPr>
+          <a:xfrm>
+            <a:off x="6359652" y="3854196"/>
+            <a:ext cx="338328" cy="338328"/>
+          </a:xfrm>
+          <a:prstGeom prst="ellipse">
             <a:avLst/>
           </a:prstGeom>
           <a:solidFill>
-            <a:srgbClr val="888888"/>
+            <a:srgbClr val="FFFFFF"/>
           </a:solidFill>
           <a:ln w="12700">
             <a:solidFill>
-              <a:srgbClr val="888888"/>
+              <a:srgbClr val="111111"/>
             </a:solidFill>
             <a:prstDash val="solid"/>
           </a:ln>
@@ -7066,24 +8188,60 @@
       </p:sp>
       <p:sp>
         <p:nvSpPr>
-          <p:cNvPr id="17" name="Shape 15"/>
-          <p:cNvSpPr/>
-          <p:nvPr/>
-        </p:nvSpPr>
-        <p:spPr>
-          <a:xfrm>
-            <a:off x="6227064" y="777240"/>
-            <a:ext cx="2788920" cy="4023360"/>
-          </a:xfrm>
-          <a:prstGeom prst="rect">
+          <p:cNvPr id="49" name="Text 47"/>
+          <p:cNvSpPr/>
+          <p:nvPr/>
+        </p:nvSpPr>
+        <p:spPr>
+          <a:xfrm>
+            <a:off x="6359652" y="3854196"/>
+            <a:ext cx="338328" cy="338328"/>
+          </a:xfrm>
+          <a:prstGeom prst="rect">
+            <a:avLst/>
+          </a:prstGeom>
+          <a:noFill/>
+          <a:ln/>
+        </p:spPr>
+        <p:txBody>
+          <a:bodyPr wrap="square" lIns="0" tIns="0" rIns="0" bIns="0" rtlCol="0" anchor="ctr"/>
+          <a:lstStyle/>
+          <a:p>
+            <a:pPr algn="ctr" indent="0" marL="0">
+              <a:buNone/>
+            </a:pPr>
+            <a:r>
+              <a:rPr lang="en-US" sz="600" b="1" dirty="0">
+                <a:solidFill>
+                  <a:srgbClr val="111111"/>
+                </a:solidFill>
+              </a:rPr>
+              <a:t>init</a:t>
+            </a:r>
+            <a:endParaRPr lang="en-US" sz="600" dirty="0"/>
+          </a:p>
+        </p:txBody>
+      </p:sp>
+      <p:sp>
+        <p:nvSpPr>
+          <p:cNvPr id="50" name="Shape 48"/>
+          <p:cNvSpPr/>
+          <p:nvPr/>
+        </p:nvSpPr>
+        <p:spPr>
+          <a:xfrm>
+            <a:off x="7100316" y="3854196"/>
+            <a:ext cx="338328" cy="338328"/>
+          </a:xfrm>
+          <a:prstGeom prst="ellipse">
             <a:avLst/>
           </a:prstGeom>
           <a:solidFill>
-            <a:srgbClr val="E0E0E0"/>
+            <a:srgbClr val="FFFFFF"/>
           </a:solidFill>
           <a:ln w="12700">
             <a:solidFill>
-              <a:srgbClr val="CCCCCC"/>
+              <a:srgbClr val="111111"/>
             </a:solidFill>
             <a:prstDash val="solid"/>
           </a:ln>
@@ -7091,14 +8249,136 @@
       </p:sp>
       <p:sp>
         <p:nvSpPr>
-          <p:cNvPr id="18" name="Shape 16"/>
-          <p:cNvSpPr/>
-          <p:nvPr/>
-        </p:nvSpPr>
-        <p:spPr>
-          <a:xfrm>
-            <a:off x="7232904" y="896112"/>
-            <a:ext cx="777240" cy="777240"/>
+          <p:cNvPr id="51" name="Text 49"/>
+          <p:cNvSpPr/>
+          <p:nvPr/>
+        </p:nvSpPr>
+        <p:spPr>
+          <a:xfrm>
+            <a:off x="7100316" y="3854196"/>
+            <a:ext cx="338328" cy="338328"/>
+          </a:xfrm>
+          <a:prstGeom prst="rect">
+            <a:avLst/>
+          </a:prstGeom>
+          <a:noFill/>
+          <a:ln/>
+        </p:spPr>
+        <p:txBody>
+          <a:bodyPr wrap="square" lIns="0" tIns="0" rIns="0" bIns="0" rtlCol="0" anchor="ctr"/>
+          <a:lstStyle/>
+          <a:p>
+            <a:pPr algn="ctr" indent="0" marL="0">
+              <a:buNone/>
+            </a:pPr>
+            <a:r>
+              <a:rPr lang="en-US" sz="600" b="1" dirty="0">
+                <a:solidFill>
+                  <a:srgbClr val="111111"/>
+                </a:solidFill>
+              </a:rPr>
+              <a:t>s1</a:t>
+            </a:r>
+            <a:endParaRPr lang="en-US" sz="600" dirty="0"/>
+          </a:p>
+        </p:txBody>
+      </p:sp>
+      <p:sp>
+        <p:nvSpPr>
+          <p:cNvPr id="52" name="Shape 50"/>
+          <p:cNvSpPr/>
+          <p:nvPr/>
+        </p:nvSpPr>
+        <p:spPr>
+          <a:xfrm>
+            <a:off x="7840980" y="3854196"/>
+            <a:ext cx="338328" cy="338328"/>
+          </a:xfrm>
+          <a:prstGeom prst="ellipse">
+            <a:avLst/>
+          </a:prstGeom>
+          <a:solidFill>
+            <a:srgbClr val="FFFFFF"/>
+          </a:solidFill>
+          <a:ln w="12700">
+            <a:solidFill>
+              <a:srgbClr val="111111"/>
+            </a:solidFill>
+            <a:prstDash val="solid"/>
+          </a:ln>
+        </p:spPr>
+      </p:sp>
+      <p:sp>
+        <p:nvSpPr>
+          <p:cNvPr id="53" name="Text 51"/>
+          <p:cNvSpPr/>
+          <p:nvPr/>
+        </p:nvSpPr>
+        <p:spPr>
+          <a:xfrm>
+            <a:off x="7840980" y="3854196"/>
+            <a:ext cx="338328" cy="338328"/>
+          </a:xfrm>
+          <a:prstGeom prst="rect">
+            <a:avLst/>
+          </a:prstGeom>
+          <a:noFill/>
+          <a:ln/>
+        </p:spPr>
+        <p:txBody>
+          <a:bodyPr wrap="square" lIns="0" tIns="0" rIns="0" bIns="0" rtlCol="0" anchor="ctr"/>
+          <a:lstStyle/>
+          <a:p>
+            <a:pPr algn="ctr" indent="0" marL="0">
+              <a:buNone/>
+            </a:pPr>
+            <a:r>
+              <a:rPr lang="en-US" sz="600" b="1" dirty="0">
+                <a:solidFill>
+                  <a:srgbClr val="111111"/>
+                </a:solidFill>
+              </a:rPr>
+              <a:t>s2</a:t>
+            </a:r>
+            <a:endParaRPr lang="en-US" sz="600" dirty="0"/>
+          </a:p>
+        </p:txBody>
+      </p:sp>
+      <p:sp>
+        <p:nvSpPr>
+          <p:cNvPr id="54" name="Shape 52"/>
+          <p:cNvSpPr/>
+          <p:nvPr/>
+        </p:nvSpPr>
+        <p:spPr>
+          <a:xfrm>
+            <a:off x="8535924" y="3808476"/>
+            <a:ext cx="429768" cy="429768"/>
+          </a:xfrm>
+          <a:prstGeom prst="ellipse">
+            <a:avLst/>
+          </a:prstGeom>
+          <a:solidFill>
+            <a:srgbClr val="F7F7F7"/>
+          </a:solidFill>
+          <a:ln w="12700">
+            <a:solidFill>
+              <a:srgbClr val="111111"/>
+            </a:solidFill>
+            <a:prstDash val="solid"/>
+          </a:ln>
+        </p:spPr>
+      </p:sp>
+      <p:sp>
+        <p:nvSpPr>
+          <p:cNvPr id="55" name="Shape 53"/>
+          <p:cNvSpPr/>
+          <p:nvPr/>
+        </p:nvSpPr>
+        <p:spPr>
+          <a:xfrm>
+            <a:off x="8581644" y="3854196"/>
+            <a:ext cx="338328" cy="338328"/>
           </a:xfrm>
           <a:prstGeom prst="ellipse">
             <a:avLst/>
@@ -7116,14 +8396,420 @@
       </p:sp>
       <p:sp>
         <p:nvSpPr>
-          <p:cNvPr id="19" name="Text 17"/>
-          <p:cNvSpPr/>
-          <p:nvPr/>
-        </p:nvSpPr>
-        <p:spPr>
-          <a:xfrm>
-            <a:off x="7232904" y="896112"/>
-            <a:ext cx="777240" cy="777240"/>
+          <p:cNvPr id="56" name="Text 54"/>
+          <p:cNvSpPr/>
+          <p:nvPr/>
+        </p:nvSpPr>
+        <p:spPr>
+          <a:xfrm>
+            <a:off x="8581644" y="3854196"/>
+            <a:ext cx="338328" cy="338328"/>
+          </a:xfrm>
+          <a:prstGeom prst="rect">
+            <a:avLst/>
+          </a:prstGeom>
+          <a:noFill/>
+          <a:ln/>
+        </p:spPr>
+        <p:txBody>
+          <a:bodyPr wrap="square" lIns="0" tIns="0" rIns="0" bIns="0" rtlCol="0" anchor="ctr"/>
+          <a:lstStyle/>
+          <a:p>
+            <a:pPr algn="ctr" indent="0" marL="0">
+              <a:buNone/>
+            </a:pPr>
+            <a:r>
+              <a:rPr lang="en-US" sz="600" b="1" dirty="0">
+                <a:solidFill>
+                  <a:srgbClr val="FFFFFF"/>
+                </a:solidFill>
+              </a:rPr>
+              <a:t>BUG</a:t>
+            </a:r>
+            <a:endParaRPr lang="en-US" sz="600" dirty="0"/>
+          </a:p>
+        </p:txBody>
+      </p:sp>
+      <p:sp>
+        <p:nvSpPr>
+          <p:cNvPr id="57" name="Shape 55"/>
+          <p:cNvSpPr/>
+          <p:nvPr/>
+        </p:nvSpPr>
+        <p:spPr>
+          <a:xfrm>
+            <a:off x="6195060" y="4023360"/>
+            <a:ext cx="164592" cy="0"/>
+          </a:xfrm>
+          <a:prstGeom prst="line">
+            <a:avLst/>
+          </a:prstGeom>
+          <a:noFill/>
+          <a:ln w="12700">
+            <a:solidFill>
+              <a:srgbClr val="111111"/>
+            </a:solidFill>
+            <a:prstDash val="solid"/>
+            <a:tailEnd type="arrow"/>
+          </a:ln>
+        </p:spPr>
+      </p:sp>
+      <p:sp>
+        <p:nvSpPr>
+          <p:cNvPr id="58" name="Shape 56"/>
+          <p:cNvSpPr/>
+          <p:nvPr/>
+        </p:nvSpPr>
+        <p:spPr>
+          <a:xfrm>
+            <a:off x="6697980" y="4023360"/>
+            <a:ext cx="402336" cy="0"/>
+          </a:xfrm>
+          <a:prstGeom prst="line">
+            <a:avLst/>
+          </a:prstGeom>
+          <a:noFill/>
+          <a:ln w="12700">
+            <a:solidFill>
+              <a:srgbClr val="111111"/>
+            </a:solidFill>
+            <a:prstDash val="solid"/>
+            <a:tailEnd type="arrow"/>
+          </a:ln>
+        </p:spPr>
+      </p:sp>
+      <p:sp>
+        <p:nvSpPr>
+          <p:cNvPr id="59" name="Text 57"/>
+          <p:cNvSpPr/>
+          <p:nvPr/>
+        </p:nvSpPr>
+        <p:spPr>
+          <a:xfrm>
+            <a:off x="6624828" y="3849624"/>
+            <a:ext cx="548640" cy="155448"/>
+          </a:xfrm>
+          <a:prstGeom prst="rect">
+            <a:avLst/>
+          </a:prstGeom>
+          <a:noFill/>
+          <a:ln/>
+        </p:spPr>
+        <p:txBody>
+          <a:bodyPr wrap="square" lIns="0" tIns="0" rIns="0" bIns="0" rtlCol="0" anchor="ctr"/>
+          <a:lstStyle/>
+          <a:p>
+            <a:pPr algn="ctr" indent="0" marL="0">
+              <a:buNone/>
+            </a:pPr>
+            <a:r>
+              <a:rPr lang="en-US" sz="650" dirty="0">
+                <a:solidFill>
+                  <a:srgbClr val="1A1A1A"/>
+                </a:solidFill>
+              </a:rPr>
+              <a:t>CertVer</a:t>
+            </a:r>
+            <a:endParaRPr lang="en-US" sz="650" dirty="0"/>
+          </a:p>
+        </p:txBody>
+      </p:sp>
+      <p:sp>
+        <p:nvSpPr>
+          <p:cNvPr id="60" name="Shape 58"/>
+          <p:cNvSpPr/>
+          <p:nvPr/>
+        </p:nvSpPr>
+        <p:spPr>
+          <a:xfrm>
+            <a:off x="7438644" y="4023360"/>
+            <a:ext cx="402336" cy="0"/>
+          </a:xfrm>
+          <a:prstGeom prst="line">
+            <a:avLst/>
+          </a:prstGeom>
+          <a:noFill/>
+          <a:ln w="12700">
+            <a:solidFill>
+              <a:srgbClr val="111111"/>
+            </a:solidFill>
+            <a:prstDash val="solid"/>
+            <a:tailEnd type="arrow"/>
+          </a:ln>
+        </p:spPr>
+      </p:sp>
+      <p:sp>
+        <p:nvSpPr>
+          <p:cNvPr id="61" name="Text 59"/>
+          <p:cNvSpPr/>
+          <p:nvPr/>
+        </p:nvSpPr>
+        <p:spPr>
+          <a:xfrm>
+            <a:off x="7365492" y="3849624"/>
+            <a:ext cx="548640" cy="155448"/>
+          </a:xfrm>
+          <a:prstGeom prst="rect">
+            <a:avLst/>
+          </a:prstGeom>
+          <a:noFill/>
+          <a:ln/>
+        </p:spPr>
+        <p:txBody>
+          <a:bodyPr wrap="square" lIns="0" tIns="0" rIns="0" bIns="0" rtlCol="0" anchor="ctr"/>
+          <a:lstStyle/>
+          <a:p>
+            <a:pPr algn="ctr" indent="0" marL="0">
+              <a:buNone/>
+            </a:pPr>
+            <a:r>
+              <a:rPr lang="en-US" sz="650" dirty="0">
+                <a:solidFill>
+                  <a:srgbClr val="1A1A1A"/>
+                </a:solidFill>
+              </a:rPr>
+              <a:t>CKE</a:t>
+            </a:r>
+            <a:endParaRPr lang="en-US" sz="650" dirty="0"/>
+          </a:p>
+        </p:txBody>
+      </p:sp>
+      <p:sp>
+        <p:nvSpPr>
+          <p:cNvPr id="62" name="Shape 60"/>
+          <p:cNvSpPr/>
+          <p:nvPr/>
+        </p:nvSpPr>
+        <p:spPr>
+          <a:xfrm>
+            <a:off x="8179308" y="4023360"/>
+            <a:ext cx="402336" cy="0"/>
+          </a:xfrm>
+          <a:prstGeom prst="line">
+            <a:avLst/>
+          </a:prstGeom>
+          <a:noFill/>
+          <a:ln w="12700">
+            <a:solidFill>
+              <a:srgbClr val="111111"/>
+            </a:solidFill>
+            <a:prstDash val="solid"/>
+            <a:tailEnd type="arrow"/>
+          </a:ln>
+        </p:spPr>
+      </p:sp>
+      <p:sp>
+        <p:nvSpPr>
+          <p:cNvPr id="63" name="Text 61"/>
+          <p:cNvSpPr/>
+          <p:nvPr/>
+        </p:nvSpPr>
+        <p:spPr>
+          <a:xfrm>
+            <a:off x="8106156" y="3849624"/>
+            <a:ext cx="548640" cy="155448"/>
+          </a:xfrm>
+          <a:prstGeom prst="rect">
+            <a:avLst/>
+          </a:prstGeom>
+          <a:noFill/>
+          <a:ln/>
+        </p:spPr>
+        <p:txBody>
+          <a:bodyPr wrap="square" lIns="0" tIns="0" rIns="0" bIns="0" rtlCol="0" anchor="ctr"/>
+          <a:lstStyle/>
+          <a:p>
+            <a:pPr algn="ctr" indent="0" marL="0">
+              <a:buNone/>
+            </a:pPr>
+            <a:r>
+              <a:rPr lang="en-US" sz="650" dirty="0">
+                <a:solidFill>
+                  <a:srgbClr val="1A1A1A"/>
+                </a:solidFill>
+              </a:rPr>
+              <a:t>CCS_s</a:t>
+            </a:r>
+            <a:endParaRPr lang="en-US" sz="650" dirty="0"/>
+          </a:p>
+        </p:txBody>
+      </p:sp>
+      <p:sp>
+        <p:nvSpPr>
+          <p:cNvPr id="64" name="Shape 62"/>
+          <p:cNvSpPr/>
+          <p:nvPr/>
+        </p:nvSpPr>
+        <p:spPr>
+          <a:xfrm>
+            <a:off x="7269480" y="3854196"/>
+            <a:ext cx="-370332" cy="-516636"/>
+          </a:xfrm>
+          <a:prstGeom prst="line">
+            <a:avLst/>
+          </a:prstGeom>
+          <a:noFill/>
+          <a:ln w="12700">
+            <a:solidFill>
+              <a:srgbClr val="1A1A1A"/>
+            </a:solidFill>
+            <a:prstDash val="solid"/>
+          </a:ln>
+        </p:spPr>
+      </p:sp>
+      <p:sp>
+        <p:nvSpPr>
+          <p:cNvPr id="65" name="Shape 63"/>
+          <p:cNvSpPr/>
+          <p:nvPr/>
+        </p:nvSpPr>
+        <p:spPr>
+          <a:xfrm>
+            <a:off x="6899148" y="3337560"/>
+            <a:ext cx="-370332" cy="516636"/>
+          </a:xfrm>
+          <a:prstGeom prst="line">
+            <a:avLst/>
+          </a:prstGeom>
+          <a:noFill/>
+          <a:ln w="12700">
+            <a:solidFill>
+              <a:srgbClr val="1A1A1A"/>
+            </a:solidFill>
+            <a:prstDash val="solid"/>
+            <a:tailEnd type="arrow"/>
+          </a:ln>
+        </p:spPr>
+      </p:sp>
+      <p:sp>
+        <p:nvSpPr>
+          <p:cNvPr id="66" name="Text 64"/>
+          <p:cNvSpPr/>
+          <p:nvPr/>
+        </p:nvSpPr>
+        <p:spPr>
+          <a:xfrm>
+            <a:off x="6597396" y="3182112"/>
+            <a:ext cx="603504" cy="146304"/>
+          </a:xfrm>
+          <a:prstGeom prst="rect">
+            <a:avLst/>
+          </a:prstGeom>
+          <a:noFill/>
+          <a:ln/>
+        </p:spPr>
+        <p:txBody>
+          <a:bodyPr wrap="square" lIns="0" tIns="0" rIns="0" bIns="0" rtlCol="0" anchor="ctr"/>
+          <a:lstStyle/>
+          <a:p>
+            <a:pPr algn="ctr" indent="0" marL="0">
+              <a:buNone/>
+            </a:pPr>
+            <a:r>
+              <a:rPr lang="en-US" sz="650" dirty="0">
+                <a:solidFill>
+                  <a:srgbClr val="1A1A1A"/>
+                </a:solidFill>
+              </a:rPr>
+              <a:t>SH</a:t>
+            </a:r>
+            <a:endParaRPr lang="en-US" sz="650" dirty="0"/>
+          </a:p>
+        </p:txBody>
+      </p:sp>
+      <p:sp>
+        <p:nvSpPr>
+          <p:cNvPr id="67" name="Shape 65"/>
+          <p:cNvSpPr/>
+          <p:nvPr/>
+        </p:nvSpPr>
+        <p:spPr>
+          <a:xfrm>
+            <a:off x="8010144" y="4192524"/>
+            <a:ext cx="-740664" cy="352044"/>
+          </a:xfrm>
+          <a:prstGeom prst="line">
+            <a:avLst/>
+          </a:prstGeom>
+          <a:noFill/>
+          <a:ln w="12700">
+            <a:solidFill>
+              <a:srgbClr val="1A1A1A"/>
+            </a:solidFill>
+            <a:prstDash val="solid"/>
+          </a:ln>
+        </p:spPr>
+      </p:sp>
+      <p:sp>
+        <p:nvSpPr>
+          <p:cNvPr id="68" name="Shape 66"/>
+          <p:cNvSpPr/>
+          <p:nvPr/>
+        </p:nvSpPr>
+        <p:spPr>
+          <a:xfrm>
+            <a:off x="7269480" y="4544568"/>
+            <a:ext cx="-740664" cy="-352044"/>
+          </a:xfrm>
+          <a:prstGeom prst="line">
+            <a:avLst/>
+          </a:prstGeom>
+          <a:noFill/>
+          <a:ln w="12700">
+            <a:solidFill>
+              <a:srgbClr val="1A1A1A"/>
+            </a:solidFill>
+            <a:prstDash val="solid"/>
+            <a:tailEnd type="arrow"/>
+          </a:ln>
+        </p:spPr>
+      </p:sp>
+      <p:sp>
+        <p:nvSpPr>
+          <p:cNvPr id="69" name="Text 67"/>
+          <p:cNvSpPr/>
+          <p:nvPr/>
+        </p:nvSpPr>
+        <p:spPr>
+          <a:xfrm>
+            <a:off x="6967728" y="4553712"/>
+            <a:ext cx="603504" cy="146304"/>
+          </a:xfrm>
+          <a:prstGeom prst="rect">
+            <a:avLst/>
+          </a:prstGeom>
+          <a:noFill/>
+          <a:ln/>
+        </p:spPr>
+        <p:txBody>
+          <a:bodyPr wrap="square" lIns="0" tIns="0" rIns="0" bIns="0" rtlCol="0" anchor="ctr"/>
+          <a:lstStyle/>
+          <a:p>
+            <a:pPr algn="ctr" indent="0" marL="0">
+              <a:buNone/>
+            </a:pPr>
+            <a:r>
+              <a:rPr lang="en-US" sz="650" dirty="0">
+                <a:solidFill>
+                  <a:srgbClr val="1A1A1A"/>
+                </a:solidFill>
+              </a:rPr>
+              <a:t>SH</a:t>
+            </a:r>
+            <a:endParaRPr lang="en-US" sz="650" dirty="0"/>
+          </a:p>
+        </p:txBody>
+      </p:sp>
+      <p:sp>
+        <p:nvSpPr>
+          <p:cNvPr id="70" name="Text 68"/>
+          <p:cNvSpPr/>
+          <p:nvPr/>
+        </p:nvSpPr>
+        <p:spPr>
+          <a:xfrm>
+            <a:off x="6080760" y="4773168"/>
+            <a:ext cx="2926080" cy="164592"/>
           </a:xfrm>
           <a:prstGeom prst="rect">
             <a:avLst/>
@@ -7139,148 +8825,20 @@
               <a:buNone/>
             </a:pPr>
             <a:r>
-              <a:rPr lang="en-US" sz="1800" b="1" dirty="0">
-                <a:solidFill>
-                  <a:srgbClr val="FFFFFF"/>
-                </a:solidFill>
-              </a:rPr>
-              <a:t>3</a:t>
-            </a:r>
-            <a:endParaRPr lang="en-US" sz="1800" dirty="0"/>
-          </a:p>
-        </p:txBody>
-      </p:sp>
-      <p:sp>
-        <p:nvSpPr>
-          <p:cNvPr id="20" name="Text 18"/>
-          <p:cNvSpPr/>
-          <p:nvPr/>
-        </p:nvSpPr>
-        <p:spPr>
-          <a:xfrm>
-            <a:off x="6318504" y="1783080"/>
-            <a:ext cx="2606040" cy="347472"/>
-          </a:xfrm>
-          <a:prstGeom prst="rect">
-            <a:avLst/>
-          </a:prstGeom>
-          <a:noFill/>
-          <a:ln/>
-        </p:spPr>
-        <p:txBody>
-          <a:bodyPr wrap="square" rtlCol="0" anchor="ctr"/>
-          <a:lstStyle/>
-          <a:p>
-            <a:pPr algn="ctr" indent="0" marL="0">
-              <a:buNone/>
-            </a:pPr>
-            <a:r>
-              <a:rPr lang="en-US" sz="1250" b="1" dirty="0">
-                <a:solidFill>
-                  <a:srgbClr val="111111"/>
-                </a:solidFill>
-              </a:rPr>
-              <a:t>Intersect &amp; Validate</a:t>
-            </a:r>
-            <a:endParaRPr lang="en-US" sz="1250" dirty="0"/>
-          </a:p>
-        </p:txBody>
-      </p:sp>
-      <p:sp>
-        <p:nvSpPr>
-          <p:cNvPr id="21" name="Text 19"/>
-          <p:cNvSpPr/>
-          <p:nvPr/>
-        </p:nvSpPr>
-        <p:spPr>
-          <a:xfrm>
-            <a:off x="6364224" y="2212848"/>
-            <a:ext cx="2514600" cy="2423160"/>
-          </a:xfrm>
-          <a:prstGeom prst="rect">
-            <a:avLst/>
-          </a:prstGeom>
-          <a:noFill/>
-          <a:ln/>
-        </p:spPr>
-        <p:txBody>
-          <a:bodyPr wrap="square" rtlCol="0" anchor="t"/>
-          <a:lstStyle/>
-          <a:p>
-            <a:pPr algn="ctr" indent="0" marL="0">
-              <a:buNone/>
-            </a:pPr>
-            <a:r>
-              <a:rPr lang="en-US" sz="1100" dirty="0">
-                <a:solidFill>
-                  <a:srgbClr val="1A1A1A"/>
-                </a:solidFill>
-              </a:rPr>
-              <a:t>A∩ = A_M ∩ A_bug</a:t>
-            </a:r>
-            <a:endParaRPr lang="en-US" sz="1100" dirty="0"/>
-          </a:p>
-          <a:p>
-            <a:pPr algn="ctr" indent="0" marL="0">
-              <a:buNone/>
-            </a:pPr>
-            <a:r>
-              <a:rPr lang="en-US" sz="1100" dirty="0">
-                <a:solidFill>
-                  <a:srgbClr val="1A1A1A"/>
-                </a:solidFill>
-              </a:rPr>
-              <a:t>Algorithm 1 extracts a</a:t>
-            </a:r>
-            <a:endParaRPr lang="en-US" sz="1100" dirty="0"/>
-          </a:p>
-          <a:p>
-            <a:pPr algn="ctr" indent="0" marL="0">
-              <a:buNone/>
-            </a:pPr>
-            <a:r>
-              <a:rPr lang="en-US" sz="1100" dirty="0">
-                <a:solidFill>
-                  <a:srgbClr val="1A1A1A"/>
-                </a:solidFill>
-              </a:rPr>
-              <a:t>witness via backward BFS</a:t>
-            </a:r>
-            <a:endParaRPr lang="en-US" sz="1100" dirty="0"/>
-          </a:p>
-          <a:p>
-            <a:pPr algn="ctr" indent="0" marL="0">
-              <a:buNone/>
-            </a:pPr>
-            <a:r>
-              <a:rPr lang="en-US" sz="1100" dirty="0">
-                <a:solidFill>
-                  <a:srgbClr val="1A1A1A"/>
-                </a:solidFill>
-              </a:rPr>
-              <a:t>and replays on the SUT</a:t>
-            </a:r>
-            <a:endParaRPr lang="en-US" sz="1100" dirty="0"/>
-          </a:p>
-          <a:p>
-            <a:pPr algn="ctr" indent="0" marL="0">
-              <a:buNone/>
-            </a:pPr>
-            <a:r>
-              <a:rPr lang="en-US" sz="1100" dirty="0">
-                <a:solidFill>
-                  <a:srgbClr val="1A1A1A"/>
-                </a:solidFill>
-              </a:rPr>
-              <a:t>to confirm the bug</a:t>
-            </a:r>
-            <a:endParaRPr lang="en-US" sz="1100" dirty="0"/>
-          </a:p>
-        </p:txBody>
-      </p:sp>
-      <p:sp>
-        <p:nvSpPr>
-          <p:cNvPr id="22" name="Text 20"/>
+              <a:rPr lang="en-US" sz="550" dirty="0">
+                <a:solidFill>
+                  <a:srgbClr val="888888"/>
+                </a:solidFill>
+              </a:rPr>
+              <a:t>BP3: s1 = certver  |  s2 = cke_after  |  SH = renegotiation reset  |  self-loops on other symbols not shown</a:t>
+            </a:r>
+            <a:endParaRPr lang="en-US" sz="550" dirty="0"/>
+          </a:p>
+        </p:txBody>
+      </p:sp>
+      <p:sp>
+        <p:nvSpPr>
+          <p:cNvPr id="71" name="Text 69"/>
           <p:cNvSpPr/>
           <p:nvPr/>
         </p:nvSpPr>
@@ -7419,7 +8977,7 @@
                   <a:srgbClr val="FFFFFF"/>
                 </a:solidFill>
               </a:rPr>
-              <a:t>Converting M to DFA Aᵀ (Section VI)</a:t>
+              <a:t>Converting M to DFA A_M (Section VI)</a:t>
             </a:r>
             <a:endParaRPr lang="en-US" sz="2100" dirty="0"/>
           </a:p>
@@ -7434,7 +8992,7 @@
         <p:spPr>
           <a:xfrm>
             <a:off x="365760" y="749808"/>
-            <a:ext cx="8412480" cy="548640"/>
+            <a:ext cx="8412480" cy="310896"/>
           </a:xfrm>
           <a:prstGeom prst="rect">
             <a:avLst/>
@@ -7450,26 +9008,84 @@
               <a:buNone/>
             </a:pPr>
             <a:r>
-              <a:rPr lang="en-US" sz="1150" dirty="0">
+              <a:rPr lang="en-US" sz="1100" dirty="0">
                 <a:solidFill>
                   <a:srgbClr val="1A1A1A"/>
                 </a:solidFill>
               </a:rPr>
-              <a:t>DFA intersection requires both operands over the same alphabet Σ = I ∪ O.</a:t>
+              <a:t>A_M accepts all I/O traces M can produce. Both operands require the same alphabet Σ = I ∪ O for intersection.</a:t>
+            </a:r>
+            <a:endParaRPr lang="en-US" sz="1100" dirty="0"/>
+          </a:p>
+        </p:txBody>
+      </p:sp>
+      <p:sp>
+        <p:nvSpPr>
+          <p:cNvPr id="6" name="Text 4"/>
+          <p:cNvSpPr/>
+          <p:nvPr/>
+        </p:nvSpPr>
+        <p:spPr>
+          <a:xfrm>
+            <a:off x="274320" y="1097280"/>
+            <a:ext cx="3566160" cy="237744"/>
+          </a:xfrm>
+          <a:prstGeom prst="rect">
+            <a:avLst/>
+          </a:prstGeom>
+          <a:noFill/>
+          <a:ln/>
+        </p:spPr>
+        <p:txBody>
+          <a:bodyPr wrap="square" rtlCol="0" anchor="ctr"/>
+          <a:lstStyle/>
+          <a:p>
+            <a:pPr algn="ctr" indent="0" marL="0">
+              <a:buNone/>
+            </a:pPr>
+            <a:r>
+              <a:rPr lang="en-US" sz="1150" b="1" dirty="0">
+                <a:solidFill>
+                  <a:srgbClr val="111111"/>
+                </a:solidFill>
+              </a:rPr>
+              <a:t>Mealy machine  M</a:t>
             </a:r>
             <a:endParaRPr lang="en-US" sz="1150" dirty="0"/>
           </a:p>
-          <a:p>
-            <a:pPr indent="0" marL="0">
-              <a:buNone/>
-            </a:pPr>
-            <a:r>
-              <a:rPr lang="en-US" sz="1150" dirty="0">
-                <a:solidFill>
-                  <a:srgbClr val="1A1A1A"/>
-                </a:solidFill>
-              </a:rPr>
-              <a:t>The Mealy machine must be converted to A_M that accepts all I/O sequences M can produce.</a:t>
+        </p:txBody>
+      </p:sp>
+      <p:sp>
+        <p:nvSpPr>
+          <p:cNvPr id="7" name="Text 5"/>
+          <p:cNvSpPr/>
+          <p:nvPr/>
+        </p:nvSpPr>
+        <p:spPr>
+          <a:xfrm>
+            <a:off x="4370832" y="1097280"/>
+            <a:ext cx="4407408" cy="237744"/>
+          </a:xfrm>
+          <a:prstGeom prst="rect">
+            <a:avLst/>
+          </a:prstGeom>
+          <a:noFill/>
+          <a:ln/>
+        </p:spPr>
+        <p:txBody>
+          <a:bodyPr wrap="square" rtlCol="0" anchor="ctr"/>
+          <a:lstStyle/>
+          <a:p>
+            <a:pPr algn="ctr" indent="0" marL="0">
+              <a:buNone/>
+            </a:pPr>
+            <a:r>
+              <a:rPr lang="en-US" sz="1150" b="1" dirty="0">
+                <a:solidFill>
+                  <a:srgbClr val="111111"/>
+                </a:solidFill>
+              </a:rPr>
+              <a:t>DFA  A_M</a:t>
             </a:r>
             <a:endParaRPr lang="en-US" sz="1150" dirty="0"/>
           </a:p>
@@ -7477,14 +9093,14 @@
       </p:sp>
       <p:sp>
         <p:nvSpPr>
-          <p:cNvPr id="6" name="Shape 4"/>
-          <p:cNvSpPr/>
-          <p:nvPr/>
-        </p:nvSpPr>
-        <p:spPr>
-          <a:xfrm>
-            <a:off x="365760" y="1389888"/>
-            <a:ext cx="5212080" cy="2743200"/>
+          <p:cNvPr id="8" name="Shape 6"/>
+          <p:cNvSpPr/>
+          <p:nvPr/>
+        </p:nvSpPr>
+        <p:spPr>
+          <a:xfrm>
+            <a:off x="274320" y="1389888"/>
+            <a:ext cx="3566160" cy="438912"/>
           </a:xfrm>
           <a:prstGeom prst="rect">
             <a:avLst/>
@@ -7502,207 +9118,427 @@
       </p:sp>
       <p:sp>
         <p:nvSpPr>
-          <p:cNvPr id="7" name="Text 5"/>
-          <p:cNvSpPr/>
-          <p:nvPr/>
-        </p:nvSpPr>
-        <p:spPr>
-          <a:xfrm>
-            <a:off x="475488" y="1481328"/>
-            <a:ext cx="4992624" cy="2560320"/>
-          </a:xfrm>
-          <a:prstGeom prst="rect">
-            <a:avLst/>
-          </a:prstGeom>
-          <a:noFill/>
-          <a:ln/>
-        </p:spPr>
-        <p:txBody>
-          <a:bodyPr wrap="square" rtlCol="0" anchor="t"/>
-          <a:lstStyle/>
-          <a:p>
-            <a:pPr indent="0" marL="0">
-              <a:buNone/>
-            </a:pPr>
-            <a:r>
-              <a:rPr lang="en-US" sz="900" dirty="0">
+          <p:cNvPr id="9" name="Text 7"/>
+          <p:cNvSpPr/>
+          <p:nvPr/>
+        </p:nvSpPr>
+        <p:spPr>
+          <a:xfrm>
+            <a:off x="384048" y="1444752"/>
+            <a:ext cx="3346704" cy="329184"/>
+          </a:xfrm>
+          <a:prstGeom prst="rect">
+            <a:avLst/>
+          </a:prstGeom>
+          <a:noFill/>
+          <a:ln/>
+        </p:spPr>
+        <p:txBody>
+          <a:bodyPr wrap="square" rtlCol="0" anchor="ctr"/>
+          <a:lstStyle/>
+          <a:p>
+            <a:pPr indent="0" marL="0">
+              <a:buNone/>
+            </a:pPr>
+            <a:r>
+              <a:rPr lang="en-US" sz="1050" dirty="0">
                 <a:solidFill>
                   <a:srgbClr val="111111"/>
                 </a:solidFill>
-                <a:latin typeface="Courier New" pitchFamily="34" charset="0"/>
-                <a:ea typeface="Courier New" pitchFamily="34" charset="-122"/>
-                <a:cs typeface="Courier New" pitchFamily="34" charset="-120"/>
-              </a:rPr>
-              <a:t>For each (q, i) with λ(q,i) = o₁ o₂ … oₙ  (n ≥ 1):</a:t>
-            </a:r>
-            <a:endParaRPr lang="en-US" sz="900" dirty="0"/>
-          </a:p>
-          <a:p>
-            <a:pPr indent="0" marL="0">
-              <a:buNone/>
-            </a:pPr>
-            <a:r>
-              <a:rPr lang="en-US" sz="900" dirty="0">
+              </a:rPr>
+              <a:t>I, O  (input &amp; output alphabets)</a:t>
+            </a:r>
+            <a:endParaRPr lang="en-US" sz="1050" dirty="0"/>
+          </a:p>
+        </p:txBody>
+      </p:sp>
+      <p:sp>
+        <p:nvSpPr>
+          <p:cNvPr id="10" name="Shape 8"/>
+          <p:cNvSpPr/>
+          <p:nvPr/>
+        </p:nvSpPr>
+        <p:spPr>
+          <a:xfrm>
+            <a:off x="3877056" y="1609344"/>
+            <a:ext cx="365760" cy="0"/>
+          </a:xfrm>
+          <a:prstGeom prst="line">
+            <a:avLst/>
+          </a:prstGeom>
+          <a:noFill/>
+          <a:ln w="12700">
+            <a:solidFill>
+              <a:srgbClr val="888888"/>
+            </a:solidFill>
+            <a:prstDash val="solid"/>
+            <a:tailEnd type="arrow"/>
+          </a:ln>
+        </p:spPr>
+      </p:sp>
+      <p:sp>
+        <p:nvSpPr>
+          <p:cNvPr id="11" name="Shape 9"/>
+          <p:cNvSpPr/>
+          <p:nvPr/>
+        </p:nvSpPr>
+        <p:spPr>
+          <a:xfrm>
+            <a:off x="4370832" y="1389888"/>
+            <a:ext cx="4407408" cy="438912"/>
+          </a:xfrm>
+          <a:prstGeom prst="rect">
+            <a:avLst/>
+          </a:prstGeom>
+          <a:solidFill>
+            <a:srgbClr val="EBEBEB"/>
+          </a:solidFill>
+          <a:ln w="12700">
+            <a:solidFill>
+              <a:srgbClr val="CCCCCC"/>
+            </a:solidFill>
+            <a:prstDash val="solid"/>
+          </a:ln>
+        </p:spPr>
+      </p:sp>
+      <p:sp>
+        <p:nvSpPr>
+          <p:cNvPr id="12" name="Text 10"/>
+          <p:cNvSpPr/>
+          <p:nvPr/>
+        </p:nvSpPr>
+        <p:spPr>
+          <a:xfrm>
+            <a:off x="4480560" y="1444752"/>
+            <a:ext cx="4187952" cy="329184"/>
+          </a:xfrm>
+          <a:prstGeom prst="rect">
+            <a:avLst/>
+          </a:prstGeom>
+          <a:noFill/>
+          <a:ln/>
+        </p:spPr>
+        <p:txBody>
+          <a:bodyPr wrap="square" rtlCol="0" anchor="ctr"/>
+          <a:lstStyle/>
+          <a:p>
+            <a:pPr indent="0" marL="0">
+              <a:buNone/>
+            </a:pPr>
+            <a:r>
+              <a:rPr lang="en-US" sz="1050" dirty="0">
                 <a:solidFill>
                   <a:srgbClr val="111111"/>
                 </a:solidFill>
-                <a:latin typeface="Courier New" pitchFamily="34" charset="0"/>
-                <a:ea typeface="Courier New" pitchFamily="34" charset="-122"/>
-                <a:cs typeface="Courier New" pitchFamily="34" charset="-120"/>
-              </a:rPr>
-              <a:t>  introduce aux states  aux(q,i,0), aux(q,i,1), …, aux(q,i,n-1)</a:t>
-            </a:r>
-            <a:endParaRPr lang="en-US" sz="900" dirty="0"/>
-          </a:p>
-          <a:p>
-            <a:pPr indent="0" marL="0">
-              <a:buNone/>
-            </a:pPr>
-            <a:endParaRPr lang="en-US" sz="900" dirty="0"/>
-          </a:p>
-          <a:p>
-            <a:pPr indent="0" marL="0">
-              <a:buNone/>
-            </a:pPr>
-            <a:r>
-              <a:rPr lang="en-US" sz="900" dirty="0">
+              </a:rPr>
+              <a:t>Σ = I ∪ O  (same combined alphabet)</a:t>
+            </a:r>
+            <a:endParaRPr lang="en-US" sz="1050" dirty="0"/>
+          </a:p>
+        </p:txBody>
+      </p:sp>
+      <p:sp>
+        <p:nvSpPr>
+          <p:cNvPr id="13" name="Shape 11"/>
+          <p:cNvSpPr/>
+          <p:nvPr/>
+        </p:nvSpPr>
+        <p:spPr>
+          <a:xfrm>
+            <a:off x="274320" y="1865376"/>
+            <a:ext cx="3566160" cy="438912"/>
+          </a:xfrm>
+          <a:prstGeom prst="rect">
+            <a:avLst/>
+          </a:prstGeom>
+          <a:solidFill>
+            <a:srgbClr val="EBEBEB"/>
+          </a:solidFill>
+          <a:ln w="12700">
+            <a:solidFill>
+              <a:srgbClr val="CCCCCC"/>
+            </a:solidFill>
+            <a:prstDash val="solid"/>
+          </a:ln>
+        </p:spPr>
+      </p:sp>
+      <p:sp>
+        <p:nvSpPr>
+          <p:cNvPr id="14" name="Text 12"/>
+          <p:cNvSpPr/>
+          <p:nvPr/>
+        </p:nvSpPr>
+        <p:spPr>
+          <a:xfrm>
+            <a:off x="384048" y="1920240"/>
+            <a:ext cx="3346704" cy="329184"/>
+          </a:xfrm>
+          <a:prstGeom prst="rect">
+            <a:avLst/>
+          </a:prstGeom>
+          <a:noFill/>
+          <a:ln/>
+        </p:spPr>
+        <p:txBody>
+          <a:bodyPr wrap="square" rtlCol="0" anchor="ctr"/>
+          <a:lstStyle/>
+          <a:p>
+            <a:pPr indent="0" marL="0">
+              <a:buNone/>
+            </a:pPr>
+            <a:r>
+              <a:rPr lang="en-US" sz="1050" dirty="0">
                 <a:solidFill>
                   <a:srgbClr val="111111"/>
                 </a:solidFill>
-                <a:latin typeface="Courier New" pitchFamily="34" charset="0"/>
-                <a:ea typeface="Courier New" pitchFamily="34" charset="-122"/>
-                <a:cs typeface="Courier New" pitchFamily="34" charset="-120"/>
-              </a:rPr>
-              <a:t>  Δ(q,          i)          = aux(q,i,0)</a:t>
-            </a:r>
-            <a:endParaRPr lang="en-US" sz="900" dirty="0"/>
-          </a:p>
-          <a:p>
-            <a:pPr indent="0" marL="0">
-              <a:buNone/>
-            </a:pPr>
-            <a:r>
-              <a:rPr lang="en-US" sz="900" dirty="0">
+              </a:rPr>
+              <a:t>Q  (set of states)</a:t>
+            </a:r>
+            <a:endParaRPr lang="en-US" sz="1050" dirty="0"/>
+          </a:p>
+        </p:txBody>
+      </p:sp>
+      <p:sp>
+        <p:nvSpPr>
+          <p:cNvPr id="15" name="Shape 13"/>
+          <p:cNvSpPr/>
+          <p:nvPr/>
+        </p:nvSpPr>
+        <p:spPr>
+          <a:xfrm>
+            <a:off x="3877056" y="2084832"/>
+            <a:ext cx="365760" cy="0"/>
+          </a:xfrm>
+          <a:prstGeom prst="line">
+            <a:avLst/>
+          </a:prstGeom>
+          <a:noFill/>
+          <a:ln w="12700">
+            <a:solidFill>
+              <a:srgbClr val="888888"/>
+            </a:solidFill>
+            <a:prstDash val="solid"/>
+            <a:tailEnd type="arrow"/>
+          </a:ln>
+        </p:spPr>
+      </p:sp>
+      <p:sp>
+        <p:nvSpPr>
+          <p:cNvPr id="16" name="Shape 14"/>
+          <p:cNvSpPr/>
+          <p:nvPr/>
+        </p:nvSpPr>
+        <p:spPr>
+          <a:xfrm>
+            <a:off x="4370832" y="1865376"/>
+            <a:ext cx="4407408" cy="438912"/>
+          </a:xfrm>
+          <a:prstGeom prst="rect">
+            <a:avLst/>
+          </a:prstGeom>
+          <a:solidFill>
+            <a:srgbClr val="EBEBEB"/>
+          </a:solidFill>
+          <a:ln w="12700">
+            <a:solidFill>
+              <a:srgbClr val="CCCCCC"/>
+            </a:solidFill>
+            <a:prstDash val="solid"/>
+          </a:ln>
+        </p:spPr>
+      </p:sp>
+      <p:sp>
+        <p:nvSpPr>
+          <p:cNvPr id="17" name="Text 15"/>
+          <p:cNvSpPr/>
+          <p:nvPr/>
+        </p:nvSpPr>
+        <p:spPr>
+          <a:xfrm>
+            <a:off x="4480560" y="1920240"/>
+            <a:ext cx="4187952" cy="329184"/>
+          </a:xfrm>
+          <a:prstGeom prst="rect">
+            <a:avLst/>
+          </a:prstGeom>
+          <a:noFill/>
+          <a:ln/>
+        </p:spPr>
+        <p:txBody>
+          <a:bodyPr wrap="square" rtlCol="0" anchor="ctr"/>
+          <a:lstStyle/>
+          <a:p>
+            <a:pPr indent="0" marL="0">
+              <a:buNone/>
+            </a:pPr>
+            <a:r>
+              <a:rPr lang="en-US" sz="1050" dirty="0">
                 <a:solidFill>
                   <a:srgbClr val="111111"/>
                 </a:solidFill>
-                <a:latin typeface="Courier New" pitchFamily="34" charset="0"/>
-                <a:ea typeface="Courier New" pitchFamily="34" charset="-122"/>
-                <a:cs typeface="Courier New" pitchFamily="34" charset="-120"/>
-              </a:rPr>
-              <a:t>  Δ(aux(q,i,k), o_{k+1})    = aux(q,i,k+1)   for k &lt; n-1</a:t>
-            </a:r>
-            <a:endParaRPr lang="en-US" sz="900" dirty="0"/>
-          </a:p>
-          <a:p>
-            <a:pPr indent="0" marL="0">
-              <a:buNone/>
-            </a:pPr>
-            <a:r>
-              <a:rPr lang="en-US" sz="900" dirty="0">
+              </a:rPr>
+              <a:t>Q ∪ Q_aux ∪ {SINK}  (original + auxiliary + dead)</a:t>
+            </a:r>
+            <a:endParaRPr lang="en-US" sz="1050" dirty="0"/>
+          </a:p>
+        </p:txBody>
+      </p:sp>
+      <p:sp>
+        <p:nvSpPr>
+          <p:cNvPr id="18" name="Shape 16"/>
+          <p:cNvSpPr/>
+          <p:nvPr/>
+        </p:nvSpPr>
+        <p:spPr>
+          <a:xfrm>
+            <a:off x="274320" y="2340864"/>
+            <a:ext cx="3566160" cy="438912"/>
+          </a:xfrm>
+          <a:prstGeom prst="rect">
+            <a:avLst/>
+          </a:prstGeom>
+          <a:solidFill>
+            <a:srgbClr val="EBEBEB"/>
+          </a:solidFill>
+          <a:ln w="12700">
+            <a:solidFill>
+              <a:srgbClr val="CCCCCC"/>
+            </a:solidFill>
+            <a:prstDash val="solid"/>
+          </a:ln>
+        </p:spPr>
+      </p:sp>
+      <p:sp>
+        <p:nvSpPr>
+          <p:cNvPr id="19" name="Text 17"/>
+          <p:cNvSpPr/>
+          <p:nvPr/>
+        </p:nvSpPr>
+        <p:spPr>
+          <a:xfrm>
+            <a:off x="384048" y="2395728"/>
+            <a:ext cx="3346704" cy="329184"/>
+          </a:xfrm>
+          <a:prstGeom prst="rect">
+            <a:avLst/>
+          </a:prstGeom>
+          <a:noFill/>
+          <a:ln/>
+        </p:spPr>
+        <p:txBody>
+          <a:bodyPr wrap="square" rtlCol="0" anchor="ctr"/>
+          <a:lstStyle/>
+          <a:p>
+            <a:pPr indent="0" marL="0">
+              <a:buNone/>
+            </a:pPr>
+            <a:r>
+              <a:rPr lang="en-US" sz="1050" dirty="0">
                 <a:solidFill>
                   <a:srgbClr val="111111"/>
                 </a:solidFill>
-                <a:latin typeface="Courier New" pitchFamily="34" charset="0"/>
-                <a:ea typeface="Courier New" pitchFamily="34" charset="-122"/>
-                <a:cs typeface="Courier New" pitchFamily="34" charset="-120"/>
-              </a:rPr>
-              <a:t>  Δ(aux(q,i,n-1), o_n)      = δ(q,i)          (original Mealy target)</a:t>
-            </a:r>
-            <a:endParaRPr lang="en-US" sz="900" dirty="0"/>
-          </a:p>
-          <a:p>
-            <a:pPr indent="0" marL="0">
-              <a:buNone/>
-            </a:pPr>
-            <a:endParaRPr lang="en-US" sz="900" dirty="0"/>
-          </a:p>
-          <a:p>
-            <a:pPr indent="0" marL="0">
-              <a:buNone/>
-            </a:pPr>
-            <a:r>
-              <a:rPr lang="en-US" sz="900" dirty="0">
+              </a:rPr>
+              <a:t>q₀  (initial state)</a:t>
+            </a:r>
+            <a:endParaRPr lang="en-US" sz="1050" dirty="0"/>
+          </a:p>
+        </p:txBody>
+      </p:sp>
+      <p:sp>
+        <p:nvSpPr>
+          <p:cNvPr id="20" name="Shape 18"/>
+          <p:cNvSpPr/>
+          <p:nvPr/>
+        </p:nvSpPr>
+        <p:spPr>
+          <a:xfrm>
+            <a:off x="3877056" y="2560320"/>
+            <a:ext cx="365760" cy="0"/>
+          </a:xfrm>
+          <a:prstGeom prst="line">
+            <a:avLst/>
+          </a:prstGeom>
+          <a:noFill/>
+          <a:ln w="12700">
+            <a:solidFill>
+              <a:srgbClr val="888888"/>
+            </a:solidFill>
+            <a:prstDash val="solid"/>
+            <a:tailEnd type="arrow"/>
+          </a:ln>
+        </p:spPr>
+      </p:sp>
+      <p:sp>
+        <p:nvSpPr>
+          <p:cNvPr id="21" name="Shape 19"/>
+          <p:cNvSpPr/>
+          <p:nvPr/>
+        </p:nvSpPr>
+        <p:spPr>
+          <a:xfrm>
+            <a:off x="4370832" y="2340864"/>
+            <a:ext cx="4407408" cy="438912"/>
+          </a:xfrm>
+          <a:prstGeom prst="rect">
+            <a:avLst/>
+          </a:prstGeom>
+          <a:solidFill>
+            <a:srgbClr val="EBEBEB"/>
+          </a:solidFill>
+          <a:ln w="12700">
+            <a:solidFill>
+              <a:srgbClr val="CCCCCC"/>
+            </a:solidFill>
+            <a:prstDash val="solid"/>
+          </a:ln>
+        </p:spPr>
+      </p:sp>
+      <p:sp>
+        <p:nvSpPr>
+          <p:cNvPr id="22" name="Text 20"/>
+          <p:cNvSpPr/>
+          <p:nvPr/>
+        </p:nvSpPr>
+        <p:spPr>
+          <a:xfrm>
+            <a:off x="4480560" y="2395728"/>
+            <a:ext cx="4187952" cy="329184"/>
+          </a:xfrm>
+          <a:prstGeom prst="rect">
+            <a:avLst/>
+          </a:prstGeom>
+          <a:noFill/>
+          <a:ln/>
+        </p:spPr>
+        <p:txBody>
+          <a:bodyPr wrap="square" rtlCol="0" anchor="ctr"/>
+          <a:lstStyle/>
+          <a:p>
+            <a:pPr indent="0" marL="0">
+              <a:buNone/>
+            </a:pPr>
+            <a:r>
+              <a:rPr lang="en-US" sz="1050" dirty="0">
                 <a:solidFill>
                   <a:srgbClr val="111111"/>
                 </a:solidFill>
-                <a:latin typeface="Courier New" pitchFamily="34" charset="0"/>
-                <a:ea typeface="Courier New" pitchFamily="34" charset="-122"/>
-                <a:cs typeface="Courier New" pitchFamily="34" charset="-120"/>
-              </a:rPr>
-              <a:t>For each (q, i) with λ(q,i) = ε (empty output):</a:t>
-            </a:r>
-            <a:endParaRPr lang="en-US" sz="900" dirty="0"/>
-          </a:p>
-          <a:p>
-            <a:pPr indent="0" marL="0">
-              <a:buNone/>
-            </a:pPr>
-            <a:r>
-              <a:rPr lang="en-US" sz="900" dirty="0">
-                <a:solidFill>
-                  <a:srgbClr val="111111"/>
-                </a:solidFill>
-                <a:latin typeface="Courier New" pitchFamily="34" charset="0"/>
-                <a:ea typeface="Courier New" pitchFamily="34" charset="-122"/>
-                <a:cs typeface="Courier New" pitchFamily="34" charset="-120"/>
-              </a:rPr>
-              <a:t>  Δ(q, i)  =  δ(q,i)            (direct transition)</a:t>
-            </a:r>
-            <a:endParaRPr lang="en-US" sz="900" dirty="0"/>
-          </a:p>
-          <a:p>
-            <a:pPr indent="0" marL="0">
-              <a:buNone/>
-            </a:pPr>
-            <a:endParaRPr lang="en-US" sz="900" dirty="0"/>
-          </a:p>
-          <a:p>
-            <a:pPr indent="0" marL="0">
-              <a:buNone/>
-            </a:pPr>
-            <a:r>
-              <a:rPr lang="en-US" sz="900" dirty="0">
-                <a:solidFill>
-                  <a:srgbClr val="111111"/>
-                </a:solidFill>
-                <a:latin typeface="Courier New" pitchFamily="34" charset="0"/>
-                <a:ea typeface="Courier New" pitchFamily="34" charset="-122"/>
-                <a:cs typeface="Courier New" pitchFamily="34" charset="-120"/>
-              </a:rPr>
-              <a:t>Accepting states F_M = Q  (all original Mealy states)</a:t>
-            </a:r>
-            <a:endParaRPr lang="en-US" sz="900" dirty="0"/>
-          </a:p>
-          <a:p>
-            <a:pPr indent="0" marL="0">
-              <a:buNone/>
-            </a:pPr>
-            <a:r>
-              <a:rPr lang="en-US" sz="900" dirty="0">
-                <a:solidFill>
-                  <a:srgbClr val="111111"/>
-                </a:solidFill>
-                <a:latin typeface="Courier New" pitchFamily="34" charset="0"/>
-                <a:ea typeface="Courier New" pitchFamily="34" charset="-122"/>
-                <a:cs typeface="Courier New" pitchFamily="34" charset="-120"/>
-              </a:rPr>
-              <a:t>Undefined transitions → SINK (non-accepting)</a:t>
-            </a:r>
-            <a:endParaRPr lang="en-US" sz="900" dirty="0"/>
-          </a:p>
-        </p:txBody>
-      </p:sp>
-      <p:sp>
-        <p:nvSpPr>
-          <p:cNvPr id="8" name="Shape 6"/>
-          <p:cNvSpPr/>
-          <p:nvPr/>
-        </p:nvSpPr>
-        <p:spPr>
-          <a:xfrm>
-            <a:off x="5760720" y="1389888"/>
-            <a:ext cx="3108960" cy="2743200"/>
+              </a:rPr>
+              <a:t>q₀  (unchanged)</a:t>
+            </a:r>
+            <a:endParaRPr lang="en-US" sz="1050" dirty="0"/>
+          </a:p>
+        </p:txBody>
+      </p:sp>
+      <p:sp>
+        <p:nvSpPr>
+          <p:cNvPr id="23" name="Shape 21"/>
+          <p:cNvSpPr/>
+          <p:nvPr/>
+        </p:nvSpPr>
+        <p:spPr>
+          <a:xfrm>
+            <a:off x="274320" y="2816352"/>
+            <a:ext cx="3566160" cy="438912"/>
           </a:xfrm>
           <a:prstGeom prst="rect">
             <a:avLst/>
@@ -7720,14 +9556,14 @@
       </p:sp>
       <p:sp>
         <p:nvSpPr>
-          <p:cNvPr id="9" name="Text 7"/>
-          <p:cNvSpPr/>
-          <p:nvPr/>
-        </p:nvSpPr>
-        <p:spPr>
-          <a:xfrm>
-            <a:off x="5870448" y="1444752"/>
-            <a:ext cx="2889504" cy="274320"/>
+          <p:cNvPr id="24" name="Text 22"/>
+          <p:cNvSpPr/>
+          <p:nvPr/>
+        </p:nvSpPr>
+        <p:spPr>
+          <a:xfrm>
+            <a:off x="384048" y="2871216"/>
+            <a:ext cx="3346704" cy="329184"/>
           </a:xfrm>
           <a:prstGeom prst="rect">
             <a:avLst/>
@@ -7743,148 +9579,469 @@
               <a:buNone/>
             </a:pPr>
             <a:r>
-              <a:rPr lang="en-US" sz="1200" b="1" dirty="0">
+              <a:rPr lang="en-US" sz="1050" dirty="0">
                 <a:solidFill>
                   <a:srgbClr val="111111"/>
                 </a:solidFill>
               </a:rPr>
-              <a:t>Key Properties</a:t>
-            </a:r>
-            <a:endParaRPr lang="en-US" sz="1200" dirty="0"/>
-          </a:p>
-        </p:txBody>
-      </p:sp>
-      <p:sp>
-        <p:nvSpPr>
-          <p:cNvPr id="10" name="Text 8"/>
-          <p:cNvSpPr/>
-          <p:nvPr/>
-        </p:nvSpPr>
-        <p:spPr>
-          <a:xfrm>
-            <a:off x="5870448" y="1810512"/>
-            <a:ext cx="2889504" cy="2194560"/>
-          </a:xfrm>
-          <a:prstGeom prst="rect">
-            <a:avLst/>
-          </a:prstGeom>
-          <a:noFill/>
-          <a:ln/>
-        </p:spPr>
-        <p:txBody>
-          <a:bodyPr wrap="square" rtlCol="0" anchor="t"/>
-          <a:lstStyle/>
-          <a:p>
-            <a:pPr indent="0" marL="0">
-              <a:spcAft>
-                <a:spcPts val="500"/>
-              </a:spcAft>
-              <a:buNone/>
-            </a:pPr>
-            <a:r>
-              <a:rPr lang="en-US" sz="1100" dirty="0">
+              <a:t>δ : Q × I → Q  (transitions)</a:t>
+            </a:r>
+            <a:endParaRPr lang="en-US" sz="1050" dirty="0"/>
+          </a:p>
+        </p:txBody>
+      </p:sp>
+      <p:sp>
+        <p:nvSpPr>
+          <p:cNvPr id="25" name="Shape 23"/>
+          <p:cNvSpPr/>
+          <p:nvPr/>
+        </p:nvSpPr>
+        <p:spPr>
+          <a:xfrm>
+            <a:off x="3877056" y="3035808"/>
+            <a:ext cx="365760" cy="0"/>
+          </a:xfrm>
+          <a:prstGeom prst="line">
+            <a:avLst/>
+          </a:prstGeom>
+          <a:noFill/>
+          <a:ln w="12700">
+            <a:solidFill>
+              <a:srgbClr val="888888"/>
+            </a:solidFill>
+            <a:prstDash val="solid"/>
+            <a:tailEnd type="arrow"/>
+          </a:ln>
+        </p:spPr>
+      </p:sp>
+      <p:sp>
+        <p:nvSpPr>
+          <p:cNvPr id="26" name="Shape 24"/>
+          <p:cNvSpPr/>
+          <p:nvPr/>
+        </p:nvSpPr>
+        <p:spPr>
+          <a:xfrm>
+            <a:off x="4370832" y="2816352"/>
+            <a:ext cx="4407408" cy="438912"/>
+          </a:xfrm>
+          <a:prstGeom prst="rect">
+            <a:avLst/>
+          </a:prstGeom>
+          <a:solidFill>
+            <a:srgbClr val="E0E0E0"/>
+          </a:solidFill>
+          <a:ln w="12700">
+            <a:solidFill>
+              <a:srgbClr val="CCCCCC"/>
+            </a:solidFill>
+            <a:prstDash val="solid"/>
+          </a:ln>
+        </p:spPr>
+      </p:sp>
+      <p:sp>
+        <p:nvSpPr>
+          <p:cNvPr id="27" name="Text 25"/>
+          <p:cNvSpPr/>
+          <p:nvPr/>
+        </p:nvSpPr>
+        <p:spPr>
+          <a:xfrm>
+            <a:off x="4480560" y="2871216"/>
+            <a:ext cx="4187952" cy="329184"/>
+          </a:xfrm>
+          <a:prstGeom prst="rect">
+            <a:avLst/>
+          </a:prstGeom>
+          <a:noFill/>
+          <a:ln/>
+        </p:spPr>
+        <p:txBody>
+          <a:bodyPr wrap="square" rtlCol="0" anchor="ctr"/>
+          <a:lstStyle/>
+          <a:p>
+            <a:pPr indent="0" marL="0">
+              <a:buNone/>
+            </a:pPr>
+            <a:r>
+              <a:rPr lang="en-US" sz="1050" dirty="0">
                 <a:solidFill>
                   <a:srgbClr val="111111"/>
                 </a:solidFill>
               </a:rPr>
-              <a:t>L(A_M) = all valid I/O traces of M</a:t>
-            </a:r>
-            <a:pPr indent="0" marL="0">
-              <a:spcAft>
-                <a:spcPts val="500"/>
-              </a:spcAft>
-              <a:buNone/>
-            </a:pPr>
-            <a:r>
-              <a:rPr lang="en-US" sz="1100" dirty="0">
+              <a:t>Δ encodes target state at end of Q_aux chain</a:t>
+            </a:r>
+            <a:endParaRPr lang="en-US" sz="1050" dirty="0"/>
+          </a:p>
+        </p:txBody>
+      </p:sp>
+      <p:sp>
+        <p:nvSpPr>
+          <p:cNvPr id="28" name="Shape 26"/>
+          <p:cNvSpPr/>
+          <p:nvPr/>
+        </p:nvSpPr>
+        <p:spPr>
+          <a:xfrm>
+            <a:off x="274320" y="3291840"/>
+            <a:ext cx="3566160" cy="438912"/>
+          </a:xfrm>
+          <a:prstGeom prst="rect">
+            <a:avLst/>
+          </a:prstGeom>
+          <a:solidFill>
+            <a:srgbClr val="E0E0E0"/>
+          </a:solidFill>
+          <a:ln w="12700">
+            <a:solidFill>
+              <a:srgbClr val="CCCCCC"/>
+            </a:solidFill>
+            <a:prstDash val="solid"/>
+          </a:ln>
+        </p:spPr>
+      </p:sp>
+      <p:sp>
+        <p:nvSpPr>
+          <p:cNvPr id="29" name="Text 27"/>
+          <p:cNvSpPr/>
+          <p:nvPr/>
+        </p:nvSpPr>
+        <p:spPr>
+          <a:xfrm>
+            <a:off x="384048" y="3346704"/>
+            <a:ext cx="3346704" cy="329184"/>
+          </a:xfrm>
+          <a:prstGeom prst="rect">
+            <a:avLst/>
+          </a:prstGeom>
+          <a:noFill/>
+          <a:ln/>
+        </p:spPr>
+        <p:txBody>
+          <a:bodyPr wrap="square" rtlCol="0" anchor="ctr"/>
+          <a:lstStyle/>
+          <a:p>
+            <a:pPr indent="0" marL="0">
+              <a:buNone/>
+            </a:pPr>
+            <a:r>
+              <a:rPr lang="en-US" sz="1050" dirty="0">
                 <a:solidFill>
                   <a:srgbClr val="111111"/>
                 </a:solidFill>
               </a:rPr>
-              <a:t>Multi-output transitions become chains of auxiliary states</a:t>
-            </a:r>
-            <a:pPr indent="0" marL="0">
-              <a:spcAft>
-                <a:spcPts val="500"/>
-              </a:spcAft>
-              <a:buNone/>
-            </a:pPr>
-            <a:r>
-              <a:rPr lang="en-US" sz="1100" dirty="0">
+              <a:t>λ : Q × I → O*  (output fn)</a:t>
+            </a:r>
+            <a:endParaRPr lang="en-US" sz="1050" dirty="0"/>
+          </a:p>
+        </p:txBody>
+      </p:sp>
+      <p:sp>
+        <p:nvSpPr>
+          <p:cNvPr id="30" name="Shape 28"/>
+          <p:cNvSpPr/>
+          <p:nvPr/>
+        </p:nvSpPr>
+        <p:spPr>
+          <a:xfrm>
+            <a:off x="3877056" y="3511296"/>
+            <a:ext cx="365760" cy="0"/>
+          </a:xfrm>
+          <a:prstGeom prst="line">
+            <a:avLst/>
+          </a:prstGeom>
+          <a:noFill/>
+          <a:ln w="12700">
+            <a:solidFill>
+              <a:srgbClr val="888888"/>
+            </a:solidFill>
+            <a:prstDash val="solid"/>
+            <a:tailEnd type="arrow"/>
+          </a:ln>
+        </p:spPr>
+      </p:sp>
+      <p:sp>
+        <p:nvSpPr>
+          <p:cNvPr id="31" name="Shape 29"/>
+          <p:cNvSpPr/>
+          <p:nvPr/>
+        </p:nvSpPr>
+        <p:spPr>
+          <a:xfrm>
+            <a:off x="4370832" y="3291840"/>
+            <a:ext cx="4407408" cy="438912"/>
+          </a:xfrm>
+          <a:prstGeom prst="rect">
+            <a:avLst/>
+          </a:prstGeom>
+          <a:solidFill>
+            <a:srgbClr val="E0E0E0"/>
+          </a:solidFill>
+          <a:ln w="12700">
+            <a:solidFill>
+              <a:srgbClr val="CCCCCC"/>
+            </a:solidFill>
+            <a:prstDash val="solid"/>
+          </a:ln>
+        </p:spPr>
+      </p:sp>
+      <p:sp>
+        <p:nvSpPr>
+          <p:cNvPr id="32" name="Text 30"/>
+          <p:cNvSpPr/>
+          <p:nvPr/>
+        </p:nvSpPr>
+        <p:spPr>
+          <a:xfrm>
+            <a:off x="4480560" y="3346704"/>
+            <a:ext cx="4187952" cy="329184"/>
+          </a:xfrm>
+          <a:prstGeom prst="rect">
+            <a:avLst/>
+          </a:prstGeom>
+          <a:noFill/>
+          <a:ln/>
+        </p:spPr>
+        <p:txBody>
+          <a:bodyPr wrap="square" rtlCol="0" anchor="ctr"/>
+          <a:lstStyle/>
+          <a:p>
+            <a:pPr indent="0" marL="0">
+              <a:buNone/>
+            </a:pPr>
+            <a:r>
+              <a:rPr lang="en-US" sz="1050" dirty="0">
                 <a:solidFill>
                   <a:srgbClr val="111111"/>
                 </a:solidFill>
               </a:rPr>
-              <a:t>All original Mealy states are accepting</a:t>
-            </a:r>
-            <a:pPr indent="0" marL="0">
-              <a:spcAft>
-                <a:spcPts val="500"/>
-              </a:spcAft>
-              <a:buNone/>
-            </a:pPr>
-            <a:r>
-              <a:rPr lang="en-US" sz="1100" dirty="0">
+              <a:t>Each output symbol = one auxiliary-state step</a:t>
+            </a:r>
+            <a:endParaRPr lang="en-US" sz="1050" dirty="0"/>
+          </a:p>
+        </p:txBody>
+      </p:sp>
+      <p:sp>
+        <p:nvSpPr>
+          <p:cNvPr id="33" name="Shape 31"/>
+          <p:cNvSpPr/>
+          <p:nvPr/>
+        </p:nvSpPr>
+        <p:spPr>
+          <a:xfrm>
+            <a:off x="274320" y="3767328"/>
+            <a:ext cx="3566160" cy="438912"/>
+          </a:xfrm>
+          <a:prstGeom prst="rect">
+            <a:avLst/>
+          </a:prstGeom>
+          <a:solidFill>
+            <a:srgbClr val="EBEBEB"/>
+          </a:solidFill>
+          <a:ln w="12700">
+            <a:solidFill>
+              <a:srgbClr val="CCCCCC"/>
+            </a:solidFill>
+            <a:prstDash val="solid"/>
+          </a:ln>
+        </p:spPr>
+      </p:sp>
+      <p:sp>
+        <p:nvSpPr>
+          <p:cNvPr id="34" name="Text 32"/>
+          <p:cNvSpPr/>
+          <p:nvPr/>
+        </p:nvSpPr>
+        <p:spPr>
+          <a:xfrm>
+            <a:off x="384048" y="3822192"/>
+            <a:ext cx="3346704" cy="329184"/>
+          </a:xfrm>
+          <a:prstGeom prst="rect">
+            <a:avLst/>
+          </a:prstGeom>
+          <a:noFill/>
+          <a:ln/>
+        </p:spPr>
+        <p:txBody>
+          <a:bodyPr wrap="square" rtlCol="0" anchor="ctr"/>
+          <a:lstStyle/>
+          <a:p>
+            <a:pPr indent="0" marL="0">
+              <a:buNone/>
+            </a:pPr>
+            <a:r>
+              <a:rPr lang="en-US" sz="1050" dirty="0">
                 <a:solidFill>
                   <a:srgbClr val="111111"/>
                 </a:solidFill>
               </a:rPr>
-              <a:t>Undefined (state, input) pairs map to SINK</a:t>
-            </a:r>
-            <a:pPr indent="0" marL="0">
-              <a:buNone/>
-            </a:pPr>
-            <a:r>
-              <a:rPr lang="en-US" sz="1100" i="1" dirty="0">
+              <a:t>(none — Mealy has no accepting concept)</a:t>
+            </a:r>
+            <a:endParaRPr lang="en-US" sz="1050" dirty="0"/>
+          </a:p>
+        </p:txBody>
+      </p:sp>
+      <p:sp>
+        <p:nvSpPr>
+          <p:cNvPr id="35" name="Shape 33"/>
+          <p:cNvSpPr/>
+          <p:nvPr/>
+        </p:nvSpPr>
+        <p:spPr>
+          <a:xfrm>
+            <a:off x="3877056" y="3986784"/>
+            <a:ext cx="365760" cy="0"/>
+          </a:xfrm>
+          <a:prstGeom prst="line">
+            <a:avLst/>
+          </a:prstGeom>
+          <a:noFill/>
+          <a:ln w="12700">
+            <a:solidFill>
+              <a:srgbClr val="888888"/>
+            </a:solidFill>
+            <a:prstDash val="solid"/>
+            <a:tailEnd type="arrow"/>
+          </a:ln>
+        </p:spPr>
+      </p:sp>
+      <p:sp>
+        <p:nvSpPr>
+          <p:cNvPr id="36" name="Shape 34"/>
+          <p:cNvSpPr/>
+          <p:nvPr/>
+        </p:nvSpPr>
+        <p:spPr>
+          <a:xfrm>
+            <a:off x="4370832" y="3767328"/>
+            <a:ext cx="4407408" cy="438912"/>
+          </a:xfrm>
+          <a:prstGeom prst="rect">
+            <a:avLst/>
+          </a:prstGeom>
+          <a:solidFill>
+            <a:srgbClr val="EBEBEB"/>
+          </a:solidFill>
+          <a:ln w="12700">
+            <a:solidFill>
+              <a:srgbClr val="CCCCCC"/>
+            </a:solidFill>
+            <a:prstDash val="solid"/>
+          </a:ln>
+        </p:spPr>
+      </p:sp>
+      <p:sp>
+        <p:nvSpPr>
+          <p:cNvPr id="37" name="Text 35"/>
+          <p:cNvSpPr/>
+          <p:nvPr/>
+        </p:nvSpPr>
+        <p:spPr>
+          <a:xfrm>
+            <a:off x="4480560" y="3822192"/>
+            <a:ext cx="4187952" cy="329184"/>
+          </a:xfrm>
+          <a:prstGeom prst="rect">
+            <a:avLst/>
+          </a:prstGeom>
+          <a:noFill/>
+          <a:ln/>
+        </p:spPr>
+        <p:txBody>
+          <a:bodyPr wrap="square" rtlCol="0" anchor="ctr"/>
+          <a:lstStyle/>
+          <a:p>
+            <a:pPr indent="0" marL="0">
+              <a:buNone/>
+            </a:pPr>
+            <a:r>
+              <a:rPr lang="en-US" sz="1050" dirty="0">
+                <a:solidFill>
+                  <a:srgbClr val="111111"/>
+                </a:solidFill>
+              </a:rPr>
+              <a:t>F = Q  (all original Mealy states accepting)</a:t>
+            </a:r>
+            <a:endParaRPr lang="en-US" sz="1050" dirty="0"/>
+          </a:p>
+        </p:txBody>
+      </p:sp>
+      <p:sp>
+        <p:nvSpPr>
+          <p:cNvPr id="38" name="Text 36"/>
+          <p:cNvSpPr/>
+          <p:nvPr/>
+        </p:nvSpPr>
+        <p:spPr>
+          <a:xfrm>
+            <a:off x="365760" y="4334256"/>
+            <a:ext cx="8412480" cy="256032"/>
+          </a:xfrm>
+          <a:prstGeom prst="rect">
+            <a:avLst/>
+          </a:prstGeom>
+          <a:noFill/>
+          <a:ln/>
+        </p:spPr>
+        <p:txBody>
+          <a:bodyPr wrap="square" rtlCol="0" anchor="ctr"/>
+          <a:lstStyle/>
+          <a:p>
+            <a:pPr indent="0" marL="0">
+              <a:buNone/>
+            </a:pPr>
+            <a:r>
+              <a:rPr lang="en-US" sz="1000" dirty="0">
+                <a:solidFill>
+                  <a:srgbClr val="1A1A1A"/>
+                </a:solidFill>
+              </a:rPr>
+              <a:t>Chain example: (q, i) with output o₁ o₂ →  q →[i]→ aux₁ →[o₁]→ aux₂ →[o₂]→ q'   (q, q’ ∈ F;  aux states not in F)</a:t>
+            </a:r>
+            <a:endParaRPr lang="en-US" sz="1000" dirty="0"/>
+          </a:p>
+        </p:txBody>
+      </p:sp>
+      <p:sp>
+        <p:nvSpPr>
+          <p:cNvPr id="39" name="Text 37"/>
+          <p:cNvSpPr/>
+          <p:nvPr/>
+        </p:nvSpPr>
+        <p:spPr>
+          <a:xfrm>
+            <a:off x="365760" y="4636008"/>
+            <a:ext cx="8412480" cy="201168"/>
+          </a:xfrm>
+          <a:prstGeom prst="rect">
+            <a:avLst/>
+          </a:prstGeom>
+          <a:noFill/>
+          <a:ln/>
+        </p:spPr>
+        <p:txBody>
+          <a:bodyPr wrap="square" rtlCol="0" anchor="ctr"/>
+          <a:lstStyle/>
+          <a:p>
+            <a:pPr indent="0" marL="0">
+              <a:buNone/>
+            </a:pPr>
+            <a:r>
+              <a:rPr lang="en-US" sz="950" i="1" dirty="0">
                 <a:solidFill>
                   <a:srgbClr val="888888"/>
                 </a:solidFill>
               </a:rPr>
-              <a:t>|A_M| grows linearly with output lengths</a:t>
-            </a:r>
-            <a:endParaRPr lang="en-US" sz="1100" dirty="0"/>
-          </a:p>
-        </p:txBody>
-      </p:sp>
-      <p:sp>
-        <p:nvSpPr>
-          <p:cNvPr id="11" name="Text 9"/>
-          <p:cNvSpPr/>
-          <p:nvPr/>
-        </p:nvSpPr>
-        <p:spPr>
-          <a:xfrm>
-            <a:off x="365760" y="4224528"/>
-            <a:ext cx="8412480" cy="256032"/>
-          </a:xfrm>
-          <a:prstGeom prst="rect">
-            <a:avLst/>
-          </a:prstGeom>
-          <a:noFill/>
-          <a:ln/>
-        </p:spPr>
-        <p:txBody>
-          <a:bodyPr wrap="square" rtlCol="0" anchor="ctr"/>
-          <a:lstStyle/>
-          <a:p>
-            <a:pPr indent="0" marL="0">
-              <a:buNone/>
-            </a:pPr>
-            <a:r>
-              <a:rPr lang="en-US" sz="1000" i="1" dirty="0">
-                <a:solidFill>
-                  <a:srgbClr val="888888"/>
-                </a:solidFill>
-              </a:rPr>
               <a:t>Replication: |A_M| = 71–87 states for our mock DTLS models</a:t>
             </a:r>
-            <a:endParaRPr lang="en-US" sz="1000" dirty="0"/>
-          </a:p>
-        </p:txBody>
-      </p:sp>
-      <p:sp>
-        <p:nvSpPr>
-          <p:cNvPr id="12" name="Text 10"/>
+            <a:endParaRPr lang="en-US" sz="950" dirty="0"/>
+          </a:p>
+        </p:txBody>
+      </p:sp>
+      <p:sp>
+        <p:nvSpPr>
+          <p:cNvPr id="40" name="Text 38"/>
           <p:cNvSpPr/>
           <p:nvPr/>
         </p:nvSpPr>
@@ -8023,7 +10180,7 @@
                   <a:srgbClr val="FFFFFF"/>
                 </a:solidFill>
               </a:rPr>
-              <a:t>DFA Intersection: A∩ = Aᵀ ∩ Aᵥ (Section IV)</a:t>
+              <a:t>DFA Intersection: A∩ = A_M ∩ A_bug (Section IV)</a:t>
             </a:r>
             <a:endParaRPr lang="en-US" sz="2100" dirty="0"/>
           </a:p>

</xml_diff>

<commit_message>
Fix corrupt PPTX and subscript rendering
Fixes two issues:
- Arc helper functions (dfaArcAbove/Below) used negative w/h values,
  producing invalid OOXML cx/cy that PowerPoint refused to open.
  Rewritten to use right-angle staircase geometry with all-positive
  dimensions; beginArrowType used for below-arc arrowhead direction.
- Headers and card titles with A_M / A_bug shown as literal underscores.
  Converted to pptxgenjs rich-text arrays with subScript:true on the
  subscript runs (M, bug) across slide 5 card title, slides 6 and 7
  headerBands, column header, intro text, replication note, and results
  key-stat list. Underscore notation kept only in codeBox pseudocode.
</commit_message>
<xml_diff>
--- a/slides/presentation.pptx
+++ b/slides/presentation.pptx
@@ -2418,6 +2418,28 @@
               <a:t>1–4 ms  (matches “within seconds”)</a:t>
             </a:r>
             <a:pPr indent="0" marL="0">
+              <a:buNone/>
+            </a:pPr>
+            <a:r>
+              <a:rPr lang="en-US" sz="1100" dirty="0">
+                <a:solidFill>
+                  <a:srgbClr val="111111"/>
+                </a:solidFill>
+              </a:rPr>
+              <a:t>|A</a:t>
+            </a:r>
+            <a:pPr indent="0" marL="0">
+              <a:buNone/>
+            </a:pPr>
+            <a:r>
+              <a:rPr lang="en-US" sz="800" dirty="0">
+                <a:solidFill>
+                  <a:srgbClr val="111111"/>
+                </a:solidFill>
+              </a:rPr>
+              <a:t>M</a:t>
+            </a:r>
+            <a:pPr indent="0" marL="0">
               <a:spcAft>
                 <a:spcPts val="300"/>
               </a:spcAft>
@@ -2429,7 +2451,7 @@
                   <a:srgbClr val="111111"/>
                 </a:solidFill>
               </a:rPr>
-              <a:t>|A_M| = 71–87 states</a:t>
+              <a:t>| = 71–87 states</a:t>
             </a:r>
             <a:pPr indent="0" marL="0">
               <a:spcAft>
@@ -7029,7 +7051,18 @@
                   <a:srgbClr val="111111"/>
                 </a:solidFill>
               </a:rPr>
-              <a:t>Bug Pattern DFA  A_bug</a:t>
+              <a:t>Bug Pattern DFA  A</a:t>
+            </a:r>
+            <a:pPr indent="0" marL="0">
+              <a:buNone/>
+            </a:pPr>
+            <a:r>
+              <a:rPr lang="en-US" sz="1000" b="1" dirty="0">
+                <a:solidFill>
+                  <a:srgbClr val="111111"/>
+                </a:solidFill>
+              </a:rPr>
+              <a:t>bug</a:t>
             </a:r>
             <a:endParaRPr lang="en-US" sz="1350" dirty="0"/>
           </a:p>
@@ -7651,8 +7684,8 @@
         </p:nvSpPr>
         <p:spPr>
           <a:xfrm>
-            <a:off x="1536192" y="3854196"/>
-            <a:ext cx="-434340" cy="-452628"/>
+            <a:off x="1536192" y="3401568"/>
+            <a:ext cx="9144" cy="452628"/>
           </a:xfrm>
           <a:prstGeom prst="line">
             <a:avLst/>
@@ -7674,8 +7707,31 @@
         </p:nvSpPr>
         <p:spPr>
           <a:xfrm>
-            <a:off x="1101852" y="3401568"/>
-            <a:ext cx="-434340" cy="452628"/>
+            <a:off x="667512" y="3401568"/>
+            <a:ext cx="868680" cy="9144"/>
+          </a:xfrm>
+          <a:prstGeom prst="line">
+            <a:avLst/>
+          </a:prstGeom>
+          <a:noFill/>
+          <a:ln w="12700">
+            <a:solidFill>
+              <a:srgbClr val="1A1A1A"/>
+            </a:solidFill>
+            <a:prstDash val="solid"/>
+          </a:ln>
+        </p:spPr>
+      </p:sp>
+      <p:sp>
+        <p:nvSpPr>
+          <p:cNvPr id="32" name="Shape 30"/>
+          <p:cNvSpPr/>
+          <p:nvPr/>
+        </p:nvSpPr>
+        <p:spPr>
+          <a:xfrm>
+            <a:off x="667512" y="3401568"/>
+            <a:ext cx="9144" cy="452628"/>
           </a:xfrm>
           <a:prstGeom prst="line">
             <a:avLst/>
@@ -7692,7 +7748,7 @@
       </p:sp>
       <p:sp>
         <p:nvSpPr>
-          <p:cNvPr id="32" name="Text 30"/>
+          <p:cNvPr id="33" name="Text 31"/>
           <p:cNvSpPr/>
           <p:nvPr/>
         </p:nvSpPr>
@@ -7728,7 +7784,7 @@
       </p:sp>
       <p:sp>
         <p:nvSpPr>
-          <p:cNvPr id="33" name="Shape 31"/>
+          <p:cNvPr id="34" name="Shape 32"/>
           <p:cNvSpPr/>
           <p:nvPr/>
         </p:nvSpPr>
@@ -7753,7 +7809,7 @@
       </p:sp>
       <p:sp>
         <p:nvSpPr>
-          <p:cNvPr id="34" name="Text 32"/>
+          <p:cNvPr id="35" name="Text 33"/>
           <p:cNvSpPr/>
           <p:nvPr/>
         </p:nvSpPr>
@@ -7789,7 +7845,7 @@
       </p:sp>
       <p:sp>
         <p:nvSpPr>
-          <p:cNvPr id="35" name="Shape 33"/>
+          <p:cNvPr id="36" name="Shape 34"/>
           <p:cNvSpPr/>
           <p:nvPr/>
         </p:nvSpPr>
@@ -7814,7 +7870,7 @@
       </p:sp>
       <p:sp>
         <p:nvSpPr>
-          <p:cNvPr id="36" name="Text 34"/>
+          <p:cNvPr id="37" name="Text 35"/>
           <p:cNvSpPr/>
           <p:nvPr/>
         </p:nvSpPr>
@@ -7850,7 +7906,7 @@
       </p:sp>
       <p:sp>
         <p:nvSpPr>
-          <p:cNvPr id="37" name="Shape 35"/>
+          <p:cNvPr id="38" name="Shape 36"/>
           <p:cNvSpPr/>
           <p:nvPr/>
         </p:nvSpPr>
@@ -7875,7 +7931,7 @@
       </p:sp>
       <p:sp>
         <p:nvSpPr>
-          <p:cNvPr id="38" name="Shape 36"/>
+          <p:cNvPr id="39" name="Shape 37"/>
           <p:cNvSpPr/>
           <p:nvPr/>
         </p:nvSpPr>
@@ -7900,7 +7956,7 @@
       </p:sp>
       <p:sp>
         <p:nvSpPr>
-          <p:cNvPr id="39" name="Text 37"/>
+          <p:cNvPr id="40" name="Text 38"/>
           <p:cNvSpPr/>
           <p:nvPr/>
         </p:nvSpPr>
@@ -7936,7 +7992,7 @@
       </p:sp>
       <p:sp>
         <p:nvSpPr>
-          <p:cNvPr id="40" name="Shape 38"/>
+          <p:cNvPr id="41" name="Shape 39"/>
           <p:cNvSpPr/>
           <p:nvPr/>
         </p:nvSpPr>
@@ -7960,7 +8016,7 @@
       </p:sp>
       <p:sp>
         <p:nvSpPr>
-          <p:cNvPr id="41" name="Shape 39"/>
+          <p:cNvPr id="42" name="Shape 40"/>
           <p:cNvSpPr/>
           <p:nvPr/>
         </p:nvSpPr>
@@ -7984,7 +8040,7 @@
       </p:sp>
       <p:sp>
         <p:nvSpPr>
-          <p:cNvPr id="42" name="Text 40"/>
+          <p:cNvPr id="43" name="Text 41"/>
           <p:cNvSpPr/>
           <p:nvPr/>
         </p:nvSpPr>
@@ -8020,7 +8076,7 @@
       </p:sp>
       <p:sp>
         <p:nvSpPr>
-          <p:cNvPr id="43" name="Shape 41"/>
+          <p:cNvPr id="44" name="Shape 42"/>
           <p:cNvSpPr/>
           <p:nvPr/>
         </p:nvSpPr>
@@ -8044,7 +8100,7 @@
       </p:sp>
       <p:sp>
         <p:nvSpPr>
-          <p:cNvPr id="44" name="Text 42"/>
+          <p:cNvPr id="45" name="Text 43"/>
           <p:cNvSpPr/>
           <p:nvPr/>
         </p:nvSpPr>
@@ -8080,14 +8136,14 @@
       </p:sp>
       <p:sp>
         <p:nvSpPr>
-          <p:cNvPr id="45" name="Shape 43"/>
-          <p:cNvSpPr/>
-          <p:nvPr/>
-        </p:nvSpPr>
-        <p:spPr>
-          <a:xfrm>
-            <a:off x="4599432" y="3854196"/>
-            <a:ext cx="-434340" cy="-452628"/>
+          <p:cNvPr id="46" name="Shape 44"/>
+          <p:cNvSpPr/>
+          <p:nvPr/>
+        </p:nvSpPr>
+        <p:spPr>
+          <a:xfrm>
+            <a:off x="4599432" y="3401568"/>
+            <a:ext cx="9144" cy="452628"/>
           </a:xfrm>
           <a:prstGeom prst="line">
             <a:avLst/>
@@ -8103,14 +8159,37 @@
       </p:sp>
       <p:sp>
         <p:nvSpPr>
-          <p:cNvPr id="46" name="Shape 44"/>
-          <p:cNvSpPr/>
-          <p:nvPr/>
-        </p:nvSpPr>
-        <p:spPr>
-          <a:xfrm>
-            <a:off x="4165092" y="3401568"/>
-            <a:ext cx="-434340" cy="452628"/>
+          <p:cNvPr id="47" name="Shape 45"/>
+          <p:cNvSpPr/>
+          <p:nvPr/>
+        </p:nvSpPr>
+        <p:spPr>
+          <a:xfrm>
+            <a:off x="3730752" y="3401568"/>
+            <a:ext cx="868680" cy="9144"/>
+          </a:xfrm>
+          <a:prstGeom prst="line">
+            <a:avLst/>
+          </a:prstGeom>
+          <a:noFill/>
+          <a:ln w="12700">
+            <a:solidFill>
+              <a:srgbClr val="1A1A1A"/>
+            </a:solidFill>
+            <a:prstDash val="solid"/>
+          </a:ln>
+        </p:spPr>
+      </p:sp>
+      <p:sp>
+        <p:nvSpPr>
+          <p:cNvPr id="48" name="Shape 46"/>
+          <p:cNvSpPr/>
+          <p:nvPr/>
+        </p:nvSpPr>
+        <p:spPr>
+          <a:xfrm>
+            <a:off x="3730752" y="3401568"/>
+            <a:ext cx="9144" cy="452628"/>
           </a:xfrm>
           <a:prstGeom prst="line">
             <a:avLst/>
@@ -8127,7 +8206,7 @@
       </p:sp>
       <p:sp>
         <p:nvSpPr>
-          <p:cNvPr id="47" name="Text 45"/>
+          <p:cNvPr id="49" name="Text 47"/>
           <p:cNvSpPr/>
           <p:nvPr/>
         </p:nvSpPr>
@@ -8163,7 +8242,7 @@
       </p:sp>
       <p:sp>
         <p:nvSpPr>
-          <p:cNvPr id="48" name="Shape 46"/>
+          <p:cNvPr id="50" name="Shape 48"/>
           <p:cNvSpPr/>
           <p:nvPr/>
         </p:nvSpPr>
@@ -8188,7 +8267,7 @@
       </p:sp>
       <p:sp>
         <p:nvSpPr>
-          <p:cNvPr id="49" name="Text 47"/>
+          <p:cNvPr id="51" name="Text 49"/>
           <p:cNvSpPr/>
           <p:nvPr/>
         </p:nvSpPr>
@@ -8224,7 +8303,7 @@
       </p:sp>
       <p:sp>
         <p:nvSpPr>
-          <p:cNvPr id="50" name="Shape 48"/>
+          <p:cNvPr id="52" name="Shape 50"/>
           <p:cNvSpPr/>
           <p:nvPr/>
         </p:nvSpPr>
@@ -8249,7 +8328,7 @@
       </p:sp>
       <p:sp>
         <p:nvSpPr>
-          <p:cNvPr id="51" name="Text 49"/>
+          <p:cNvPr id="53" name="Text 51"/>
           <p:cNvSpPr/>
           <p:nvPr/>
         </p:nvSpPr>
@@ -8285,7 +8364,7 @@
       </p:sp>
       <p:sp>
         <p:nvSpPr>
-          <p:cNvPr id="52" name="Shape 50"/>
+          <p:cNvPr id="54" name="Shape 52"/>
           <p:cNvSpPr/>
           <p:nvPr/>
         </p:nvSpPr>
@@ -8310,7 +8389,7 @@
       </p:sp>
       <p:sp>
         <p:nvSpPr>
-          <p:cNvPr id="53" name="Text 51"/>
+          <p:cNvPr id="55" name="Text 53"/>
           <p:cNvSpPr/>
           <p:nvPr/>
         </p:nvSpPr>
@@ -8346,7 +8425,7 @@
       </p:sp>
       <p:sp>
         <p:nvSpPr>
-          <p:cNvPr id="54" name="Shape 52"/>
+          <p:cNvPr id="56" name="Shape 54"/>
           <p:cNvSpPr/>
           <p:nvPr/>
         </p:nvSpPr>
@@ -8371,7 +8450,7 @@
       </p:sp>
       <p:sp>
         <p:nvSpPr>
-          <p:cNvPr id="55" name="Shape 53"/>
+          <p:cNvPr id="57" name="Shape 55"/>
           <p:cNvSpPr/>
           <p:nvPr/>
         </p:nvSpPr>
@@ -8396,7 +8475,7 @@
       </p:sp>
       <p:sp>
         <p:nvSpPr>
-          <p:cNvPr id="56" name="Text 54"/>
+          <p:cNvPr id="58" name="Text 56"/>
           <p:cNvSpPr/>
           <p:nvPr/>
         </p:nvSpPr>
@@ -8432,7 +8511,7 @@
       </p:sp>
       <p:sp>
         <p:nvSpPr>
-          <p:cNvPr id="57" name="Shape 55"/>
+          <p:cNvPr id="59" name="Shape 57"/>
           <p:cNvSpPr/>
           <p:nvPr/>
         </p:nvSpPr>
@@ -8456,7 +8535,7 @@
       </p:sp>
       <p:sp>
         <p:nvSpPr>
-          <p:cNvPr id="58" name="Shape 56"/>
+          <p:cNvPr id="60" name="Shape 58"/>
           <p:cNvSpPr/>
           <p:nvPr/>
         </p:nvSpPr>
@@ -8480,7 +8559,7 @@
       </p:sp>
       <p:sp>
         <p:nvSpPr>
-          <p:cNvPr id="59" name="Text 57"/>
+          <p:cNvPr id="61" name="Text 59"/>
           <p:cNvSpPr/>
           <p:nvPr/>
         </p:nvSpPr>
@@ -8516,7 +8595,7 @@
       </p:sp>
       <p:sp>
         <p:nvSpPr>
-          <p:cNvPr id="60" name="Shape 58"/>
+          <p:cNvPr id="62" name="Shape 60"/>
           <p:cNvSpPr/>
           <p:nvPr/>
         </p:nvSpPr>
@@ -8540,7 +8619,7 @@
       </p:sp>
       <p:sp>
         <p:nvSpPr>
-          <p:cNvPr id="61" name="Text 59"/>
+          <p:cNvPr id="63" name="Text 61"/>
           <p:cNvSpPr/>
           <p:nvPr/>
         </p:nvSpPr>
@@ -8576,7 +8655,7 @@
       </p:sp>
       <p:sp>
         <p:nvSpPr>
-          <p:cNvPr id="62" name="Shape 60"/>
+          <p:cNvPr id="64" name="Shape 62"/>
           <p:cNvSpPr/>
           <p:nvPr/>
         </p:nvSpPr>
@@ -8600,7 +8679,7 @@
       </p:sp>
       <p:sp>
         <p:nvSpPr>
-          <p:cNvPr id="63" name="Text 61"/>
+          <p:cNvPr id="65" name="Text 63"/>
           <p:cNvSpPr/>
           <p:nvPr/>
         </p:nvSpPr>
@@ -8636,14 +8715,14 @@
       </p:sp>
       <p:sp>
         <p:nvSpPr>
-          <p:cNvPr id="64" name="Shape 62"/>
-          <p:cNvSpPr/>
-          <p:nvPr/>
-        </p:nvSpPr>
-        <p:spPr>
-          <a:xfrm>
-            <a:off x="7269480" y="3854196"/>
-            <a:ext cx="-370332" cy="-516636"/>
+          <p:cNvPr id="66" name="Shape 64"/>
+          <p:cNvSpPr/>
+          <p:nvPr/>
+        </p:nvSpPr>
+        <p:spPr>
+          <a:xfrm>
+            <a:off x="7269480" y="3337560"/>
+            <a:ext cx="9144" cy="516636"/>
           </a:xfrm>
           <a:prstGeom prst="line">
             <a:avLst/>
@@ -8659,14 +8738,37 @@
       </p:sp>
       <p:sp>
         <p:nvSpPr>
-          <p:cNvPr id="65" name="Shape 63"/>
-          <p:cNvSpPr/>
-          <p:nvPr/>
-        </p:nvSpPr>
-        <p:spPr>
-          <a:xfrm>
-            <a:off x="6899148" y="3337560"/>
-            <a:ext cx="-370332" cy="516636"/>
+          <p:cNvPr id="67" name="Shape 65"/>
+          <p:cNvSpPr/>
+          <p:nvPr/>
+        </p:nvSpPr>
+        <p:spPr>
+          <a:xfrm>
+            <a:off x="6528816" y="3337560"/>
+            <a:ext cx="740664" cy="9144"/>
+          </a:xfrm>
+          <a:prstGeom prst="line">
+            <a:avLst/>
+          </a:prstGeom>
+          <a:noFill/>
+          <a:ln w="12700">
+            <a:solidFill>
+              <a:srgbClr val="1A1A1A"/>
+            </a:solidFill>
+            <a:prstDash val="solid"/>
+          </a:ln>
+        </p:spPr>
+      </p:sp>
+      <p:sp>
+        <p:nvSpPr>
+          <p:cNvPr id="68" name="Shape 66"/>
+          <p:cNvSpPr/>
+          <p:nvPr/>
+        </p:nvSpPr>
+        <p:spPr>
+          <a:xfrm>
+            <a:off x="6528816" y="3337560"/>
+            <a:ext cx="9144" cy="516636"/>
           </a:xfrm>
           <a:prstGeom prst="line">
             <a:avLst/>
@@ -8683,7 +8785,7 @@
       </p:sp>
       <p:sp>
         <p:nvSpPr>
-          <p:cNvPr id="66" name="Text 64"/>
+          <p:cNvPr id="69" name="Text 67"/>
           <p:cNvSpPr/>
           <p:nvPr/>
         </p:nvSpPr>
@@ -8719,14 +8821,14 @@
       </p:sp>
       <p:sp>
         <p:nvSpPr>
-          <p:cNvPr id="67" name="Shape 65"/>
+          <p:cNvPr id="70" name="Shape 68"/>
           <p:cNvSpPr/>
           <p:nvPr/>
         </p:nvSpPr>
         <p:spPr>
           <a:xfrm>
             <a:off x="8010144" y="4192524"/>
-            <a:ext cx="-740664" cy="352044"/>
+            <a:ext cx="9144" cy="352044"/>
           </a:xfrm>
           <a:prstGeom prst="line">
             <a:avLst/>
@@ -8742,14 +8844,14 @@
       </p:sp>
       <p:sp>
         <p:nvSpPr>
-          <p:cNvPr id="68" name="Shape 66"/>
-          <p:cNvSpPr/>
-          <p:nvPr/>
-        </p:nvSpPr>
-        <p:spPr>
-          <a:xfrm>
-            <a:off x="7269480" y="4544568"/>
-            <a:ext cx="-740664" cy="-352044"/>
+          <p:cNvPr id="71" name="Shape 69"/>
+          <p:cNvSpPr/>
+          <p:nvPr/>
+        </p:nvSpPr>
+        <p:spPr>
+          <a:xfrm>
+            <a:off x="6528816" y="4544568"/>
+            <a:ext cx="1481328" cy="9144"/>
           </a:xfrm>
           <a:prstGeom prst="line">
             <a:avLst/>
@@ -8760,13 +8862,36 @@
               <a:srgbClr val="1A1A1A"/>
             </a:solidFill>
             <a:prstDash val="solid"/>
-            <a:tailEnd type="arrow"/>
           </a:ln>
         </p:spPr>
       </p:sp>
       <p:sp>
         <p:nvSpPr>
-          <p:cNvPr id="69" name="Text 67"/>
+          <p:cNvPr id="72" name="Shape 70"/>
+          <p:cNvSpPr/>
+          <p:nvPr/>
+        </p:nvSpPr>
+        <p:spPr>
+          <a:xfrm>
+            <a:off x="6528816" y="4192524"/>
+            <a:ext cx="9144" cy="352044"/>
+          </a:xfrm>
+          <a:prstGeom prst="line">
+            <a:avLst/>
+          </a:prstGeom>
+          <a:noFill/>
+          <a:ln w="12700">
+            <a:solidFill>
+              <a:srgbClr val="1A1A1A"/>
+            </a:solidFill>
+            <a:prstDash val="solid"/>
+            <a:headEnd type="arrow"/>
+          </a:ln>
+        </p:spPr>
+      </p:sp>
+      <p:sp>
+        <p:nvSpPr>
+          <p:cNvPr id="73" name="Text 71"/>
           <p:cNvSpPr/>
           <p:nvPr/>
         </p:nvSpPr>
@@ -8802,7 +8927,7 @@
       </p:sp>
       <p:sp>
         <p:nvSpPr>
-          <p:cNvPr id="70" name="Text 68"/>
+          <p:cNvPr id="74" name="Text 72"/>
           <p:cNvSpPr/>
           <p:nvPr/>
         </p:nvSpPr>
@@ -8838,7 +8963,7 @@
       </p:sp>
       <p:sp>
         <p:nvSpPr>
-          <p:cNvPr id="71" name="Text 69"/>
+          <p:cNvPr id="75" name="Text 73"/>
           <p:cNvSpPr/>
           <p:nvPr/>
         </p:nvSpPr>
@@ -8977,7 +9102,29 @@
                   <a:srgbClr val="FFFFFF"/>
                 </a:solidFill>
               </a:rPr>
-              <a:t>Converting M to DFA A_M (Section VI)</a:t>
+              <a:t>Converting M to DFA A</a:t>
+            </a:r>
+            <a:pPr indent="0" marL="0">
+              <a:buNone/>
+            </a:pPr>
+            <a:r>
+              <a:rPr lang="en-US" sz="1400" b="1" dirty="0">
+                <a:solidFill>
+                  <a:srgbClr val="FFFFFF"/>
+                </a:solidFill>
+              </a:rPr>
+              <a:t>M</a:t>
+            </a:r>
+            <a:pPr indent="0" marL="0">
+              <a:buNone/>
+            </a:pPr>
+            <a:r>
+              <a:rPr lang="en-US" sz="2100" b="1" dirty="0">
+                <a:solidFill>
+                  <a:srgbClr val="FFFFFF"/>
+                </a:solidFill>
+              </a:rPr>
+              <a:t> (Section VI)</a:t>
             </a:r>
             <a:endParaRPr lang="en-US" sz="2100" dirty="0"/>
           </a:p>
@@ -9013,7 +9160,29 @@
                   <a:srgbClr val="1A1A1A"/>
                 </a:solidFill>
               </a:rPr>
-              <a:t>A_M accepts all I/O traces M can produce. Both operands require the same alphabet Σ = I ∪ O for intersection.</a:t>
+              <a:t>A</a:t>
+            </a:r>
+            <a:pPr indent="0" marL="0">
+              <a:buNone/>
+            </a:pPr>
+            <a:r>
+              <a:rPr lang="en-US" sz="800" dirty="0">
+                <a:solidFill>
+                  <a:srgbClr val="1A1A1A"/>
+                </a:solidFill>
+              </a:rPr>
+              <a:t>M</a:t>
+            </a:r>
+            <a:pPr indent="0" marL="0">
+              <a:buNone/>
+            </a:pPr>
+            <a:r>
+              <a:rPr lang="en-US" sz="1100" dirty="0">
+                <a:solidFill>
+                  <a:srgbClr val="1A1A1A"/>
+                </a:solidFill>
+              </a:rPr>
+              <a:t> accepts all I/O traces M can produce. Both operands require the same alphabet Σ = I ∪ O for intersection.</a:t>
             </a:r>
             <a:endParaRPr lang="en-US" sz="1100" dirty="0"/>
           </a:p>
@@ -9085,7 +9254,18 @@
                   <a:srgbClr val="111111"/>
                 </a:solidFill>
               </a:rPr>
-              <a:t>DFA  A_M</a:t>
+              <a:t>DFA  A</a:t>
+            </a:r>
+            <a:pPr algn="ctr" indent="0" marL="0">
+              <a:buNone/>
+            </a:pPr>
+            <a:r>
+              <a:rPr lang="en-US" sz="900" b="1" dirty="0">
+                <a:solidFill>
+                  <a:srgbClr val="111111"/>
+                </a:solidFill>
+              </a:rPr>
+              <a:t>M</a:t>
             </a:r>
             <a:endParaRPr lang="en-US" sz="1150" dirty="0"/>
           </a:p>
@@ -10033,7 +10213,29 @@
                   <a:srgbClr val="888888"/>
                 </a:solidFill>
               </a:rPr>
-              <a:t>Replication: |A_M| = 71–87 states for our mock DTLS models</a:t>
+              <a:t>Replication: |A</a:t>
+            </a:r>
+            <a:pPr indent="0" marL="0">
+              <a:buNone/>
+            </a:pPr>
+            <a:r>
+              <a:rPr lang="en-US" sz="700" i="1" dirty="0">
+                <a:solidFill>
+                  <a:srgbClr val="888888"/>
+                </a:solidFill>
+              </a:rPr>
+              <a:t>M</a:t>
+            </a:r>
+            <a:pPr indent="0" marL="0">
+              <a:buNone/>
+            </a:pPr>
+            <a:r>
+              <a:rPr lang="en-US" sz="950" i="1" dirty="0">
+                <a:solidFill>
+                  <a:srgbClr val="888888"/>
+                </a:solidFill>
+              </a:rPr>
+              <a:t>| = 71–87 states for our mock DTLS models</a:t>
             </a:r>
             <a:endParaRPr lang="en-US" sz="950" dirty="0"/>
           </a:p>
@@ -10180,7 +10382,51 @@
                   <a:srgbClr val="FFFFFF"/>
                 </a:solidFill>
               </a:rPr>
-              <a:t>DFA Intersection: A∩ = A_M ∩ A_bug (Section IV)</a:t>
+              <a:t>DFA Intersection: A∩ = A</a:t>
+            </a:r>
+            <a:pPr indent="0" marL="0">
+              <a:buNone/>
+            </a:pPr>
+            <a:r>
+              <a:rPr lang="en-US" sz="1400" b="1" dirty="0">
+                <a:solidFill>
+                  <a:srgbClr val="FFFFFF"/>
+                </a:solidFill>
+              </a:rPr>
+              <a:t>M</a:t>
+            </a:r>
+            <a:pPr indent="0" marL="0">
+              <a:buNone/>
+            </a:pPr>
+            <a:r>
+              <a:rPr lang="en-US" sz="2100" b="1" dirty="0">
+                <a:solidFill>
+                  <a:srgbClr val="FFFFFF"/>
+                </a:solidFill>
+              </a:rPr>
+              <a:t> ∩ A</a:t>
+            </a:r>
+            <a:pPr indent="0" marL="0">
+              <a:buNone/>
+            </a:pPr>
+            <a:r>
+              <a:rPr lang="en-US" sz="1400" b="1" dirty="0">
+                <a:solidFill>
+                  <a:srgbClr val="FFFFFF"/>
+                </a:solidFill>
+              </a:rPr>
+              <a:t>bug</a:t>
+            </a:r>
+            <a:pPr indent="0" marL="0">
+              <a:buNone/>
+            </a:pPr>
+            <a:r>
+              <a:rPr lang="en-US" sz="2100" b="1" dirty="0">
+                <a:solidFill>
+                  <a:srgbClr val="FFFFFF"/>
+                </a:solidFill>
+              </a:rPr>
+              <a:t> (Section IV)</a:t>
             </a:r>
             <a:endParaRPr lang="en-US" sz="2100" dirty="0"/>
           </a:p>
@@ -10216,7 +10462,29 @@
                   <a:srgbClr val="1A1A1A"/>
                 </a:solidFill>
               </a:rPr>
-              <a:t>A sequence is a bug witness iff it is both producible by M and accepted by A_bug.</a:t>
+              <a:t>A sequence is a bug witness iff it is both producible by M and accepted by A</a:t>
+            </a:r>
+            <a:pPr indent="0" marL="0">
+              <a:buNone/>
+            </a:pPr>
+            <a:r>
+              <a:rPr lang="en-US" sz="900" dirty="0">
+                <a:solidFill>
+                  <a:srgbClr val="1A1A1A"/>
+                </a:solidFill>
+              </a:rPr>
+              <a:t>bug</a:t>
+            </a:r>
+            <a:pPr indent="0" marL="0">
+              <a:buNone/>
+            </a:pPr>
+            <a:r>
+              <a:rPr lang="en-US" sz="1200" dirty="0">
+                <a:solidFill>
+                  <a:srgbClr val="1A1A1A"/>
+                </a:solidFill>
+              </a:rPr>
+              <a:t>.</a:t>
             </a:r>
             <a:endParaRPr lang="en-US" sz="1200" dirty="0"/>
           </a:p>

</xml_diff>